<commit_message>
Publish the real peaq-linked paid check and reviewer path
</commit_message>
<xml_diff>
--- a/competition/fieldproof-pitch.pptx
+++ b/competition/fieldproof-pitch.pptx
@@ -2,17 +2,17 @@
 <file path=ppt/presentation.xml><?xml version="1.0" encoding="utf-8"?>
 <p:presentation xmlns:p="http://schemas.openxmlformats.org/presentationml/2006/main">
   <p:sldMasterIdLst>
-    <p:sldMasterId xmlns:r="http://schemas.openxmlformats.org/officeDocument/2006/relationships" id="2147483648" r:id="R23ea92e1e26b4a6a"/>
+    <p:sldMasterId xmlns:r="http://schemas.openxmlformats.org/officeDocument/2006/relationships" id="2147483648" r:id="R5e3e9016d05141af"/>
   </p:sldMasterIdLst>
   <p:notesMasterIdLst>
-    <p:notesMasterId xmlns:r="http://schemas.openxmlformats.org/officeDocument/2006/relationships" r:id="R284703bbfa424e91"/>
+    <p:notesMasterId xmlns:r="http://schemas.openxmlformats.org/officeDocument/2006/relationships" r:id="R1ffac5f41aec41bd"/>
   </p:notesMasterIdLst>
   <p:sldIdLst>
-    <p:sldId xmlns:r="http://schemas.openxmlformats.org/officeDocument/2006/relationships" id="256" r:id="R8735ce0ff52a44bc"/>
-    <p:sldId xmlns:r="http://schemas.openxmlformats.org/officeDocument/2006/relationships" id="257" r:id="R442506087e1846b7"/>
-    <p:sldId xmlns:r="http://schemas.openxmlformats.org/officeDocument/2006/relationships" id="258" r:id="R50b15bbfa774469b"/>
-    <p:sldId xmlns:r="http://schemas.openxmlformats.org/officeDocument/2006/relationships" id="259" r:id="Rb9f1aefe962a4d45"/>
-    <p:sldId xmlns:r="http://schemas.openxmlformats.org/officeDocument/2006/relationships" id="260" r:id="Rec604e4503874f26"/>
+    <p:sldId xmlns:r="http://schemas.openxmlformats.org/officeDocument/2006/relationships" id="256" r:id="Rddd7d392dd94452c"/>
+    <p:sldId xmlns:r="http://schemas.openxmlformats.org/officeDocument/2006/relationships" id="257" r:id="R1fca12981e9e4765"/>
+    <p:sldId xmlns:r="http://schemas.openxmlformats.org/officeDocument/2006/relationships" id="258" r:id="R7b8168d628d749e8"/>
+    <p:sldId xmlns:r="http://schemas.openxmlformats.org/officeDocument/2006/relationships" id="259" r:id="R55c44a381eb24a77"/>
+    <p:sldId xmlns:r="http://schemas.openxmlformats.org/officeDocument/2006/relationships" id="260" r:id="Ra2e1ae4c9f6046ec"/>
   </p:sldIdLst>
   <p:sldSz cx="12192000" cy="6858000"/>
   <p:notesSz cx="6858000" cy="9144000"/>
@@ -446,7 +446,7 @@
           <a:lstStyle xmlns:a="http://schemas.openxmlformats.org/drawingml/2006/main"/>
           <a:p xmlns:a="http://schemas.openxmlformats.org/drawingml/2006/main">
             <a:r>
-              <a:t>Content source: docs/competition/slides.html. Implementation and evidence: docs/VERIFICATION.md and docs/evidence/device-signed-purchase-20261011.json. Buyer value and commercial pricing are hypotheses. The Solana transaction uses test tokens. Live peaq activation and event readback remain pending. Slide 1 of 5.</a:t>
+              <a:t>Content source: docs/competition/slides.html. Implementation and evidence: docs/VERIFICATION.md and docs/evidence/device-signed-purchase-20261011.json. Buyer value and commercial pricing are hypotheses. The Solana transaction uses test tokens. Real Agung identity and native Storage work readbacks passed on October 12. No EventRegistry event or credit rating is claimed. Slide 1 of 5.</a:t>
             </a:r>
           </a:p>
         </p:txBody>
@@ -516,7 +516,7 @@
           <a:lstStyle xmlns:a="http://schemas.openxmlformats.org/drawingml/2006/main"/>
           <a:p xmlns:a="http://schemas.openxmlformats.org/drawingml/2006/main">
             <a:r>
-              <a:t>Content source: docs/competition/slides.html. Implementation and evidence: docs/VERIFICATION.md and docs/evidence/device-signed-purchase-20261011.json. Buyer value and commercial pricing are hypotheses. The Solana transaction uses test tokens. Live peaq activation and event readback remain pending. Slide 2 of 5.</a:t>
+              <a:t>Content source: docs/competition/slides.html. Implementation and evidence: docs/VERIFICATION.md and docs/evidence/device-signed-purchase-20261011.json. Buyer value and commercial pricing are hypotheses. The Solana transaction uses test tokens. Real Agung identity and native Storage work readbacks passed on October 12. No EventRegistry event or credit rating is claimed. Slide 2 of 5.</a:t>
             </a:r>
           </a:p>
         </p:txBody>
@@ -586,7 +586,7 @@
           <a:lstStyle xmlns:a="http://schemas.openxmlformats.org/drawingml/2006/main"/>
           <a:p xmlns:a="http://schemas.openxmlformats.org/drawingml/2006/main">
             <a:r>
-              <a:t>Content source: docs/competition/slides.html. Implementation and evidence: docs/VERIFICATION.md and docs/evidence/device-signed-purchase-20261011.json. Buyer value and commercial pricing are hypotheses. The Solana transaction uses test tokens. Live peaq activation and event readback remain pending. Slide 3 of 5.</a:t>
+              <a:t>Content source: docs/competition/slides.html. Implementation and evidence: docs/VERIFICATION.md and docs/evidence/device-signed-purchase-20261011.json. Buyer value and commercial pricing are hypotheses. The Solana transaction uses test tokens. Real Agung identity and native Storage work readbacks passed on October 12. No EventRegistry event or credit rating is claimed. Slide 3 of 5.</a:t>
             </a:r>
           </a:p>
         </p:txBody>
@@ -656,7 +656,7 @@
           <a:lstStyle xmlns:a="http://schemas.openxmlformats.org/drawingml/2006/main"/>
           <a:p xmlns:a="http://schemas.openxmlformats.org/drawingml/2006/main">
             <a:r>
-              <a:t>Content source: docs/competition/slides.html. Implementation and evidence: docs/VERIFICATION.md and docs/evidence/device-signed-purchase-20261011.json. Buyer value and commercial pricing are hypotheses. The Solana transaction uses test tokens. Live peaq activation and event readback remain pending. Slide 4 of 5.</a:t>
+              <a:t>Content source: docs/competition/slides.html. Implementation and evidence: docs/VERIFICATION.md and docs/evidence/device-signed-purchase-20261011.json. Buyer value and commercial pricing are hypotheses. The Solana transaction uses test tokens. Real Agung identity and native Storage work readbacks passed on October 12. No EventRegistry event or credit rating is claimed. Slide 4 of 5.</a:t>
             </a:r>
           </a:p>
         </p:txBody>
@@ -726,7 +726,7 @@
           <a:lstStyle xmlns:a="http://schemas.openxmlformats.org/drawingml/2006/main"/>
           <a:p xmlns:a="http://schemas.openxmlformats.org/drawingml/2006/main">
             <a:r>
-              <a:t>Content source: docs/competition/slides.html. Implementation and evidence: docs/VERIFICATION.md and docs/evidence/device-signed-purchase-20261011.json. Buyer value and commercial pricing are hypotheses. The Solana transaction uses test tokens. Live peaq activation and event readback remain pending. Slide 5 of 5.</a:t>
+              <a:t>Content source: docs/competition/slides.html. Implementation and evidence: docs/VERIFICATION.md and docs/evidence/device-signed-purchase-20261011.json. Buyer value and commercial pricing are hypotheses. The Solana transaction uses test tokens. Real Agung identity and native Storage work readbacks passed on October 12. No EventRegistry event or credit rating is claimed. Slide 5 of 5.</a:t>
             </a:r>
           </a:p>
         </p:txBody>
@@ -794,7 +794,7 @@
   </p:cSld>
   <p:clrMap bg1="lt1" tx1="dk1" bg2="lt2" tx2="dk2" accent1="accent1" accent2="accent2" accent3="accent3" accent4="accent4" accent5="accent5" accent6="accent6" hlink="hlink" folHlink="folHlink"/>
   <p:sldLayoutIdLst>
-    <p:sldLayoutId xmlns:r="http://schemas.openxmlformats.org/officeDocument/2006/relationships" id="2147483649" r:id="Rd55828bcdb86441f"/>
+    <p:sldLayoutId xmlns:r="http://schemas.openxmlformats.org/officeDocument/2006/relationships" id="2147483649" r:id="R043c941cac0c4f89"/>
   </p:sldLayoutIdLst>
   <p:txStyles>
     <p:titleStyle>
@@ -1345,7 +1345,7 @@
           <p:cNvPr id="7" name="">
             <a:extLst xmlns:a="http://schemas.openxmlformats.org/drawingml/2006/main">
               <a:ext uri="{FF2B5EF4-FFF2-40B4-BE49-F238E27FC236}">
-                <a16:creationId xmlns:a16="http://schemas.microsoft.com/office/drawing/2014/main" id="{A02F20DD-196D-424C-8C39-6E842DBD9C4E}"/>
+                <a16:creationId xmlns:a16="http://schemas.microsoft.com/office/drawing/2014/main" id="{DEA8DFB1-E5CA-4677-8019-928C3D8049FE}"/>
               </a:ext>
             </a:extLst>
           </p:cNvPr>
@@ -1406,7 +1406,7 @@
           <p:cNvPr id="2" name="">
             <a:extLst xmlns:a="http://schemas.openxmlformats.org/drawingml/2006/main">
               <a:ext uri="{FF2B5EF4-FFF2-40B4-BE49-F238E27FC236}">
-                <a16:creationId xmlns:a16="http://schemas.microsoft.com/office/drawing/2014/main" id="{F8539FF9-2018-465B-BDA7-FE91098A77BF}"/>
+                <a16:creationId xmlns:a16="http://schemas.microsoft.com/office/drawing/2014/main" id="{9F6C66BA-CEC1-4E06-A466-190FF9C95A15}"/>
               </a:ext>
             </a:extLst>
           </p:cNvPr>
@@ -1467,7 +1467,7 @@
           <p:cNvPr id="3" name="">
             <a:extLst xmlns:a="http://schemas.openxmlformats.org/drawingml/2006/main">
               <a:ext uri="{FF2B5EF4-FFF2-40B4-BE49-F238E27FC236}">
-                <a16:creationId xmlns:a16="http://schemas.microsoft.com/office/drawing/2014/main" id="{8B3635BA-7F43-42FF-805A-A46C8E57D1C8}"/>
+                <a16:creationId xmlns:a16="http://schemas.microsoft.com/office/drawing/2014/main" id="{87EE48BF-3467-4654-AF69-8F6ECAE1E0FB}"/>
               </a:ext>
             </a:extLst>
           </p:cNvPr>
@@ -1528,7 +1528,7 @@
           <p:cNvPr id="4" name="">
             <a:extLst xmlns:a="http://schemas.openxmlformats.org/drawingml/2006/main">
               <a:ext uri="{FF2B5EF4-FFF2-40B4-BE49-F238E27FC236}">
-                <a16:creationId xmlns:a16="http://schemas.microsoft.com/office/drawing/2014/main" id="{DD563C8C-DA1A-4AE3-AB8F-500BBA148273}"/>
+                <a16:creationId xmlns:a16="http://schemas.microsoft.com/office/drawing/2014/main" id="{A514202E-96DB-4A1D-8BB1-1487138184E8}"/>
               </a:ext>
             </a:extLst>
           </p:cNvPr>
@@ -1593,7 +1593,7 @@
           <p:nvPr/>
         </p:nvPicPr>
         <p:blipFill>
-          <a:blip xmlns:r="http://schemas.openxmlformats.org/officeDocument/2006/relationships" xmlns:a="http://schemas.openxmlformats.org/drawingml/2006/main" r:embed="R60a19325875149d5"/>
+          <a:blip xmlns:r="http://schemas.openxmlformats.org/officeDocument/2006/relationships" xmlns:a="http://schemas.openxmlformats.org/drawingml/2006/main" r:embed="Rce9f1a99adde4235"/>
           <a:stretch xmlns:a="http://schemas.openxmlformats.org/drawingml/2006/main"/>
         </p:blipFill>
         <p:spPr>
@@ -1611,7 +1611,7 @@
           <p:cNvPr id="6" name="">
             <a:extLst xmlns:a="http://schemas.openxmlformats.org/drawingml/2006/main">
               <a:ext uri="{FF2B5EF4-FFF2-40B4-BE49-F238E27FC236}">
-                <a16:creationId xmlns:a16="http://schemas.microsoft.com/office/drawing/2014/main" id="{C44AF1B0-FBE7-4FDA-A9C6-A3571D945C4A}"/>
+                <a16:creationId xmlns:a16="http://schemas.microsoft.com/office/drawing/2014/main" id="{CC164124-A2BF-46C2-B731-ACE2E8C84775}"/>
               </a:ext>
             </a:extLst>
           </p:cNvPr>
@@ -1662,7 +1662,7 @@
                 <a:ea typeface="Liberation Sans"/>
                 <a:cs typeface="Liberation Sans"/>
               </a:rPr>
-              <a:t>01 / A device signature authenticates a claim. It does not establish physical truth.</a:t>
+              <a:t>01 / A signature identifies the claim’s source. Physical truth needs separate controls.</a:t>
             </a:r>
           </a:p>
         </p:txBody>
@@ -1670,7 +1670,7 @@
     </p:spTree>
     <p:extLst>
       <p:ext uri="{BB962C8B-B14F-4D97-AF65-F5344CB8AC3E}">
-        <p14:creationId xmlns:p14="http://schemas.microsoft.com/office/powerpoint/2010/main" val="96589454"/>
+        <p14:creationId xmlns:p14="http://schemas.microsoft.com/office/powerpoint/2010/main" val="1400951751"/>
       </p:ext>
     </p:extLst>
   </p:cSld>
@@ -1701,7 +1701,7 @@
           <p:cNvPr id="10" name="">
             <a:extLst xmlns:a="http://schemas.openxmlformats.org/drawingml/2006/main">
               <a:ext uri="{FF2B5EF4-FFF2-40B4-BE49-F238E27FC236}">
-                <a16:creationId xmlns:a16="http://schemas.microsoft.com/office/drawing/2014/main" id="{F4BBBA1B-FAA3-45C6-8D49-15E16E13DC2B}"/>
+                <a16:creationId xmlns:a16="http://schemas.microsoft.com/office/drawing/2014/main" id="{9626C400-F500-4BB9-A44B-5F491EF4682A}"/>
               </a:ext>
             </a:extLst>
           </p:cNvPr>
@@ -1762,7 +1762,7 @@
           <p:cNvPr id="2" name="">
             <a:extLst xmlns:a="http://schemas.openxmlformats.org/drawingml/2006/main">
               <a:ext uri="{FF2B5EF4-FFF2-40B4-BE49-F238E27FC236}">
-                <a16:creationId xmlns:a16="http://schemas.microsoft.com/office/drawing/2014/main" id="{28CFCB66-6A7F-41CD-9A7C-243D85C06425}"/>
+                <a16:creationId xmlns:a16="http://schemas.microsoft.com/office/drawing/2014/main" id="{347A121C-8D91-46A8-A663-BAA8EB4366AD}"/>
               </a:ext>
             </a:extLst>
           </p:cNvPr>
@@ -1823,7 +1823,7 @@
           <p:cNvPr id="3" name="">
             <a:extLst xmlns:a="http://schemas.openxmlformats.org/drawingml/2006/main">
               <a:ext uri="{FF2B5EF4-FFF2-40B4-BE49-F238E27FC236}">
-                <a16:creationId xmlns:a16="http://schemas.microsoft.com/office/drawing/2014/main" id="{7DE2F1E5-6548-4F06-8BC6-C295DFD127CA}"/>
+                <a16:creationId xmlns:a16="http://schemas.microsoft.com/office/drawing/2014/main" id="{D6B07CFF-45EE-4C80-9A47-A90618F96DBA}"/>
               </a:ext>
             </a:extLst>
           </p:cNvPr>
@@ -1884,7 +1884,7 @@
           <p:cNvPr id="4" name="">
             <a:extLst xmlns:a="http://schemas.openxmlformats.org/drawingml/2006/main">
               <a:ext uri="{FF2B5EF4-FFF2-40B4-BE49-F238E27FC236}">
-                <a16:creationId xmlns:a16="http://schemas.microsoft.com/office/drawing/2014/main" id="{62A8D1CD-E793-481F-A881-081E5EAE8823}"/>
+                <a16:creationId xmlns:a16="http://schemas.microsoft.com/office/drawing/2014/main" id="{A4B86E51-DE71-4915-AF2D-4D20ADCAC2A1}"/>
               </a:ext>
             </a:extLst>
           </p:cNvPr>
@@ -1945,7 +1945,7 @@
           <p:cNvPr id="5" name="">
             <a:extLst xmlns:a="http://schemas.openxmlformats.org/drawingml/2006/main">
               <a:ext uri="{FF2B5EF4-FFF2-40B4-BE49-F238E27FC236}">
-                <a16:creationId xmlns:a16="http://schemas.microsoft.com/office/drawing/2014/main" id="{E0834333-BB5F-482B-8284-3329BE3FBD13}"/>
+                <a16:creationId xmlns:a16="http://schemas.microsoft.com/office/drawing/2014/main" id="{C370338D-7AB0-42FE-B2DA-C4E22EA8733F}"/>
               </a:ext>
             </a:extLst>
           </p:cNvPr>
@@ -2006,7 +2006,7 @@
           <p:cNvPr id="6" name="">
             <a:extLst xmlns:a="http://schemas.openxmlformats.org/drawingml/2006/main">
               <a:ext uri="{FF2B5EF4-FFF2-40B4-BE49-F238E27FC236}">
-                <a16:creationId xmlns:a16="http://schemas.microsoft.com/office/drawing/2014/main" id="{9E2F1DFC-9F9C-42CF-B76F-C562E52F80F6}"/>
+                <a16:creationId xmlns:a16="http://schemas.microsoft.com/office/drawing/2014/main" id="{B48DD837-1430-4117-BDA6-4520BAADA121}"/>
               </a:ext>
             </a:extLst>
           </p:cNvPr>
@@ -2067,7 +2067,7 @@
           <p:cNvPr id="7" name="">
             <a:extLst xmlns:a="http://schemas.openxmlformats.org/drawingml/2006/main">
               <a:ext uri="{FF2B5EF4-FFF2-40B4-BE49-F238E27FC236}">
-                <a16:creationId xmlns:a16="http://schemas.microsoft.com/office/drawing/2014/main" id="{7BE6FCB7-35C5-4563-B3F3-287BEE46C1FF}"/>
+                <a16:creationId xmlns:a16="http://schemas.microsoft.com/office/drawing/2014/main" id="{45C897BC-075E-422C-95AD-B6B08EE52B0E}"/>
               </a:ext>
             </a:extLst>
           </p:cNvPr>
@@ -2128,7 +2128,7 @@
           <p:cNvPr id="8" name="">
             <a:extLst xmlns:a="http://schemas.openxmlformats.org/drawingml/2006/main">
               <a:ext uri="{FF2B5EF4-FFF2-40B4-BE49-F238E27FC236}">
-                <a16:creationId xmlns:a16="http://schemas.microsoft.com/office/drawing/2014/main" id="{F77B72B4-2475-456F-9386-7C50C067533B}"/>
+                <a16:creationId xmlns:a16="http://schemas.microsoft.com/office/drawing/2014/main" id="{4DE72AA6-164A-4BBD-90F4-0CC3FE4DD242}"/>
               </a:ext>
             </a:extLst>
           </p:cNvPr>
@@ -2189,7 +2189,7 @@
           <p:cNvPr id="9" name="">
             <a:extLst xmlns:a="http://schemas.openxmlformats.org/drawingml/2006/main">
               <a:ext uri="{FF2B5EF4-FFF2-40B4-BE49-F238E27FC236}">
-                <a16:creationId xmlns:a16="http://schemas.microsoft.com/office/drawing/2014/main" id="{83F24F17-DEB1-4A9D-8F50-61AC77AE8886}"/>
+                <a16:creationId xmlns:a16="http://schemas.microsoft.com/office/drawing/2014/main" id="{86B2106D-EA2A-4163-AB58-A28AD8458EE3}"/>
               </a:ext>
             </a:extLst>
           </p:cNvPr>
@@ -2240,7 +2240,7 @@
                 <a:ea typeface="Liberation Sans"/>
                 <a:cs typeface="Liberation Sans"/>
               </a:rPr>
-              <a:t>02 / Buyer hypothesis. No customer or willingness to pay is validated. Use an existing API when it supplies the answer.</a:t>
+              <a:t>02 / Buyer and pricing remain hypotheses. An existing reliable API can be sufficient.</a:t>
             </a:r>
           </a:p>
         </p:txBody>
@@ -2248,7 +2248,7 @@
     </p:spTree>
     <p:extLst>
       <p:ext uri="{BB962C8B-B14F-4D97-AF65-F5344CB8AC3E}">
-        <p14:creationId xmlns:p14="http://schemas.microsoft.com/office/powerpoint/2010/main" val="53345973"/>
+        <p14:creationId xmlns:p14="http://schemas.microsoft.com/office/powerpoint/2010/main" val="1041157775"/>
       </p:ext>
     </p:extLst>
   </p:cSld>
@@ -2279,7 +2279,7 @@
           <p:cNvPr id="11" name="">
             <a:extLst xmlns:a="http://schemas.openxmlformats.org/drawingml/2006/main">
               <a:ext uri="{FF2B5EF4-FFF2-40B4-BE49-F238E27FC236}">
-                <a16:creationId xmlns:a16="http://schemas.microsoft.com/office/drawing/2014/main" id="{06C900AF-428E-4ACE-89D3-DBE9CEDD8674}"/>
+                <a16:creationId xmlns:a16="http://schemas.microsoft.com/office/drawing/2014/main" id="{655C990A-8EF5-4541-8653-2CB0B5F7A70C}"/>
               </a:ext>
             </a:extLst>
           </p:cNvPr>
@@ -2340,7 +2340,7 @@
           <p:cNvPr id="2" name="">
             <a:extLst xmlns:a="http://schemas.openxmlformats.org/drawingml/2006/main">
               <a:ext uri="{FF2B5EF4-FFF2-40B4-BE49-F238E27FC236}">
-                <a16:creationId xmlns:a16="http://schemas.microsoft.com/office/drawing/2014/main" id="{260C98F7-8B0C-42A1-8ECA-12A1946BB3B4}"/>
+                <a16:creationId xmlns:a16="http://schemas.microsoft.com/office/drawing/2014/main" id="{C939EADB-D828-4CB1-815E-B164D3570066}"/>
               </a:ext>
             </a:extLst>
           </p:cNvPr>
@@ -2401,7 +2401,7 @@
           <p:cNvPr id="3" name="">
             <a:extLst xmlns:a="http://schemas.openxmlformats.org/drawingml/2006/main">
               <a:ext uri="{FF2B5EF4-FFF2-40B4-BE49-F238E27FC236}">
-                <a16:creationId xmlns:a16="http://schemas.microsoft.com/office/drawing/2014/main" id="{CAD29CF3-2CE0-42C2-B050-C6AFDA61CE16}"/>
+                <a16:creationId xmlns:a16="http://schemas.microsoft.com/office/drawing/2014/main" id="{D72B06EA-86A2-4759-B497-D83D8F4BC767}"/>
               </a:ext>
             </a:extLst>
           </p:cNvPr>
@@ -2462,7 +2462,7 @@
           <p:cNvPr id="4" name="">
             <a:extLst xmlns:a="http://schemas.openxmlformats.org/drawingml/2006/main">
               <a:ext uri="{FF2B5EF4-FFF2-40B4-BE49-F238E27FC236}">
-                <a16:creationId xmlns:a16="http://schemas.microsoft.com/office/drawing/2014/main" id="{DF0EC04A-FC93-46DD-BBC8-05E2B1D8E3D8}"/>
+                <a16:creationId xmlns:a16="http://schemas.microsoft.com/office/drawing/2014/main" id="{06E96C98-6CE3-4B49-A17F-92177986D982}"/>
               </a:ext>
             </a:extLst>
           </p:cNvPr>
@@ -2523,7 +2523,7 @@
           <p:cNvPr id="5" name="">
             <a:extLst xmlns:a="http://schemas.openxmlformats.org/drawingml/2006/main">
               <a:ext uri="{FF2B5EF4-FFF2-40B4-BE49-F238E27FC236}">
-                <a16:creationId xmlns:a16="http://schemas.microsoft.com/office/drawing/2014/main" id="{41C0DCA4-3642-4855-B7DC-9BCB70D235DB}"/>
+                <a16:creationId xmlns:a16="http://schemas.microsoft.com/office/drawing/2014/main" id="{6E227CF9-EA9A-433D-8468-51B1709D845E}"/>
               </a:ext>
             </a:extLst>
           </p:cNvPr>
@@ -2584,7 +2584,7 @@
           <p:cNvPr id="6" name="">
             <a:extLst xmlns:a="http://schemas.openxmlformats.org/drawingml/2006/main">
               <a:ext uri="{FF2B5EF4-FFF2-40B4-BE49-F238E27FC236}">
-                <a16:creationId xmlns:a16="http://schemas.microsoft.com/office/drawing/2014/main" id="{290DDFC4-B564-4CAE-BF06-872E6601598F}"/>
+                <a16:creationId xmlns:a16="http://schemas.microsoft.com/office/drawing/2014/main" id="{14545F58-6ABB-4C80-873C-E773E95D3280}"/>
               </a:ext>
             </a:extLst>
           </p:cNvPr>
@@ -2645,7 +2645,7 @@
           <p:cNvPr id="7" name="">
             <a:extLst xmlns:a="http://schemas.openxmlformats.org/drawingml/2006/main">
               <a:ext uri="{FF2B5EF4-FFF2-40B4-BE49-F238E27FC236}">
-                <a16:creationId xmlns:a16="http://schemas.microsoft.com/office/drawing/2014/main" id="{53109F1B-54B3-4D2D-9EB9-C48B5532B918}"/>
+                <a16:creationId xmlns:a16="http://schemas.microsoft.com/office/drawing/2014/main" id="{A79CD3BF-D331-4A21-957B-E6E3DDE77962}"/>
               </a:ext>
             </a:extLst>
           </p:cNvPr>
@@ -2706,7 +2706,7 @@
           <p:cNvPr id="8" name="">
             <a:extLst xmlns:a="http://schemas.openxmlformats.org/drawingml/2006/main">
               <a:ext uri="{FF2B5EF4-FFF2-40B4-BE49-F238E27FC236}">
-                <a16:creationId xmlns:a16="http://schemas.microsoft.com/office/drawing/2014/main" id="{1B98F7FE-2105-4D6E-9CF5-22D676EBE4CC}"/>
+                <a16:creationId xmlns:a16="http://schemas.microsoft.com/office/drawing/2014/main" id="{B65840EE-00C9-4E8B-8C13-4901DC69D951}"/>
               </a:ext>
             </a:extLst>
           </p:cNvPr>
@@ -2767,7 +2767,7 @@
           <p:cNvPr id="9" name="">
             <a:extLst xmlns:a="http://schemas.openxmlformats.org/drawingml/2006/main">
               <a:ext uri="{FF2B5EF4-FFF2-40B4-BE49-F238E27FC236}">
-                <a16:creationId xmlns:a16="http://schemas.microsoft.com/office/drawing/2014/main" id="{826755B0-BC71-4DAF-B01C-EFAAF9ED5003}"/>
+                <a16:creationId xmlns:a16="http://schemas.microsoft.com/office/drawing/2014/main" id="{7794797A-FA9D-41A0-A69F-170A74855D43}"/>
               </a:ext>
             </a:extLst>
           </p:cNvPr>
@@ -2828,7 +2828,7 @@
           <p:cNvPr id="10" name="">
             <a:extLst xmlns:a="http://schemas.openxmlformats.org/drawingml/2006/main">
               <a:ext uri="{FF2B5EF4-FFF2-40B4-BE49-F238E27FC236}">
-                <a16:creationId xmlns:a16="http://schemas.microsoft.com/office/drawing/2014/main" id="{7E44799A-1C24-46F1-930B-EC0C3B873D2A}"/>
+                <a16:creationId xmlns:a16="http://schemas.microsoft.com/office/drawing/2014/main" id="{25EE1B7B-F1CE-4E97-8B7C-CD6A86DCED08}"/>
               </a:ext>
             </a:extLst>
           </p:cNvPr>
@@ -2879,7 +2879,7 @@
                 <a:ea typeface="Liberation Sans"/>
                 <a:cs typeface="Liberation Sans"/>
               </a:rPr>
-              <a:t>03 / OPEN and CLOSED both fulfill the paid check. The operator wallet receives test tokens. The buyer's next action is separate.</a:t>
+              <a:t>03 / Both contact states fulfill the paid check. The operator receives test tokens.</a:t>
             </a:r>
           </a:p>
         </p:txBody>
@@ -2887,7 +2887,7 @@
     </p:spTree>
     <p:extLst>
       <p:ext uri="{BB962C8B-B14F-4D97-AF65-F5344CB8AC3E}">
-        <p14:creationId xmlns:p14="http://schemas.microsoft.com/office/powerpoint/2010/main" val="1163993222"/>
+        <p14:creationId xmlns:p14="http://schemas.microsoft.com/office/powerpoint/2010/main" val="311761918"/>
       </p:ext>
     </p:extLst>
   </p:cSld>
@@ -2918,7 +2918,7 @@
           <p:cNvPr id="9" name="">
             <a:extLst xmlns:a="http://schemas.openxmlformats.org/drawingml/2006/main">
               <a:ext uri="{FF2B5EF4-FFF2-40B4-BE49-F238E27FC236}">
-                <a16:creationId xmlns:a16="http://schemas.microsoft.com/office/drawing/2014/main" id="{F1C5EDAA-18D9-4C7D-BA15-B6BDB16D0276}"/>
+                <a16:creationId xmlns:a16="http://schemas.microsoft.com/office/drawing/2014/main" id="{5730CC44-E194-4465-9290-4ABB54D2A04B}"/>
               </a:ext>
             </a:extLst>
           </p:cNvPr>
@@ -2979,7 +2979,7 @@
           <p:cNvPr id="2" name="">
             <a:extLst xmlns:a="http://schemas.openxmlformats.org/drawingml/2006/main">
               <a:ext uri="{FF2B5EF4-FFF2-40B4-BE49-F238E27FC236}">
-                <a16:creationId xmlns:a16="http://schemas.microsoft.com/office/drawing/2014/main" id="{0C291444-DE67-43F7-97E7-2FB9A35743BC}"/>
+                <a16:creationId xmlns:a16="http://schemas.microsoft.com/office/drawing/2014/main" id="{018CC3A7-E786-4CC1-9C69-74721A8FB110}"/>
               </a:ext>
             </a:extLst>
           </p:cNvPr>
@@ -3040,7 +3040,7 @@
           <p:cNvPr id="3" name="">
             <a:extLst xmlns:a="http://schemas.openxmlformats.org/drawingml/2006/main">
               <a:ext uri="{FF2B5EF4-FFF2-40B4-BE49-F238E27FC236}">
-                <a16:creationId xmlns:a16="http://schemas.microsoft.com/office/drawing/2014/main" id="{E138EE96-27E1-4C49-8A0C-949AB1B0886B}"/>
+                <a16:creationId xmlns:a16="http://schemas.microsoft.com/office/drawing/2014/main" id="{92020722-7F56-4156-80C4-3AC36EA3A367}"/>
               </a:ext>
             </a:extLst>
           </p:cNvPr>
@@ -3101,7 +3101,7 @@
           <p:cNvPr id="4" name="">
             <a:extLst xmlns:a="http://schemas.openxmlformats.org/drawingml/2006/main">
               <a:ext uri="{FF2B5EF4-FFF2-40B4-BE49-F238E27FC236}">
-                <a16:creationId xmlns:a16="http://schemas.microsoft.com/office/drawing/2014/main" id="{6105CFB5-0634-4020-9919-C20B4BE35FB9}"/>
+                <a16:creationId xmlns:a16="http://schemas.microsoft.com/office/drawing/2014/main" id="{7FD7EF97-601E-4BC5-BFBA-C95FD0DD4F74}"/>
               </a:ext>
             </a:extLst>
           </p:cNvPr>
@@ -3162,7 +3162,7 @@
           <p:cNvPr id="5" name="">
             <a:extLst xmlns:a="http://schemas.openxmlformats.org/drawingml/2006/main">
               <a:ext uri="{FF2B5EF4-FFF2-40B4-BE49-F238E27FC236}">
-                <a16:creationId xmlns:a16="http://schemas.microsoft.com/office/drawing/2014/main" id="{8B575DDD-3E2E-4576-B350-74F22D4A6112}"/>
+                <a16:creationId xmlns:a16="http://schemas.microsoft.com/office/drawing/2014/main" id="{5ED12925-5371-4E4A-BD26-D76D70D24C86}"/>
               </a:ext>
             </a:extLst>
           </p:cNvPr>
@@ -3223,7 +3223,7 @@
           <p:cNvPr id="6" name="">
             <a:extLst xmlns:a="http://schemas.openxmlformats.org/drawingml/2006/main">
               <a:ext uri="{FF2B5EF4-FFF2-40B4-BE49-F238E27FC236}">
-                <a16:creationId xmlns:a16="http://schemas.microsoft.com/office/drawing/2014/main" id="{3B7B2462-008C-4920-B45F-A3B95BC37653}"/>
+                <a16:creationId xmlns:a16="http://schemas.microsoft.com/office/drawing/2014/main" id="{E1B3F251-2749-4411-92C3-6B7BB2A5A262}"/>
               </a:ext>
             </a:extLst>
           </p:cNvPr>
@@ -3284,7 +3284,7 @@
           <p:cNvPr id="7" name="">
             <a:extLst xmlns:a="http://schemas.openxmlformats.org/drawingml/2006/main">
               <a:ext uri="{FF2B5EF4-FFF2-40B4-BE49-F238E27FC236}">
-                <a16:creationId xmlns:a16="http://schemas.microsoft.com/office/drawing/2014/main" id="{46CAAC0C-51D5-4C37-992C-DB849611875C}"/>
+                <a16:creationId xmlns:a16="http://schemas.microsoft.com/office/drawing/2014/main" id="{83E7AB47-D984-400A-B4D2-B7CAB8DCEC84}"/>
               </a:ext>
             </a:extLst>
           </p:cNvPr>
@@ -3345,7 +3345,7 @@
           <p:cNvPr id="8" name="">
             <a:extLst xmlns:a="http://schemas.openxmlformats.org/drawingml/2006/main">
               <a:ext uri="{FF2B5EF4-FFF2-40B4-BE49-F238E27FC236}">
-                <a16:creationId xmlns:a16="http://schemas.microsoft.com/office/drawing/2014/main" id="{37AE8637-58F2-48EF-AC21-C78FFFEC24C5}"/>
+                <a16:creationId xmlns:a16="http://schemas.microsoft.com/office/drawing/2014/main" id="{E21B37B1-E47D-447A-9F42-B4DE9184A511}"/>
               </a:ext>
             </a:extLst>
           </p:cNvPr>
@@ -3396,7 +3396,7 @@
                 <a:ea typeface="Liberation Sans"/>
                 <a:cs typeface="Liberation Sans"/>
               </a:rPr>
-              <a:t>04 / BOOT is a contact stand-in. No robot or real entrance is connected. The software buyer can serve an AI agent.</a:t>
+              <a:t>04 / BOOT represents a contact. This software controls no door or robot.</a:t>
             </a:r>
           </a:p>
         </p:txBody>
@@ -3404,7 +3404,7 @@
     </p:spTree>
     <p:extLst>
       <p:ext uri="{BB962C8B-B14F-4D97-AF65-F5344CB8AC3E}">
-        <p14:creationId xmlns:p14="http://schemas.microsoft.com/office/powerpoint/2010/main" val="264510098"/>
+        <p14:creationId xmlns:p14="http://schemas.microsoft.com/office/powerpoint/2010/main" val="1579757540"/>
       </p:ext>
     </p:extLst>
   </p:cSld>
@@ -3435,7 +3435,7 @@
           <p:cNvPr id="10" name="">
             <a:extLst xmlns:a="http://schemas.openxmlformats.org/drawingml/2006/main">
               <a:ext uri="{FF2B5EF4-FFF2-40B4-BE49-F238E27FC236}">
-                <a16:creationId xmlns:a16="http://schemas.microsoft.com/office/drawing/2014/main" id="{487AA1D5-3FF5-4314-979F-DAE2ADCF8E4C}"/>
+                <a16:creationId xmlns:a16="http://schemas.microsoft.com/office/drawing/2014/main" id="{9724F5E4-17EC-41DD-BA2B-F5158BEA951A}"/>
               </a:ext>
             </a:extLst>
           </p:cNvPr>
@@ -3496,7 +3496,7 @@
           <p:cNvPr id="2" name="">
             <a:extLst xmlns:a="http://schemas.openxmlformats.org/drawingml/2006/main">
               <a:ext uri="{FF2B5EF4-FFF2-40B4-BE49-F238E27FC236}">
-                <a16:creationId xmlns:a16="http://schemas.microsoft.com/office/drawing/2014/main" id="{23A01D95-E005-4A16-907B-6205581C7E10}"/>
+                <a16:creationId xmlns:a16="http://schemas.microsoft.com/office/drawing/2014/main" id="{EDB86DF7-06DD-4D5C-9EFE-A598175D4613}"/>
               </a:ext>
             </a:extLst>
           </p:cNvPr>
@@ -3557,7 +3557,7 @@
           <p:cNvPr id="3" name="">
             <a:extLst xmlns:a="http://schemas.openxmlformats.org/drawingml/2006/main">
               <a:ext uri="{FF2B5EF4-FFF2-40B4-BE49-F238E27FC236}">
-                <a16:creationId xmlns:a16="http://schemas.microsoft.com/office/drawing/2014/main" id="{EFC359E8-16AB-4EE9-AE09-5CD09C3B8F19}"/>
+                <a16:creationId xmlns:a16="http://schemas.microsoft.com/office/drawing/2014/main" id="{A2653A6F-76EB-4548-AD77-89CC759E8570}"/>
               </a:ext>
             </a:extLst>
           </p:cNvPr>
@@ -3618,7 +3618,7 @@
           <p:cNvPr id="4" name="">
             <a:extLst xmlns:a="http://schemas.openxmlformats.org/drawingml/2006/main">
               <a:ext uri="{FF2B5EF4-FFF2-40B4-BE49-F238E27FC236}">
-                <a16:creationId xmlns:a16="http://schemas.microsoft.com/office/drawing/2014/main" id="{B6866D5C-8144-40BA-9A3A-E05D14BE80C8}"/>
+                <a16:creationId xmlns:a16="http://schemas.microsoft.com/office/drawing/2014/main" id="{F4AA4F36-7F39-45F1-ABA8-E1A79CB962D8}"/>
               </a:ext>
             </a:extLst>
           </p:cNvPr>
@@ -3669,7 +3669,7 @@
                 <a:ea typeface="Liberation Sans"/>
                 <a:cs typeface="Liberation Sans"/>
               </a:rPr>
-              <a:t>The public replay preserves the October 11 transaction and capture time.</a:t>
+              <a:t>The public replay preserves the October 12 job and its original capture time.</a:t>
             </a:r>
           </a:p>
         </p:txBody>
@@ -3679,7 +3679,7 @@
           <p:cNvPr id="5" name="">
             <a:extLst xmlns:a="http://schemas.openxmlformats.org/drawingml/2006/main">
               <a:ext uri="{FF2B5EF4-FFF2-40B4-BE49-F238E27FC236}">
-                <a16:creationId xmlns:a16="http://schemas.microsoft.com/office/drawing/2014/main" id="{E0B1A7A8-3114-4C37-AA2D-062EFCA0A29F}"/>
+                <a16:creationId xmlns:a16="http://schemas.microsoft.com/office/drawing/2014/main" id="{22C798D7-7D19-415B-AC38-B83C1CE911B0}"/>
               </a:ext>
             </a:extLst>
           </p:cNvPr>
@@ -3714,7 +3714,7 @@
               <a:buNone/>
               <a:defRPr sz="2175" b="1">
                 <a:solidFill>
-                  <a:srgbClr val="9A5617"/>
+                  <a:srgbClr val="126C97"/>
                 </a:solidFill>
                 <a:latin typeface="Liberation Sans"/>
                 <a:ea typeface="Liberation Sans"/>
@@ -3724,13 +3724,13 @@
             <a:r>
               <a:rPr sz="2175" b="1">
                 <a:solidFill>
-                  <a:srgbClr val="9A5617"/>
+                  <a:srgbClr val="126C97"/>
                 </a:solidFill>
                 <a:latin typeface="Liberation Sans"/>
                 <a:ea typeface="Liberation Sans"/>
                 <a:cs typeface="Liberation Sans"/>
               </a:rPr>
-              <a:t>peaq: live integration pending</a:t>
+              <a:t>peaq Agung: verified</a:t>
             </a:r>
           </a:p>
         </p:txBody>
@@ -3740,7 +3740,7 @@
           <p:cNvPr id="6" name="">
             <a:extLst xmlns:a="http://schemas.openxmlformats.org/drawingml/2006/main">
               <a:ext uri="{FF2B5EF4-FFF2-40B4-BE49-F238E27FC236}">
-                <a16:creationId xmlns:a16="http://schemas.microsoft.com/office/drawing/2014/main" id="{9336EA76-A7A8-4E94-9F00-1484663200EE}"/>
+                <a16:creationId xmlns:a16="http://schemas.microsoft.com/office/drawing/2014/main" id="{BA1C4157-4CC7-4145-9603-248218084465}"/>
               </a:ext>
             </a:extLst>
           </p:cNvPr>
@@ -3801,7 +3801,7 @@
           <p:cNvPr id="7" name="">
             <a:extLst xmlns:a="http://schemas.openxmlformats.org/drawingml/2006/main">
               <a:ext uri="{FF2B5EF4-FFF2-40B4-BE49-F238E27FC236}">
-                <a16:creationId xmlns:a16="http://schemas.microsoft.com/office/drawing/2014/main" id="{184D22A4-FA41-4147-943D-B42218C28123}"/>
+                <a16:creationId xmlns:a16="http://schemas.microsoft.com/office/drawing/2014/main" id="{9156A9B7-7967-436E-A82D-BF33D4F6AADE}"/>
               </a:ext>
             </a:extLst>
           </p:cNvPr>
@@ -3852,7 +3852,7 @@
                 <a:ea typeface="Liberation Sans"/>
                 <a:cs typeface="Liberation Sans"/>
               </a:rPr>
-              <a:t>An activity record links a completed check to payment and evidence.</a:t>
+              <a:t>A finalized native Storage record links the unchanged job hash.</a:t>
             </a:r>
           </a:p>
         </p:txBody>
@@ -3862,7 +3862,7 @@
           <p:cNvPr id="8" name="">
             <a:extLst xmlns:a="http://schemas.openxmlformats.org/drawingml/2006/main">
               <a:ext uri="{FF2B5EF4-FFF2-40B4-BE49-F238E27FC236}">
-                <a16:creationId xmlns:a16="http://schemas.microsoft.com/office/drawing/2014/main" id="{C936E732-AE1E-47A4-A0DB-310F008EC72F}"/>
+                <a16:creationId xmlns:a16="http://schemas.microsoft.com/office/drawing/2014/main" id="{FF4D7D35-24C9-40BC-84B6-D5DE0EA65F79}"/>
               </a:ext>
             </a:extLst>
           </p:cNvPr>
@@ -3923,7 +3923,7 @@
           <p:cNvPr id="9" name="">
             <a:extLst xmlns:a="http://schemas.openxmlformats.org/drawingml/2006/main">
               <a:ext uri="{FF2B5EF4-FFF2-40B4-BE49-F238E27FC236}">
-                <a16:creationId xmlns:a16="http://schemas.microsoft.com/office/drawing/2014/main" id="{CAE80FD8-FA99-4163-ADFD-F3B83690D042}"/>
+                <a16:creationId xmlns:a16="http://schemas.microsoft.com/office/drawing/2014/main" id="{DCECA491-FDD6-4553-AB75-D5580F727B6B}"/>
               </a:ext>
             </a:extLst>
           </p:cNvPr>
@@ -3974,7 +3974,7 @@
                 <a:ea typeface="Liberation Sans"/>
                 <a:cs typeface="Liberation Sans"/>
               </a:rPr>
-              <a:t>05 / peaq code has tests. No live identity or activity event is established. Paid integration and inspection fees remain hypotheses.</a:t>
+              <a:t>05 / Real Agung identity and Storage readbacks. Customer demand remains unvalidated.</a:t>
             </a:r>
           </a:p>
         </p:txBody>
@@ -3982,7 +3982,7 @@
     </p:spTree>
     <p:extLst>
       <p:ext uri="{BB962C8B-B14F-4D97-AF65-F5344CB8AC3E}">
-        <p14:creationId xmlns:p14="http://schemas.microsoft.com/office/powerpoint/2010/main" val="1105289494"/>
+        <p14:creationId xmlns:p14="http://schemas.microsoft.com/office/powerpoint/2010/main" val="398696374"/>
       </p:ext>
     </p:extLst>
   </p:cSld>

</xml_diff>

<commit_message>
Publish the simple pitch and verified peaq-linked review cut
</commit_message>
<xml_diff>
--- a/competition/fieldproof-pitch.pptx
+++ b/competition/fieldproof-pitch.pptx
@@ -2,17 +2,17 @@
 <file path=ppt/presentation.xml><?xml version="1.0" encoding="utf-8"?>
 <p:presentation xmlns:p="http://schemas.openxmlformats.org/presentationml/2006/main">
   <p:sldMasterIdLst>
-    <p:sldMasterId xmlns:r="http://schemas.openxmlformats.org/officeDocument/2006/relationships" id="2147483648" r:id="R5e3e9016d05141af"/>
+    <p:sldMasterId xmlns:r="http://schemas.openxmlformats.org/officeDocument/2006/relationships" id="2147483648" r:id="Rad932027e67345d1"/>
   </p:sldMasterIdLst>
   <p:notesMasterIdLst>
-    <p:notesMasterId xmlns:r="http://schemas.openxmlformats.org/officeDocument/2006/relationships" r:id="R1ffac5f41aec41bd"/>
+    <p:notesMasterId xmlns:r="http://schemas.openxmlformats.org/officeDocument/2006/relationships" r:id="R9717f12da3ed4360"/>
   </p:notesMasterIdLst>
   <p:sldIdLst>
-    <p:sldId xmlns:r="http://schemas.openxmlformats.org/officeDocument/2006/relationships" id="256" r:id="Rddd7d392dd94452c"/>
-    <p:sldId xmlns:r="http://schemas.openxmlformats.org/officeDocument/2006/relationships" id="257" r:id="R1fca12981e9e4765"/>
-    <p:sldId xmlns:r="http://schemas.openxmlformats.org/officeDocument/2006/relationships" id="258" r:id="R7b8168d628d749e8"/>
-    <p:sldId xmlns:r="http://schemas.openxmlformats.org/officeDocument/2006/relationships" id="259" r:id="R55c44a381eb24a77"/>
-    <p:sldId xmlns:r="http://schemas.openxmlformats.org/officeDocument/2006/relationships" id="260" r:id="Ra2e1ae4c9f6046ec"/>
+    <p:sldId xmlns:r="http://schemas.openxmlformats.org/officeDocument/2006/relationships" id="256" r:id="Ree86c22933ad40f2"/>
+    <p:sldId xmlns:r="http://schemas.openxmlformats.org/officeDocument/2006/relationships" id="257" r:id="R3c0cdab536b44258"/>
+    <p:sldId xmlns:r="http://schemas.openxmlformats.org/officeDocument/2006/relationships" id="258" r:id="Rf269fe350e0442bb"/>
+    <p:sldId xmlns:r="http://schemas.openxmlformats.org/officeDocument/2006/relationships" id="259" r:id="Read9203d2f5443ac"/>
+    <p:sldId xmlns:r="http://schemas.openxmlformats.org/officeDocument/2006/relationships" id="260" r:id="Rff1a3ccf8c0f472f"/>
   </p:sldIdLst>
   <p:sldSz cx="12192000" cy="6858000"/>
   <p:notesSz cx="6858000" cy="9144000"/>
@@ -446,7 +446,7 @@
           <a:lstStyle xmlns:a="http://schemas.openxmlformats.org/drawingml/2006/main"/>
           <a:p xmlns:a="http://schemas.openxmlformats.org/drawingml/2006/main">
             <a:r>
-              <a:t>Content source: docs/competition/slides.html. Implementation and evidence: docs/VERIFICATION.md and docs/evidence/device-signed-purchase-20261011.json. Buyer value and commercial pricing are hypotheses. The Solana transaction uses test tokens. Real Agung identity and native Storage work readbacks passed on October 12. No EventRegistry event or credit rating is claimed. Slide 1 of 5.</a:t>
+              <a:t>Opening and founder context. Explain why software needs a fresh physical answer across device owners. Copy source: docs/competition/slides.html.</a:t>
             </a:r>
           </a:p>
         </p:txBody>
@@ -516,7 +516,7 @@
           <a:lstStyle xmlns:a="http://schemas.openxmlformats.org/drawingml/2006/main"/>
           <a:p xmlns:a="http://schemas.openxmlformats.org/drawingml/2006/main">
             <a:r>
-              <a:t>Content source: docs/competition/slides.html. Implementation and evidence: docs/VERIFICATION.md and docs/evidence/device-signed-purchase-20261011.json. Buyer value and commercial pricing are hypotheses. The Solana transaction uses test tokens. Real Agung identity and native Storage work readbacks passed on October 12. No EventRegistry event or credit rating is claimed. Slide 2 of 5.</a:t>
+              <a:t>Explain a commissioned measurement. Payment buys the check, including an unfavorable answer. A common workflow across independent operators is the product hypothesis. Copy source: docs/competition/slides.html.</a:t>
             </a:r>
           </a:p>
         </p:txBody>
@@ -586,7 +586,7 @@
           <a:lstStyle xmlns:a="http://schemas.openxmlformats.org/drawingml/2006/main"/>
           <a:p xmlns:a="http://schemas.openxmlformats.org/drawingml/2006/main">
             <a:r>
-              <a:t>Content source: docs/competition/slides.html. Implementation and evidence: docs/VERIFICATION.md and docs/evidence/device-signed-purchase-20261011.json. Buyer value and commercial pricing are hypotheses. The Solana transaction uses test tokens. Real Agung identity and native Storage work readbacks passed on October 12. No EventRegistry event or credit rating is claimed. Slide 3 of 5.</a:t>
+              <a:t>Working evidence: docs/evidence/current-job.json and docs/VERIFICATION.md. One real ESP32 provider. Seeker independently verifies receipts. Solana Devnet pays 0.001 test USDC. The buyer resolves the peaq Agung device key before payment. The completed job has a finalized native Storage work record. No EventRegistry or credit rating is claimed. Copy source: docs/competition/slides.html.</a:t>
             </a:r>
           </a:p>
         </p:txBody>
@@ -656,7 +656,7 @@
           <a:lstStyle xmlns:a="http://schemas.openxmlformats.org/drawingml/2006/main"/>
           <a:p xmlns:a="http://schemas.openxmlformats.org/drawingml/2006/main">
             <a:r>
-              <a:t>Content source: docs/competition/slides.html. Implementation and evidence: docs/VERIFICATION.md and docs/evidence/device-signed-purchase-20261011.json. Buyer value and commercial pricing are hypotheses. The Solana transaction uses test tokens. Real Agung identity and native Storage work readbacks passed on October 12. No EventRegistry event or credit rating is claimed. Slide 4 of 5.</a:t>
+              <a:t>The unchanged receipt timestamp expires under the ten-second buyer policy. An edited local copy fails the original signature. A signature authenticates a claim, not physical truth. Copy source: docs/competition/slides.html.</a:t>
             </a:r>
           </a:p>
         </p:txBody>
@@ -726,7 +726,7 @@
           <a:lstStyle xmlns:a="http://schemas.openxmlformats.org/drawingml/2006/main"/>
           <a:p xmlns:a="http://schemas.openxmlformats.org/drawingml/2006/main">
             <a:r>
-              <a:t>Content source: docs/competition/slides.html. Implementation and evidence: docs/VERIFICATION.md and docs/evidence/device-signed-purchase-20261011.json. Buyer value and commercial pricing are hypotheses. The Solana transaction uses test tokens. Real Agung identity and native Storage work readbacks passed on October 12. No EventRegistry event or credit rating is claimed. Slide 5 of 5.</a:t>
+              <a:t>Future network, customer demand, recurring paid use, and reputation remain unvalidated. Start with one authorized operator and one recurring question. Integration and per-check fees are hypotheses. Logo supplied by the founder. Copy source: docs/competition/slides.html.</a:t>
             </a:r>
           </a:p>
         </p:txBody>
@@ -794,7 +794,7 @@
   </p:cSld>
   <p:clrMap bg1="lt1" tx1="dk1" bg2="lt2" tx2="dk2" accent1="accent1" accent2="accent2" accent3="accent3" accent4="accent4" accent5="accent5" accent6="accent6" hlink="hlink" folHlink="folHlink"/>
   <p:sldLayoutIdLst>
-    <p:sldLayoutId xmlns:r="http://schemas.openxmlformats.org/officeDocument/2006/relationships" id="2147483649" r:id="R043c941cac0c4f89"/>
+    <p:sldLayoutId xmlns:r="http://schemas.openxmlformats.org/officeDocument/2006/relationships" id="2147483649" r:id="Rdf191859f87f4955"/>
   </p:sldLayoutIdLst>
   <p:txStyles>
     <p:titleStyle>
@@ -1327,7 +1327,7 @@
     <p:bg>
       <p:bgPr>
         <a:solidFill xmlns:a="http://schemas.openxmlformats.org/drawingml/2006/main">
-          <a:srgbClr val="F4FAFF"/>
+          <a:srgbClr val="FFFFFF"/>
         </a:solidFill>
       </p:bgPr>
     </p:bg>
@@ -1342,10 +1342,10 @@
       </p:grpSpPr>
       <p:sp>
         <p:nvSpPr>
-          <p:cNvPr id="7" name="">
+          <p:cNvPr id="3" name="">
             <a:extLst xmlns:a="http://schemas.openxmlformats.org/drawingml/2006/main">
               <a:ext uri="{FF2B5EF4-FFF2-40B4-BE49-F238E27FC236}">
-                <a16:creationId xmlns:a16="http://schemas.microsoft.com/office/drawing/2014/main" id="{DEA8DFB1-E5CA-4677-8019-928C3D8049FE}"/>
+                <a16:creationId xmlns:a16="http://schemas.microsoft.com/office/drawing/2014/main" id="{CADA974E-C978-43D5-936E-8D128C594A3D}"/>
               </a:ext>
             </a:extLst>
           </p:cNvPr>
@@ -1356,8 +1356,8 @@
         </p:nvSpPr>
         <p:spPr>
           <a:xfrm xmlns:a="http://schemas.openxmlformats.org/drawingml/2006/main">
-            <a:off x="685800" y="457200"/>
-            <a:ext cx="10820400" cy="857250"/>
+            <a:off x="685800" y="2095500"/>
+            <a:ext cx="10820400" cy="476250"/>
           </a:xfrm>
           <a:prstGeom xmlns:a="http://schemas.openxmlformats.org/drawingml/2006/main" prst="rect">
             <a:avLst/>
@@ -1375,12 +1375,12 @@
           <a:p xmlns:a="http://schemas.openxmlformats.org/drawingml/2006/main">
             <a:pPr>
               <a:lnSpc>
-                <a:spcPct val="118000"/>
+                <a:spcPct val="115000"/>
               </a:lnSpc>
               <a:buNone/>
-              <a:defRPr sz="3450" b="1">
-                <a:solidFill>
-                  <a:srgbClr val="17364D"/>
+              <a:defRPr sz="2250" b="0">
+                <a:solidFill>
+                  <a:srgbClr val="111111"/>
                 </a:solidFill>
                 <a:latin typeface="Liberation Sans"/>
                 <a:ea typeface="Liberation Sans"/>
@@ -1388,15 +1388,15 @@
               </a:defRPr>
             </a:pPr>
             <a:r>
-              <a:rPr sz="3450" b="1">
-                <a:solidFill>
-                  <a:srgbClr val="17364D"/>
+              <a:rPr sz="2250" b="0">
+                <a:solidFill>
+                  <a:srgbClr val="111111"/>
                 </a:solidFill>
                 <a:latin typeface="Liberation Sans"/>
                 <a:ea typeface="Liberation Sans"/>
                 <a:cs typeface="Liberation Sans"/>
               </a:rPr>
-              <a:t>FieldProof</a:t>
+              <a:t>FIELDPROOF</a:t>
             </a:r>
           </a:p>
         </p:txBody>
@@ -1406,7 +1406,7 @@
           <p:cNvPr id="2" name="">
             <a:extLst xmlns:a="http://schemas.openxmlformats.org/drawingml/2006/main">
               <a:ext uri="{FF2B5EF4-FFF2-40B4-BE49-F238E27FC236}">
-                <a16:creationId xmlns:a16="http://schemas.microsoft.com/office/drawing/2014/main" id="{9F6C66BA-CEC1-4E06-A466-190FF9C95A15}"/>
+                <a16:creationId xmlns:a16="http://schemas.microsoft.com/office/drawing/2014/main" id="{8179D66A-471E-4F32-9AE0-03E057D0DE4E}"/>
               </a:ext>
             </a:extLst>
           </p:cNvPr>
@@ -1417,8 +1417,8 @@
         </p:nvSpPr>
         <p:spPr>
           <a:xfrm xmlns:a="http://schemas.openxmlformats.org/drawingml/2006/main">
-            <a:off x="685800" y="1752600"/>
-            <a:ext cx="7810500" cy="1314450"/>
+            <a:off x="685800" y="2809875"/>
+            <a:ext cx="10820400" cy="2190750"/>
           </a:xfrm>
           <a:prstGeom xmlns:a="http://schemas.openxmlformats.org/drawingml/2006/main" prst="rect">
             <a:avLst/>
@@ -1436,12 +1436,12 @@
           <a:p xmlns:a="http://schemas.openxmlformats.org/drawingml/2006/main">
             <a:pPr>
               <a:lnSpc>
-                <a:spcPct val="118000"/>
+                <a:spcPct val="115000"/>
               </a:lnSpc>
               <a:buNone/>
-              <a:defRPr sz="3150" b="1">
-                <a:solidFill>
-                  <a:srgbClr val="126C97"/>
+              <a:defRPr sz="5700" b="1">
+                <a:solidFill>
+                  <a:srgbClr val="111111"/>
                 </a:solidFill>
                 <a:latin typeface="Liberation Sans"/>
                 <a:ea typeface="Liberation Sans"/>
@@ -1449,60 +1449,26 @@
               </a:defRPr>
             </a:pPr>
             <a:r>
-              <a:rPr sz="3150" b="1">
-                <a:solidFill>
-                  <a:srgbClr val="126C97"/>
+              <a:rPr sz="5700" b="1">
+                <a:solidFill>
+                  <a:srgbClr val="111111"/>
                 </a:solidFill>
                 <a:latin typeface="Liberation Sans"/>
                 <a:ea typeface="Liberation Sans"/>
                 <a:cs typeface="Liberation Sans"/>
               </a:rPr>
-              <a:t>Software pays for a fresh physical check.</a:t>
-            </a:r>
-          </a:p>
-        </p:txBody>
-      </p:sp>
-      <p:sp>
-        <p:nvSpPr>
-          <p:cNvPr id="3" name="">
-            <a:extLst xmlns:a="http://schemas.openxmlformats.org/drawingml/2006/main">
-              <a:ext uri="{FF2B5EF4-FFF2-40B4-BE49-F238E27FC236}">
-                <a16:creationId xmlns:a16="http://schemas.microsoft.com/office/drawing/2014/main" id="{87EE48BF-3467-4654-AF69-8F6ECAE1E0FB}"/>
-              </a:ext>
-            </a:extLst>
-          </p:cNvPr>
-          <p:cNvSpPr>
-            <a:spLocks xmlns:a="http://schemas.openxmlformats.org/drawingml/2006/main" noGrp="1"/>
-          </p:cNvSpPr>
-          <p:nvPr/>
-        </p:nvSpPr>
-        <p:spPr>
-          <a:xfrm xmlns:a="http://schemas.openxmlformats.org/drawingml/2006/main">
-            <a:off x="685800" y="3333750"/>
-            <a:ext cx="8096250" cy="1409700"/>
-          </a:xfrm>
-          <a:prstGeom xmlns:a="http://schemas.openxmlformats.org/drawingml/2006/main" prst="rect">
-            <a:avLst/>
-          </a:prstGeom>
-          <a:noFill xmlns:a="http://schemas.openxmlformats.org/drawingml/2006/main"/>
-          <a:ln xmlns:a="http://schemas.openxmlformats.org/drawingml/2006/main" w="0">
-            <a:noFill/>
-          </a:ln>
-        </p:spPr>
-        <p:txBody>
-          <a:bodyPr xmlns:a="http://schemas.openxmlformats.org/drawingml/2006/main" lIns="0" tIns="0" rIns="0" bIns="0" anchor="t">
-            <a:noAutofit/>
-          </a:bodyPr>
-          <a:lstStyle xmlns:a="http://schemas.openxmlformats.org/drawingml/2006/main"/>
+              <a:t>BUY FRESH READINGS</a:t>
+            </a:r>
+          </a:p>
           <a:p xmlns:a="http://schemas.openxmlformats.org/drawingml/2006/main">
             <a:pPr>
               <a:lnSpc>
-                <a:spcPct val="118000"/>
+                <a:spcPct val="115000"/>
               </a:lnSpc>
               <a:buNone/>
-              <a:defRPr sz="2250" b="0">
-                <a:solidFill>
-                  <a:srgbClr val="17364D"/>
+              <a:defRPr sz="5700" b="1">
+                <a:solidFill>
+                  <a:srgbClr val="111111"/>
                 </a:solidFill>
                 <a:latin typeface="Liberation Sans"/>
                 <a:ea typeface="Liberation Sans"/>
@@ -1510,159 +1476,15 @@
               </a:defRPr>
             </a:pPr>
             <a:r>
-              <a:rPr sz="2250" b="0">
-                <a:solidFill>
-                  <a:srgbClr val="17364D"/>
+              <a:rPr sz="5700" b="1">
+                <a:solidFill>
+                  <a:srgbClr val="111111"/>
                 </a:solidFill>
                 <a:latin typeface="Liberation Sans"/>
                 <a:ea typeface="Liberation Sans"/>
                 <a:cs typeface="Liberation Sans"/>
               </a:rPr>
-              <a:t>The device signs its answer. The buyer verifies who answered and whether the answer is still fresh.</a:t>
-            </a:r>
-          </a:p>
-        </p:txBody>
-      </p:sp>
-      <p:sp>
-        <p:nvSpPr>
-          <p:cNvPr id="4" name="">
-            <a:extLst xmlns:a="http://schemas.openxmlformats.org/drawingml/2006/main">
-              <a:ext uri="{FF2B5EF4-FFF2-40B4-BE49-F238E27FC236}">
-                <a16:creationId xmlns:a16="http://schemas.microsoft.com/office/drawing/2014/main" id="{A514202E-96DB-4A1D-8BB1-1487138184E8}"/>
-              </a:ext>
-            </a:extLst>
-          </p:cNvPr>
-          <p:cNvSpPr>
-            <a:spLocks xmlns:a="http://schemas.openxmlformats.org/drawingml/2006/main" noGrp="1"/>
-          </p:cNvSpPr>
-          <p:nvPr/>
-        </p:nvSpPr>
-        <p:spPr>
-          <a:xfrm xmlns:a="http://schemas.openxmlformats.org/drawingml/2006/main">
-            <a:off x="685800" y="5257800"/>
-            <a:ext cx="8572500" cy="419100"/>
-          </a:xfrm>
-          <a:prstGeom xmlns:a="http://schemas.openxmlformats.org/drawingml/2006/main" prst="rect">
-            <a:avLst/>
-          </a:prstGeom>
-          <a:noFill xmlns:a="http://schemas.openxmlformats.org/drawingml/2006/main"/>
-          <a:ln xmlns:a="http://schemas.openxmlformats.org/drawingml/2006/main" w="0">
-            <a:noFill/>
-          </a:ln>
-        </p:spPr>
-        <p:txBody>
-          <a:bodyPr xmlns:a="http://schemas.openxmlformats.org/drawingml/2006/main" lIns="0" tIns="0" rIns="0" bIns="0" anchor="t">
-            <a:noAutofit/>
-          </a:bodyPr>
-          <a:lstStyle xmlns:a="http://schemas.openxmlformats.org/drawingml/2006/main"/>
-          <a:p xmlns:a="http://schemas.openxmlformats.org/drawingml/2006/main">
-            <a:pPr>
-              <a:lnSpc>
-                <a:spcPct val="118000"/>
-              </a:lnSpc>
-              <a:buNone/>
-              <a:defRPr sz="1725" b="0">
-                <a:solidFill>
-                  <a:srgbClr val="536D80"/>
-                </a:solidFill>
-                <a:latin typeface="Liberation Sans"/>
-                <a:ea typeface="Liberation Sans"/>
-                <a:cs typeface="Liberation Sans"/>
-              </a:defRPr>
-            </a:pPr>
-            <a:r>
-              <a:rPr sz="1725" b="0">
-                <a:solidFill>
-                  <a:srgbClr val="536D80"/>
-                </a:solidFill>
-                <a:latin typeface="Liberation Sans"/>
-                <a:ea typeface="Liberation Sans"/>
-                <a:cs typeface="Liberation Sans"/>
-              </a:rPr>
-              <a:t>Working prototype: ESP32-C6 and Solana Devnet.</a:t>
-            </a:r>
-          </a:p>
-        </p:txBody>
-      </p:sp>
-      <p:pic>
-        <p:nvPicPr>
-          <p:cNvPr id="11" name=""/>
-          <p:cNvPicPr>
-            <a:picLocks xmlns:a="http://schemas.openxmlformats.org/drawingml/2006/main" noChangeAspect="1"/>
-          </p:cNvPicPr>
-          <p:nvPr/>
-        </p:nvPicPr>
-        <p:blipFill>
-          <a:blip xmlns:r="http://schemas.openxmlformats.org/officeDocument/2006/relationships" xmlns:a="http://schemas.openxmlformats.org/drawingml/2006/main" r:embed="Rce9f1a99adde4235"/>
-          <a:stretch xmlns:a="http://schemas.openxmlformats.org/drawingml/2006/main"/>
-        </p:blipFill>
-        <p:spPr>
-          <a:xfrm xmlns:a="http://schemas.openxmlformats.org/drawingml/2006/main">
-            <a:off x="9144000" y="2000250"/>
-            <a:ext cx="2381250" cy="2381250"/>
-          </a:xfrm>
-          <a:prstGeom xmlns:a="http://schemas.openxmlformats.org/drawingml/2006/main" prst="rect">
-            <a:avLst/>
-          </a:prstGeom>
-        </p:spPr>
-      </p:pic>
-      <p:sp>
-        <p:nvSpPr>
-          <p:cNvPr id="6" name="">
-            <a:extLst xmlns:a="http://schemas.openxmlformats.org/drawingml/2006/main">
-              <a:ext uri="{FF2B5EF4-FFF2-40B4-BE49-F238E27FC236}">
-                <a16:creationId xmlns:a16="http://schemas.microsoft.com/office/drawing/2014/main" id="{CC164124-A2BF-46C2-B731-ACE2E8C84775}"/>
-              </a:ext>
-            </a:extLst>
-          </p:cNvPr>
-          <p:cNvSpPr>
-            <a:spLocks xmlns:a="http://schemas.openxmlformats.org/drawingml/2006/main" noGrp="1"/>
-          </p:cNvSpPr>
-          <p:nvPr/>
-        </p:nvSpPr>
-        <p:spPr>
-          <a:xfrm xmlns:a="http://schemas.openxmlformats.org/drawingml/2006/main">
-            <a:off x="685800" y="6276975"/>
-            <a:ext cx="10820400" cy="419100"/>
-          </a:xfrm>
-          <a:prstGeom xmlns:a="http://schemas.openxmlformats.org/drawingml/2006/main" prst="rect">
-            <a:avLst/>
-          </a:prstGeom>
-          <a:noFill xmlns:a="http://schemas.openxmlformats.org/drawingml/2006/main"/>
-          <a:ln xmlns:a="http://schemas.openxmlformats.org/drawingml/2006/main" w="0">
-            <a:noFill/>
-          </a:ln>
-        </p:spPr>
-        <p:txBody>
-          <a:bodyPr xmlns:a="http://schemas.openxmlformats.org/drawingml/2006/main" lIns="0" tIns="0" rIns="0" bIns="0" anchor="t">
-            <a:noAutofit/>
-          </a:bodyPr>
-          <a:lstStyle xmlns:a="http://schemas.openxmlformats.org/drawingml/2006/main"/>
-          <a:p xmlns:a="http://schemas.openxmlformats.org/drawingml/2006/main">
-            <a:pPr>
-              <a:lnSpc>
-                <a:spcPct val="118000"/>
-              </a:lnSpc>
-              <a:buNone/>
-              <a:defRPr sz="1350" b="0">
-                <a:solidFill>
-                  <a:srgbClr val="536D80"/>
-                </a:solidFill>
-                <a:latin typeface="Liberation Sans"/>
-                <a:ea typeface="Liberation Sans"/>
-                <a:cs typeface="Liberation Sans"/>
-              </a:defRPr>
-            </a:pPr>
-            <a:r>
-              <a:rPr sz="1350" b="0">
-                <a:solidFill>
-                  <a:srgbClr val="536D80"/>
-                </a:solidFill>
-                <a:latin typeface="Liberation Sans"/>
-                <a:ea typeface="Liberation Sans"/>
-                <a:cs typeface="Liberation Sans"/>
-              </a:rPr>
-              <a:t>01 / A signature identifies the claim’s source. Physical truth needs separate controls.</a:t>
+              <a:t>FROM SENSORS</a:t>
             </a:r>
           </a:p>
         </p:txBody>
@@ -1670,7 +1492,7 @@
     </p:spTree>
     <p:extLst>
       <p:ext uri="{BB962C8B-B14F-4D97-AF65-F5344CB8AC3E}">
-        <p14:creationId xmlns:p14="http://schemas.microsoft.com/office/powerpoint/2010/main" val="1400951751"/>
+        <p14:creationId xmlns:p14="http://schemas.microsoft.com/office/powerpoint/2010/main" val="171500543"/>
       </p:ext>
     </p:extLst>
   </p:cSld>
@@ -1683,7 +1505,7 @@
     <p:bg>
       <p:bgPr>
         <a:solidFill xmlns:a="http://schemas.openxmlformats.org/drawingml/2006/main">
-          <a:srgbClr val="F4FAFF"/>
+          <a:srgbClr val="FFFFFF"/>
         </a:solidFill>
       </p:bgPr>
     </p:bg>
@@ -1701,7 +1523,7 @@
           <p:cNvPr id="10" name="">
             <a:extLst xmlns:a="http://schemas.openxmlformats.org/drawingml/2006/main">
               <a:ext uri="{FF2B5EF4-FFF2-40B4-BE49-F238E27FC236}">
-                <a16:creationId xmlns:a16="http://schemas.microsoft.com/office/drawing/2014/main" id="{9626C400-F500-4BB9-A44B-5F491EF4682A}"/>
+                <a16:creationId xmlns:a16="http://schemas.microsoft.com/office/drawing/2014/main" id="{1EFE8D5C-0C7A-4EDB-9B68-CADBC315AEED}"/>
               </a:ext>
             </a:extLst>
           </p:cNvPr>
@@ -1712,8 +1534,8 @@
         </p:nvSpPr>
         <p:spPr>
           <a:xfrm xmlns:a="http://schemas.openxmlformats.org/drawingml/2006/main">
-            <a:off x="685800" y="457200"/>
-            <a:ext cx="10820400" cy="857250"/>
+            <a:off x="685800" y="590550"/>
+            <a:ext cx="10820400" cy="1123950"/>
           </a:xfrm>
           <a:prstGeom xmlns:a="http://schemas.openxmlformats.org/drawingml/2006/main" prst="rect">
             <a:avLst/>
@@ -1731,12 +1553,12 @@
           <a:p xmlns:a="http://schemas.openxmlformats.org/drawingml/2006/main">
             <a:pPr>
               <a:lnSpc>
-                <a:spcPct val="118000"/>
+                <a:spcPct val="115000"/>
               </a:lnSpc>
               <a:buNone/>
-              <a:defRPr sz="3450" b="1">
-                <a:solidFill>
-                  <a:srgbClr val="17364D"/>
+              <a:defRPr sz="3675" b="1">
+                <a:solidFill>
+                  <a:srgbClr val="111111"/>
                 </a:solidFill>
                 <a:latin typeface="Liberation Sans"/>
                 <a:ea typeface="Liberation Sans"/>
@@ -1744,15 +1566,15 @@
               </a:defRPr>
             </a:pPr>
             <a:r>
-              <a:rPr sz="3450" b="1">
-                <a:solidFill>
-                  <a:srgbClr val="17364D"/>
+              <a:rPr sz="3675" b="1">
+                <a:solidFill>
+                  <a:srgbClr val="111111"/>
                 </a:solidFill>
                 <a:latin typeface="Liberation Sans"/>
                 <a:ea typeface="Liberation Sans"/>
                 <a:cs typeface="Liberation Sans"/>
               </a:rPr>
-              <a:t>A remote inspection before a decision</a:t>
+              <a:t>One request, one new reading</a:t>
             </a:r>
           </a:p>
         </p:txBody>
@@ -1762,7 +1584,7 @@
           <p:cNvPr id="2" name="">
             <a:extLst xmlns:a="http://schemas.openxmlformats.org/drawingml/2006/main">
               <a:ext uri="{FF2B5EF4-FFF2-40B4-BE49-F238E27FC236}">
-                <a16:creationId xmlns:a16="http://schemas.microsoft.com/office/drawing/2014/main" id="{347A121C-8D91-46A8-A663-BAA8EB4366AD}"/>
+                <a16:creationId xmlns:a16="http://schemas.microsoft.com/office/drawing/2014/main" id="{8FAC85EC-D51B-47F2-B449-DF69AFD70E3C}"/>
               </a:ext>
             </a:extLst>
           </p:cNvPr>
@@ -1773,8 +1595,8 @@
         </p:nvSpPr>
         <p:spPr>
           <a:xfrm xmlns:a="http://schemas.openxmlformats.org/drawingml/2006/main">
-            <a:off x="685800" y="1809750"/>
-            <a:ext cx="5010150" cy="666750"/>
+            <a:off x="685800" y="2762250"/>
+            <a:ext cx="4000500" cy="523875"/>
           </a:xfrm>
           <a:prstGeom xmlns:a="http://schemas.openxmlformats.org/drawingml/2006/main" prst="rect">
             <a:avLst/>
@@ -1792,12 +1614,12 @@
           <a:p xmlns:a="http://schemas.openxmlformats.org/drawingml/2006/main">
             <a:pPr>
               <a:lnSpc>
-                <a:spcPct val="118000"/>
+                <a:spcPct val="115000"/>
               </a:lnSpc>
               <a:buNone/>
-              <a:defRPr sz="2175" b="1">
-                <a:solidFill>
-                  <a:srgbClr val="126C97"/>
+              <a:defRPr sz="2850" b="1">
+                <a:solidFill>
+                  <a:srgbClr val="111111"/>
                 </a:solidFill>
                 <a:latin typeface="Liberation Sans"/>
                 <a:ea typeface="Liberation Sans"/>
@@ -1805,15 +1627,15 @@
               </a:defRPr>
             </a:pPr>
             <a:r>
-              <a:rPr sz="2175" b="1">
-                <a:solidFill>
-                  <a:srgbClr val="126C97"/>
+              <a:rPr sz="2850" b="1">
+                <a:solidFill>
+                  <a:srgbClr val="111111"/>
                 </a:solidFill>
                 <a:latin typeface="Liberation Sans"/>
                 <a:ea typeface="Liberation Sans"/>
                 <a:cs typeface="Liberation Sans"/>
               </a:rPr>
-              <a:t>Target workflow</a:t>
+              <a:t>Software buyer</a:t>
             </a:r>
           </a:p>
         </p:txBody>
@@ -1823,7 +1645,7 @@
           <p:cNvPr id="3" name="">
             <a:extLst xmlns:a="http://schemas.openxmlformats.org/drawingml/2006/main">
               <a:ext uri="{FF2B5EF4-FFF2-40B4-BE49-F238E27FC236}">
-                <a16:creationId xmlns:a16="http://schemas.microsoft.com/office/drawing/2014/main" id="{D6B07CFF-45EE-4C80-9A47-A90618F96DBA}"/>
+                <a16:creationId xmlns:a16="http://schemas.microsoft.com/office/drawing/2014/main" id="{45DBA91D-C6E1-4188-A6C5-9283E1510A9A}"/>
               </a:ext>
             </a:extLst>
           </p:cNvPr>
@@ -1834,8 +1656,8 @@
         </p:nvSpPr>
         <p:spPr>
           <a:xfrm xmlns:a="http://schemas.openxmlformats.org/drawingml/2006/main">
-            <a:off x="685800" y="2647950"/>
-            <a:ext cx="4895850" cy="1162050"/>
+            <a:off x="685800" y="3333750"/>
+            <a:ext cx="4000500" cy="523875"/>
           </a:xfrm>
           <a:prstGeom xmlns:a="http://schemas.openxmlformats.org/drawingml/2006/main" prst="rect">
             <a:avLst/>
@@ -1853,12 +1675,12 @@
           <a:p xmlns:a="http://schemas.openxmlformats.org/drawingml/2006/main">
             <a:pPr>
               <a:lnSpc>
-                <a:spcPct val="118000"/>
+                <a:spcPct val="115000"/>
               </a:lnSpc>
               <a:buNone/>
-              <a:defRPr sz="2100" b="0">
-                <a:solidFill>
-                  <a:srgbClr val="17364D"/>
+              <a:defRPr sz="1875" b="0">
+                <a:solidFill>
+                  <a:srgbClr val="111111"/>
                 </a:solidFill>
                 <a:latin typeface="Liberation Sans"/>
                 <a:ea typeface="Liberation Sans"/>
@@ -1866,15 +1688,15 @@
               </a:defRPr>
             </a:pPr>
             <a:r>
-              <a:rPr sz="2100" b="0">
-                <a:solidFill>
-                  <a:srgbClr val="17364D"/>
+              <a:rPr sz="1875" b="0">
+                <a:solidFill>
+                  <a:srgbClr val="111111"/>
                 </a:solidFill>
                 <a:latin typeface="Liberation Sans"/>
                 <a:ea typeface="Liberation Sans"/>
                 <a:cs typeface="Liberation Sans"/>
               </a:rPr>
-              <a:t>An operator pays someone to check a physical fact at another site.</a:t>
+              <a:t>Question and budget</a:t>
             </a:r>
           </a:p>
         </p:txBody>
@@ -1884,7 +1706,7 @@
           <p:cNvPr id="4" name="">
             <a:extLst xmlns:a="http://schemas.openxmlformats.org/drawingml/2006/main">
               <a:ext uri="{FF2B5EF4-FFF2-40B4-BE49-F238E27FC236}">
-                <a16:creationId xmlns:a16="http://schemas.microsoft.com/office/drawing/2014/main" id="{A4B86E51-DE71-4915-AF2D-4D20ADCAC2A1}"/>
+                <a16:creationId xmlns:a16="http://schemas.microsoft.com/office/drawing/2014/main" id="{3D3F6296-40C3-4A78-85A0-D543495038C1}"/>
               </a:ext>
             </a:extLst>
           </p:cNvPr>
@@ -1895,8 +1717,8 @@
         </p:nvSpPr>
         <p:spPr>
           <a:xfrm xmlns:a="http://schemas.openxmlformats.org/drawingml/2006/main">
-            <a:off x="685800" y="4000500"/>
-            <a:ext cx="4895850" cy="1295400"/>
+            <a:off x="4572000" y="2600325"/>
+            <a:ext cx="2619375" cy="514350"/>
           </a:xfrm>
           <a:prstGeom xmlns:a="http://schemas.openxmlformats.org/drawingml/2006/main" prst="rect">
             <a:avLst/>
@@ -1914,12 +1736,12 @@
           <a:p xmlns:a="http://schemas.openxmlformats.org/drawingml/2006/main">
             <a:pPr>
               <a:lnSpc>
-                <a:spcPct val="118000"/>
+                <a:spcPct val="115000"/>
               </a:lnSpc>
               <a:buNone/>
-              <a:defRPr sz="2100" b="0">
-                <a:solidFill>
-                  <a:srgbClr val="17364D"/>
+              <a:defRPr sz="1725" b="0">
+                <a:solidFill>
+                  <a:srgbClr val="111111"/>
                 </a:solidFill>
                 <a:latin typeface="Liberation Sans"/>
                 <a:ea typeface="Liberation Sans"/>
@@ -1927,15 +1749,15 @@
               </a:defRPr>
             </a:pPr>
             <a:r>
-              <a:rPr sz="2100" b="0">
-                <a:solidFill>
-                  <a:srgbClr val="17364D"/>
+              <a:rPr sz="1725" b="0">
+                <a:solidFill>
+                  <a:srgbClr val="111111"/>
                 </a:solidFill>
                 <a:latin typeface="Liberation Sans"/>
                 <a:ea typeface="Liberation Sans"/>
                 <a:cs typeface="Liberation Sans"/>
               </a:rPr>
-              <a:t>Its software lacks a reliable answer from an existing API.</a:t>
+              <a:t>Request and payment</a:t>
             </a:r>
           </a:p>
         </p:txBody>
@@ -1945,7 +1767,7 @@
           <p:cNvPr id="5" name="">
             <a:extLst xmlns:a="http://schemas.openxmlformats.org/drawingml/2006/main">
               <a:ext uri="{FF2B5EF4-FFF2-40B4-BE49-F238E27FC236}">
-                <a16:creationId xmlns:a16="http://schemas.microsoft.com/office/drawing/2014/main" id="{C370338D-7AB0-42FE-B2DA-C4E22EA8733F}"/>
+                <a16:creationId xmlns:a16="http://schemas.microsoft.com/office/drawing/2014/main" id="{22339FCC-93E6-4378-8676-FED173C3A20D}"/>
               </a:ext>
             </a:extLst>
           </p:cNvPr>
@@ -1956,8 +1778,8 @@
         </p:nvSpPr>
         <p:spPr>
           <a:xfrm xmlns:a="http://schemas.openxmlformats.org/drawingml/2006/main">
-            <a:off x="6496050" y="1809750"/>
-            <a:ext cx="5010150" cy="666750"/>
+            <a:off x="5334000" y="3114675"/>
+            <a:ext cx="904875" cy="714375"/>
           </a:xfrm>
           <a:prstGeom xmlns:a="http://schemas.openxmlformats.org/drawingml/2006/main" prst="rect">
             <a:avLst/>
@@ -1975,12 +1797,12 @@
           <a:p xmlns:a="http://schemas.openxmlformats.org/drawingml/2006/main">
             <a:pPr>
               <a:lnSpc>
-                <a:spcPct val="118000"/>
+                <a:spcPct val="115000"/>
               </a:lnSpc>
               <a:buNone/>
-              <a:defRPr sz="2175" b="1">
-                <a:solidFill>
-                  <a:srgbClr val="126C97"/>
+              <a:defRPr sz="3900" b="0">
+                <a:solidFill>
+                  <a:srgbClr val="111111"/>
                 </a:solidFill>
                 <a:latin typeface="Liberation Sans"/>
                 <a:ea typeface="Liberation Sans"/>
@@ -1988,15 +1810,15 @@
               </a:defRPr>
             </a:pPr>
             <a:r>
-              <a:rPr sz="2175" b="1">
-                <a:solidFill>
-                  <a:srgbClr val="126C97"/>
+              <a:rPr sz="3900" b="0">
+                <a:solidFill>
+                  <a:srgbClr val="111111"/>
                 </a:solidFill>
                 <a:latin typeface="Liberation Sans"/>
                 <a:ea typeface="Liberation Sans"/>
                 <a:cs typeface="Liberation Sans"/>
               </a:rPr>
-              <a:t>FieldProof proposal</a:t>
+              <a:t>→</a:t>
             </a:r>
           </a:p>
         </p:txBody>
@@ -2006,7 +1828,7 @@
           <p:cNvPr id="6" name="">
             <a:extLst xmlns:a="http://schemas.openxmlformats.org/drawingml/2006/main">
               <a:ext uri="{FF2B5EF4-FFF2-40B4-BE49-F238E27FC236}">
-                <a16:creationId xmlns:a16="http://schemas.microsoft.com/office/drawing/2014/main" id="{B48DD837-1430-4117-BDA6-4520BAADA121}"/>
+                <a16:creationId xmlns:a16="http://schemas.microsoft.com/office/drawing/2014/main" id="{981B916E-0263-46DB-9400-8E8859C10A23}"/>
               </a:ext>
             </a:extLst>
           </p:cNvPr>
@@ -2017,8 +1839,8 @@
         </p:nvSpPr>
         <p:spPr>
           <a:xfrm xmlns:a="http://schemas.openxmlformats.org/drawingml/2006/main">
-            <a:off x="6496050" y="2647950"/>
-            <a:ext cx="4895850" cy="1162050"/>
+            <a:off x="7905750" y="2762250"/>
+            <a:ext cx="3571875" cy="523875"/>
           </a:xfrm>
           <a:prstGeom xmlns:a="http://schemas.openxmlformats.org/drawingml/2006/main" prst="rect">
             <a:avLst/>
@@ -2036,12 +1858,12 @@
           <a:p xmlns:a="http://schemas.openxmlformats.org/drawingml/2006/main">
             <a:pPr>
               <a:lnSpc>
-                <a:spcPct val="118000"/>
+                <a:spcPct val="115000"/>
               </a:lnSpc>
               <a:buNone/>
-              <a:defRPr sz="2100" b="0">
-                <a:solidFill>
-                  <a:srgbClr val="17364D"/>
+              <a:defRPr sz="2850" b="1">
+                <a:solidFill>
+                  <a:srgbClr val="111111"/>
                 </a:solidFill>
                 <a:latin typeface="Liberation Sans"/>
                 <a:ea typeface="Liberation Sans"/>
@@ -2049,15 +1871,15 @@
               </a:defRPr>
             </a:pPr>
             <a:r>
-              <a:rPr sz="2100" b="0">
-                <a:solidFill>
-                  <a:srgbClr val="17364D"/>
+              <a:rPr sz="2850" b="1">
+                <a:solidFill>
+                  <a:srgbClr val="111111"/>
                 </a:solidFill>
                 <a:latin typeface="Liberation Sans"/>
                 <a:ea typeface="Liberation Sans"/>
                 <a:cs typeface="Liberation Sans"/>
               </a:rPr>
-              <a:t>Commission one check from a device already on site.</a:t>
+              <a:t>Device operator</a:t>
             </a:r>
           </a:p>
         </p:txBody>
@@ -2067,7 +1889,7 @@
           <p:cNvPr id="7" name="">
             <a:extLst xmlns:a="http://schemas.openxmlformats.org/drawingml/2006/main">
               <a:ext uri="{FF2B5EF4-FFF2-40B4-BE49-F238E27FC236}">
-                <a16:creationId xmlns:a16="http://schemas.microsoft.com/office/drawing/2014/main" id="{45C897BC-075E-422C-95AD-B6B08EE52B0E}"/>
+                <a16:creationId xmlns:a16="http://schemas.microsoft.com/office/drawing/2014/main" id="{B91B2A95-0B54-4E1E-B32F-A4D4AB4575E3}"/>
               </a:ext>
             </a:extLst>
           </p:cNvPr>
@@ -2078,8 +1900,8 @@
         </p:nvSpPr>
         <p:spPr>
           <a:xfrm xmlns:a="http://schemas.openxmlformats.org/drawingml/2006/main">
-            <a:off x="6496050" y="4000500"/>
-            <a:ext cx="4895850" cy="1295400"/>
+            <a:off x="7905750" y="3333750"/>
+            <a:ext cx="3571875" cy="523875"/>
           </a:xfrm>
           <a:prstGeom xmlns:a="http://schemas.openxmlformats.org/drawingml/2006/main" prst="rect">
             <a:avLst/>
@@ -2097,12 +1919,12 @@
           <a:p xmlns:a="http://schemas.openxmlformats.org/drawingml/2006/main">
             <a:pPr>
               <a:lnSpc>
-                <a:spcPct val="118000"/>
+                <a:spcPct val="115000"/>
               </a:lnSpc>
               <a:buNone/>
-              <a:defRPr sz="2100" b="0">
-                <a:solidFill>
-                  <a:srgbClr val="17364D"/>
+              <a:defRPr sz="1875" b="0">
+                <a:solidFill>
+                  <a:srgbClr val="111111"/>
                 </a:solidFill>
                 <a:latin typeface="Liberation Sans"/>
                 <a:ea typeface="Liberation Sans"/>
@@ -2110,15 +1932,15 @@
               </a:defRPr>
             </a:pPr>
             <a:r>
-              <a:rPr sz="2100" b="0">
-                <a:solidFill>
-                  <a:srgbClr val="17364D"/>
+              <a:rPr sz="1875" b="0">
+                <a:solidFill>
+                  <a:srgbClr val="111111"/>
                 </a:solidFill>
                 <a:latin typeface="Liberation Sans"/>
                 <a:ea typeface="Liberation Sans"/>
                 <a:cs typeface="Liberation Sans"/>
               </a:rPr>
-              <a:t>Get a new answer tied to that request.</a:t>
+              <a:t>New measurement</a:t>
             </a:r>
           </a:p>
         </p:txBody>
@@ -2128,7 +1950,7 @@
           <p:cNvPr id="8" name="">
             <a:extLst xmlns:a="http://schemas.openxmlformats.org/drawingml/2006/main">
               <a:ext uri="{FF2B5EF4-FFF2-40B4-BE49-F238E27FC236}">
-                <a16:creationId xmlns:a16="http://schemas.microsoft.com/office/drawing/2014/main" id="{4DE72AA6-164A-4BBD-90F4-0CC3FE4DD242}"/>
+                <a16:creationId xmlns:a16="http://schemas.microsoft.com/office/drawing/2014/main" id="{1ACCFC56-B1FF-41D0-8ED8-A17F569AE311}"/>
               </a:ext>
             </a:extLst>
           </p:cNvPr>
@@ -2139,8 +1961,8 @@
         </p:nvSpPr>
         <p:spPr>
           <a:xfrm xmlns:a="http://schemas.openxmlformats.org/drawingml/2006/main">
-            <a:off x="685800" y="5505450"/>
-            <a:ext cx="10820400" cy="590550"/>
+            <a:off x="685800" y="4572000"/>
+            <a:ext cx="10820400" cy="619125"/>
           </a:xfrm>
           <a:prstGeom xmlns:a="http://schemas.openxmlformats.org/drawingml/2006/main" prst="rect">
             <a:avLst/>
@@ -2158,12 +1980,12 @@
           <a:p xmlns:a="http://schemas.openxmlformats.org/drawingml/2006/main">
             <a:pPr>
               <a:lnSpc>
-                <a:spcPct val="118000"/>
+                <a:spcPct val="115000"/>
               </a:lnSpc>
               <a:buNone/>
-              <a:defRPr sz="1875" b="0">
-                <a:solidFill>
-                  <a:srgbClr val="126C97"/>
+              <a:defRPr sz="2400" b="0">
+                <a:solidFill>
+                  <a:srgbClr val="111111"/>
                 </a:solidFill>
                 <a:latin typeface="Liberation Sans"/>
                 <a:ea typeface="Liberation Sans"/>
@@ -2171,15 +1993,15 @@
               </a:defRPr>
             </a:pPr>
             <a:r>
-              <a:rPr sz="1875" b="0">
-                <a:solidFill>
-                  <a:srgbClr val="126C97"/>
+              <a:rPr sz="2400" b="0">
+                <a:solidFill>
+                  <a:srgbClr val="111111"/>
                 </a:solidFill>
                 <a:latin typeface="Liberation Sans"/>
                 <a:ea typeface="Liberation Sans"/>
                 <a:cs typeface="Liberation Sans"/>
               </a:rPr>
-              <a:t>Value test: does the check replace a manual check or change a costly decision?</a:t>
+              <a:t>A signed answer returns to the buyer.</a:t>
             </a:r>
           </a:p>
         </p:txBody>
@@ -2189,7 +2011,7 @@
           <p:cNvPr id="9" name="">
             <a:extLst xmlns:a="http://schemas.openxmlformats.org/drawingml/2006/main">
               <a:ext uri="{FF2B5EF4-FFF2-40B4-BE49-F238E27FC236}">
-                <a16:creationId xmlns:a16="http://schemas.microsoft.com/office/drawing/2014/main" id="{86B2106D-EA2A-4163-AB58-A28AD8458EE3}"/>
+                <a16:creationId xmlns:a16="http://schemas.microsoft.com/office/drawing/2014/main" id="{EA8C6E58-C6AD-4C71-9E82-2566CEEFF812}"/>
               </a:ext>
             </a:extLst>
           </p:cNvPr>
@@ -2200,8 +2022,8 @@
         </p:nvSpPr>
         <p:spPr>
           <a:xfrm xmlns:a="http://schemas.openxmlformats.org/drawingml/2006/main">
-            <a:off x="685800" y="6276975"/>
-            <a:ext cx="10820400" cy="419100"/>
+            <a:off x="685800" y="5791200"/>
+            <a:ext cx="10820400" cy="571500"/>
           </a:xfrm>
           <a:prstGeom xmlns:a="http://schemas.openxmlformats.org/drawingml/2006/main" prst="rect">
             <a:avLst/>
@@ -2219,12 +2041,12 @@
           <a:p xmlns:a="http://schemas.openxmlformats.org/drawingml/2006/main">
             <a:pPr>
               <a:lnSpc>
-                <a:spcPct val="118000"/>
+                <a:spcPct val="115000"/>
               </a:lnSpc>
               <a:buNone/>
-              <a:defRPr sz="1350" b="0">
-                <a:solidFill>
-                  <a:srgbClr val="536D80"/>
+              <a:defRPr sz="1575" b="0">
+                <a:solidFill>
+                  <a:srgbClr val="555555"/>
                 </a:solidFill>
                 <a:latin typeface="Liberation Sans"/>
                 <a:ea typeface="Liberation Sans"/>
@@ -2232,15 +2054,15 @@
               </a:defRPr>
             </a:pPr>
             <a:r>
-              <a:rPr sz="1350" b="0">
-                <a:solidFill>
-                  <a:srgbClr val="536D80"/>
+              <a:rPr sz="1575" b="0">
+                <a:solidFill>
+                  <a:srgbClr val="555555"/>
                 </a:solidFill>
                 <a:latin typeface="Liberation Sans"/>
                 <a:ea typeface="Liberation Sans"/>
                 <a:cs typeface="Liberation Sans"/>
               </a:rPr>
-              <a:t>02 / Buyer and pricing remain hypotheses. An existing reliable API can be sufficient.</a:t>
+              <a:t>A common workflow across different device owners is the product hypothesis.</a:t>
             </a:r>
           </a:p>
         </p:txBody>
@@ -2248,7 +2070,7 @@
     </p:spTree>
     <p:extLst>
       <p:ext uri="{BB962C8B-B14F-4D97-AF65-F5344CB8AC3E}">
-        <p14:creationId xmlns:p14="http://schemas.microsoft.com/office/powerpoint/2010/main" val="1041157775"/>
+        <p14:creationId xmlns:p14="http://schemas.microsoft.com/office/powerpoint/2010/main" val="2126693891"/>
       </p:ext>
     </p:extLst>
   </p:cSld>
@@ -2261,7 +2083,7 @@
     <p:bg>
       <p:bgPr>
         <a:solidFill xmlns:a="http://schemas.openxmlformats.org/drawingml/2006/main">
-          <a:srgbClr val="F4FAFF"/>
+          <a:srgbClr val="FFFFFF"/>
         </a:solidFill>
       </p:bgPr>
     </p:bg>
@@ -2276,10 +2098,10 @@
       </p:grpSpPr>
       <p:sp>
         <p:nvSpPr>
-          <p:cNvPr id="11" name="">
+          <p:cNvPr id="14" name="">
             <a:extLst xmlns:a="http://schemas.openxmlformats.org/drawingml/2006/main">
               <a:ext uri="{FF2B5EF4-FFF2-40B4-BE49-F238E27FC236}">
-                <a16:creationId xmlns:a16="http://schemas.microsoft.com/office/drawing/2014/main" id="{655C990A-8EF5-4541-8653-2CB0B5F7A70C}"/>
+                <a16:creationId xmlns:a16="http://schemas.microsoft.com/office/drawing/2014/main" id="{6B93A88D-F65A-4738-9ED7-09A3B56EF016}"/>
               </a:ext>
             </a:extLst>
           </p:cNvPr>
@@ -2290,8 +2112,8 @@
         </p:nvSpPr>
         <p:spPr>
           <a:xfrm xmlns:a="http://schemas.openxmlformats.org/drawingml/2006/main">
-            <a:off x="685800" y="457200"/>
-            <a:ext cx="10820400" cy="857250"/>
+            <a:off x="685800" y="590550"/>
+            <a:ext cx="10820400" cy="1123950"/>
           </a:xfrm>
           <a:prstGeom xmlns:a="http://schemas.openxmlformats.org/drawingml/2006/main" prst="rect">
             <a:avLst/>
@@ -2309,12 +2131,12 @@
           <a:p xmlns:a="http://schemas.openxmlformats.org/drawingml/2006/main">
             <a:pPr>
               <a:lnSpc>
-                <a:spcPct val="118000"/>
+                <a:spcPct val="115000"/>
               </a:lnSpc>
               <a:buNone/>
-              <a:defRPr sz="3450" b="1">
-                <a:solidFill>
-                  <a:srgbClr val="17364D"/>
+              <a:defRPr sz="3675" b="1">
+                <a:solidFill>
+                  <a:srgbClr val="111111"/>
                 </a:solidFill>
                 <a:latin typeface="Liberation Sans"/>
                 <a:ea typeface="Liberation Sans"/>
@@ -2322,25 +2144,47 @@
               </a:defRPr>
             </a:pPr>
             <a:r>
-              <a:rPr sz="3450" b="1">
-                <a:solidFill>
-                  <a:srgbClr val="17364D"/>
+              <a:rPr sz="3675" b="1">
+                <a:solidFill>
+                  <a:srgbClr val="111111"/>
                 </a:solidFill>
                 <a:latin typeface="Liberation Sans"/>
                 <a:ea typeface="Liberation Sans"/>
                 <a:cs typeface="Liberation Sans"/>
               </a:rPr>
-              <a:t>What the prototype does</a:t>
-            </a:r>
-          </a:p>
-        </p:txBody>
-      </p:sp>
-      <p:sp>
-        <p:nvSpPr>
-          <p:cNvPr id="2" name="">
+              <a:t>A working three-device prototype</a:t>
+            </a:r>
+          </a:p>
+        </p:txBody>
+      </p:sp>
+      <p:pic>
+        <p:nvPicPr>
+          <p:cNvPr id="15" name=""/>
+          <p:cNvPicPr>
+            <a:picLocks xmlns:a="http://schemas.openxmlformats.org/drawingml/2006/main" noChangeAspect="1"/>
+          </p:cNvPicPr>
+          <p:nvPr/>
+        </p:nvPicPr>
+        <p:blipFill>
+          <a:blip xmlns:r="http://schemas.openxmlformats.org/officeDocument/2006/relationships" xmlns:a="http://schemas.openxmlformats.org/drawingml/2006/main" r:embed="Rb662421ab2fb429e"/>
+          <a:stretch xmlns:a="http://schemas.openxmlformats.org/drawingml/2006/main"/>
+        </p:blipFill>
+        <p:spPr>
+          <a:xfrm xmlns:a="http://schemas.openxmlformats.org/drawingml/2006/main">
+            <a:off x="685800" y="1878211"/>
+            <a:ext cx="3905250" cy="2196703"/>
+          </a:xfrm>
+          <a:prstGeom xmlns:a="http://schemas.openxmlformats.org/drawingml/2006/main" prst="rect">
+            <a:avLst/>
+          </a:prstGeom>
+        </p:spPr>
+      </p:pic>
+      <p:sp>
+        <p:nvSpPr>
+          <p:cNvPr id="3" name="">
             <a:extLst xmlns:a="http://schemas.openxmlformats.org/drawingml/2006/main">
               <a:ext uri="{FF2B5EF4-FFF2-40B4-BE49-F238E27FC236}">
-                <a16:creationId xmlns:a16="http://schemas.microsoft.com/office/drawing/2014/main" id="{C939EADB-D828-4CB1-815E-B164D3570066}"/>
+                <a16:creationId xmlns:a16="http://schemas.microsoft.com/office/drawing/2014/main" id="{60FE2999-A2AC-4FB0-8947-8FDDD1A4C774}"/>
               </a:ext>
             </a:extLst>
           </p:cNvPr>
@@ -2351,8 +2195,8 @@
         </p:nvSpPr>
         <p:spPr>
           <a:xfrm xmlns:a="http://schemas.openxmlformats.org/drawingml/2006/main">
-            <a:off x="685800" y="1790700"/>
-            <a:ext cx="5010150" cy="514350"/>
+            <a:off x="685800" y="4210050"/>
+            <a:ext cx="4095750" cy="762000"/>
           </a:xfrm>
           <a:prstGeom xmlns:a="http://schemas.openxmlformats.org/drawingml/2006/main" prst="rect">
             <a:avLst/>
@@ -2370,12 +2214,12 @@
           <a:p xmlns:a="http://schemas.openxmlformats.org/drawingml/2006/main">
             <a:pPr>
               <a:lnSpc>
-                <a:spcPct val="118000"/>
+                <a:spcPct val="115000"/>
               </a:lnSpc>
               <a:buNone/>
-              <a:defRPr sz="2250" b="1">
-                <a:solidFill>
-                  <a:srgbClr val="126C97"/>
+              <a:defRPr sz="1575" b="0">
+                <a:solidFill>
+                  <a:srgbClr val="555555"/>
                 </a:solidFill>
                 <a:latin typeface="Liberation Sans"/>
                 <a:ea typeface="Liberation Sans"/>
@@ -2383,25 +2227,25 @@
               </a:defRPr>
             </a:pPr>
             <a:r>
-              <a:rPr sz="2250" b="1">
-                <a:solidFill>
-                  <a:srgbClr val="126C97"/>
+              <a:rPr sz="1575" b="0">
+                <a:solidFill>
+                  <a:srgbClr val="555555"/>
                 </a:solidFill>
                 <a:latin typeface="Liberation Sans"/>
                 <a:ea typeface="Liberation Sans"/>
                 <a:cs typeface="Liberation Sans"/>
               </a:rPr>
-              <a:t>1. Request a check</a:t>
-            </a:r>
-          </a:p>
-        </p:txBody>
-      </p:sp>
-      <p:sp>
-        <p:nvSpPr>
-          <p:cNvPr id="3" name="">
+              <a:t>ESP32 contact input. BOOT represents the contact.</a:t>
+            </a:r>
+          </a:p>
+        </p:txBody>
+      </p:sp>
+      <p:sp>
+        <p:nvSpPr>
+          <p:cNvPr id="4" name="">
             <a:extLst xmlns:a="http://schemas.openxmlformats.org/drawingml/2006/main">
               <a:ext uri="{FF2B5EF4-FFF2-40B4-BE49-F238E27FC236}">
-                <a16:creationId xmlns:a16="http://schemas.microsoft.com/office/drawing/2014/main" id="{D72B06EA-86A2-4759-B497-D83D8F4BC767}"/>
+                <a16:creationId xmlns:a16="http://schemas.microsoft.com/office/drawing/2014/main" id="{EBFEC9CF-DE00-4EAA-9A69-2B0B182A0DC9}"/>
               </a:ext>
             </a:extLst>
           </p:cNvPr>
@@ -2412,8 +2256,8 @@
         </p:nvSpPr>
         <p:spPr>
           <a:xfrm xmlns:a="http://schemas.openxmlformats.org/drawingml/2006/main">
-            <a:off x="685800" y="2409825"/>
-            <a:ext cx="4953000" cy="1257300"/>
+            <a:off x="5219700" y="1838325"/>
+            <a:ext cx="6191250" cy="361950"/>
           </a:xfrm>
           <a:prstGeom xmlns:a="http://schemas.openxmlformats.org/drawingml/2006/main" prst="rect">
             <a:avLst/>
@@ -2431,12 +2275,12 @@
           <a:p xmlns:a="http://schemas.openxmlformats.org/drawingml/2006/main">
             <a:pPr>
               <a:lnSpc>
-                <a:spcPct val="118000"/>
+                <a:spcPct val="115000"/>
               </a:lnSpc>
               <a:buNone/>
-              <a:defRPr sz="2025" b="0">
-                <a:solidFill>
-                  <a:srgbClr val="17364D"/>
+              <a:defRPr sz="2025" b="1">
+                <a:solidFill>
+                  <a:srgbClr val="111111"/>
                 </a:solidFill>
                 <a:latin typeface="Liberation Sans"/>
                 <a:ea typeface="Liberation Sans"/>
@@ -2444,25 +2288,25 @@
               </a:defRPr>
             </a:pPr>
             <a:r>
-              <a:rPr sz="2025" b="0">
-                <a:solidFill>
-                  <a:srgbClr val="17364D"/>
+              <a:rPr sz="2025" b="1">
+                <a:solidFill>
+                  <a:srgbClr val="111111"/>
                 </a:solidFill>
                 <a:latin typeface="Liberation Sans"/>
                 <a:ea typeface="Liberation Sans"/>
                 <a:cs typeface="Liberation Sans"/>
               </a:rPr>
-              <a:t>The buyer fixes the contact question, device key, price, and ten-second age limit.</a:t>
-            </a:r>
-          </a:p>
-        </p:txBody>
-      </p:sp>
-      <p:sp>
-        <p:nvSpPr>
-          <p:cNvPr id="4" name="">
+              <a:t>ESP32</a:t>
+            </a:r>
+          </a:p>
+        </p:txBody>
+      </p:sp>
+      <p:sp>
+        <p:nvSpPr>
+          <p:cNvPr id="5" name="">
             <a:extLst xmlns:a="http://schemas.openxmlformats.org/drawingml/2006/main">
               <a:ext uri="{FF2B5EF4-FFF2-40B4-BE49-F238E27FC236}">
-                <a16:creationId xmlns:a16="http://schemas.microsoft.com/office/drawing/2014/main" id="{06E96C98-6CE3-4B49-A17F-92177986D982}"/>
+                <a16:creationId xmlns:a16="http://schemas.microsoft.com/office/drawing/2014/main" id="{D3C8118A-DFBE-4712-ADC8-CC89117EE287}"/>
               </a:ext>
             </a:extLst>
           </p:cNvPr>
@@ -2473,8 +2317,8 @@
         </p:nvSpPr>
         <p:spPr>
           <a:xfrm xmlns:a="http://schemas.openxmlformats.org/drawingml/2006/main">
-            <a:off x="6496050" y="1790700"/>
-            <a:ext cx="5010150" cy="514350"/>
+            <a:off x="5219700" y="2209800"/>
+            <a:ext cx="6191250" cy="466725"/>
           </a:xfrm>
           <a:prstGeom xmlns:a="http://schemas.openxmlformats.org/drawingml/2006/main" prst="rect">
             <a:avLst/>
@@ -2492,12 +2336,12 @@
           <a:p xmlns:a="http://schemas.openxmlformats.org/drawingml/2006/main">
             <a:pPr>
               <a:lnSpc>
-                <a:spcPct val="118000"/>
+                <a:spcPct val="115000"/>
               </a:lnSpc>
               <a:buNone/>
-              <a:defRPr sz="2250" b="1">
-                <a:solidFill>
-                  <a:srgbClr val="126C97"/>
+              <a:defRPr sz="2175" b="0">
+                <a:solidFill>
+                  <a:srgbClr val="111111"/>
                 </a:solidFill>
                 <a:latin typeface="Liberation Sans"/>
                 <a:ea typeface="Liberation Sans"/>
@@ -2505,25 +2349,25 @@
               </a:defRPr>
             </a:pPr>
             <a:r>
-              <a:rPr sz="2250" b="1">
-                <a:solidFill>
-                  <a:srgbClr val="126C97"/>
+              <a:rPr sz="2175" b="0">
+                <a:solidFill>
+                  <a:srgbClr val="111111"/>
                 </a:solidFill>
                 <a:latin typeface="Liberation Sans"/>
                 <a:ea typeface="Liberation Sans"/>
                 <a:cs typeface="Liberation Sans"/>
               </a:rPr>
-              <a:t>2. Pay the operator</a:t>
-            </a:r>
-          </a:p>
-        </p:txBody>
-      </p:sp>
-      <p:sp>
-        <p:nvSpPr>
-          <p:cNvPr id="5" name="">
+              <a:t>Measures and signs</a:t>
+            </a:r>
+          </a:p>
+        </p:txBody>
+      </p:sp>
+      <p:sp>
+        <p:nvSpPr>
+          <p:cNvPr id="6" name="">
             <a:extLst xmlns:a="http://schemas.openxmlformats.org/drawingml/2006/main">
               <a:ext uri="{FF2B5EF4-FFF2-40B4-BE49-F238E27FC236}">
-                <a16:creationId xmlns:a16="http://schemas.microsoft.com/office/drawing/2014/main" id="{6E227CF9-EA9A-433D-8468-51B1709D845E}"/>
+                <a16:creationId xmlns:a16="http://schemas.microsoft.com/office/drawing/2014/main" id="{E4F936DB-D85D-4A73-9FFD-D3291DB50EEE}"/>
               </a:ext>
             </a:extLst>
           </p:cNvPr>
@@ -2534,8 +2378,8 @@
         </p:nvSpPr>
         <p:spPr>
           <a:xfrm xmlns:a="http://schemas.openxmlformats.org/drawingml/2006/main">
-            <a:off x="6496050" y="2409825"/>
-            <a:ext cx="4953000" cy="1257300"/>
+            <a:off x="5219700" y="2781300"/>
+            <a:ext cx="6191250" cy="361950"/>
           </a:xfrm>
           <a:prstGeom xmlns:a="http://schemas.openxmlformats.org/drawingml/2006/main" prst="rect">
             <a:avLst/>
@@ -2553,12 +2397,12 @@
           <a:p xmlns:a="http://schemas.openxmlformats.org/drawingml/2006/main">
             <a:pPr>
               <a:lnSpc>
-                <a:spcPct val="118000"/>
+                <a:spcPct val="115000"/>
               </a:lnSpc>
               <a:buNone/>
-              <a:defRPr sz="2025" b="0">
-                <a:solidFill>
-                  <a:srgbClr val="17364D"/>
+              <a:defRPr sz="2025" b="1">
+                <a:solidFill>
+                  <a:srgbClr val="111111"/>
                 </a:solidFill>
                 <a:latin typeface="Liberation Sans"/>
                 <a:ea typeface="Liberation Sans"/>
@@ -2566,25 +2410,25 @@
               </a:defRPr>
             </a:pPr>
             <a:r>
-              <a:rPr sz="2025" b="0">
-                <a:solidFill>
-                  <a:srgbClr val="17364D"/>
+              <a:rPr sz="2025" b="1">
+                <a:solidFill>
+                  <a:srgbClr val="111111"/>
                 </a:solidFill>
                 <a:latin typeface="Liberation Sans"/>
                 <a:ea typeface="Liberation Sans"/>
                 <a:cs typeface="Liberation Sans"/>
               </a:rPr>
-              <a:t>Solana x402 settles 0.001 test USDC before measurement.</a:t>
-            </a:r>
-          </a:p>
-        </p:txBody>
-      </p:sp>
-      <p:sp>
-        <p:nvSpPr>
-          <p:cNvPr id="6" name="">
+              <a:t>Laptop</a:t>
+            </a:r>
+          </a:p>
+        </p:txBody>
+      </p:sp>
+      <p:sp>
+        <p:nvSpPr>
+          <p:cNvPr id="7" name="">
             <a:extLst xmlns:a="http://schemas.openxmlformats.org/drawingml/2006/main">
               <a:ext uri="{FF2B5EF4-FFF2-40B4-BE49-F238E27FC236}">
-                <a16:creationId xmlns:a16="http://schemas.microsoft.com/office/drawing/2014/main" id="{14545F58-6ABB-4C80-873C-E773E95D3280}"/>
+                <a16:creationId xmlns:a16="http://schemas.microsoft.com/office/drawing/2014/main" id="{2D3EECA0-3BB1-43D5-BCE3-B77975A2F35D}"/>
               </a:ext>
             </a:extLst>
           </p:cNvPr>
@@ -2595,8 +2439,8 @@
         </p:nvSpPr>
         <p:spPr>
           <a:xfrm xmlns:a="http://schemas.openxmlformats.org/drawingml/2006/main">
-            <a:off x="685800" y="3810000"/>
-            <a:ext cx="5010150" cy="514350"/>
+            <a:off x="5219700" y="3152775"/>
+            <a:ext cx="6191250" cy="466725"/>
           </a:xfrm>
           <a:prstGeom xmlns:a="http://schemas.openxmlformats.org/drawingml/2006/main" prst="rect">
             <a:avLst/>
@@ -2614,12 +2458,12 @@
           <a:p xmlns:a="http://schemas.openxmlformats.org/drawingml/2006/main">
             <a:pPr>
               <a:lnSpc>
-                <a:spcPct val="118000"/>
+                <a:spcPct val="115000"/>
               </a:lnSpc>
               <a:buNone/>
-              <a:defRPr sz="2250" b="1">
-                <a:solidFill>
-                  <a:srgbClr val="126C97"/>
+              <a:defRPr sz="2175" b="0">
+                <a:solidFill>
+                  <a:srgbClr val="111111"/>
                 </a:solidFill>
                 <a:latin typeface="Liberation Sans"/>
                 <a:ea typeface="Liberation Sans"/>
@@ -2627,25 +2471,25 @@
               </a:defRPr>
             </a:pPr>
             <a:r>
-              <a:rPr sz="2250" b="1">
-                <a:solidFill>
-                  <a:srgbClr val="126C97"/>
+              <a:rPr sz="2175" b="0">
+                <a:solidFill>
+                  <a:srgbClr val="111111"/>
                 </a:solidFill>
                 <a:latin typeface="Liberation Sans"/>
                 <a:ea typeface="Liberation Sans"/>
                 <a:cs typeface="Liberation Sans"/>
               </a:rPr>
-              <a:t>3. Measure and sign</a:t>
-            </a:r>
-          </a:p>
-        </p:txBody>
-      </p:sp>
-      <p:sp>
-        <p:nvSpPr>
-          <p:cNvPr id="7" name="">
+              <a:t>Buys a new reading</a:t>
+            </a:r>
+          </a:p>
+        </p:txBody>
+      </p:sp>
+      <p:sp>
+        <p:nvSpPr>
+          <p:cNvPr id="8" name="">
             <a:extLst xmlns:a="http://schemas.openxmlformats.org/drawingml/2006/main">
               <a:ext uri="{FF2B5EF4-FFF2-40B4-BE49-F238E27FC236}">
-                <a16:creationId xmlns:a16="http://schemas.microsoft.com/office/drawing/2014/main" id="{A79CD3BF-D331-4A21-957B-E6E3DDE77962}"/>
+                <a16:creationId xmlns:a16="http://schemas.microsoft.com/office/drawing/2014/main" id="{F8AFA449-06A4-433A-BCA0-B7EECD7012EF}"/>
               </a:ext>
             </a:extLst>
           </p:cNvPr>
@@ -2656,8 +2500,8 @@
         </p:nvSpPr>
         <p:spPr>
           <a:xfrm xmlns:a="http://schemas.openxmlformats.org/drawingml/2006/main">
-            <a:off x="685800" y="4429125"/>
-            <a:ext cx="4953000" cy="1257300"/>
+            <a:off x="5219700" y="3724275"/>
+            <a:ext cx="6191250" cy="361950"/>
           </a:xfrm>
           <a:prstGeom xmlns:a="http://schemas.openxmlformats.org/drawingml/2006/main" prst="rect">
             <a:avLst/>
@@ -2675,12 +2519,12 @@
           <a:p xmlns:a="http://schemas.openxmlformats.org/drawingml/2006/main">
             <a:pPr>
               <a:lnSpc>
-                <a:spcPct val="118000"/>
+                <a:spcPct val="115000"/>
               </a:lnSpc>
               <a:buNone/>
-              <a:defRPr sz="2025" b="0">
-                <a:solidFill>
-                  <a:srgbClr val="17364D"/>
+              <a:defRPr sz="2025" b="1">
+                <a:solidFill>
+                  <a:srgbClr val="111111"/>
                 </a:solidFill>
                 <a:latin typeface="Liberation Sans"/>
                 <a:ea typeface="Liberation Sans"/>
@@ -2688,25 +2532,25 @@
               </a:defRPr>
             </a:pPr>
             <a:r>
-              <a:rPr sz="2025" b="0">
-                <a:solidFill>
-                  <a:srgbClr val="17364D"/>
+              <a:rPr sz="2025" b="1">
+                <a:solidFill>
+                  <a:srgbClr val="111111"/>
                 </a:solidFill>
                 <a:latin typeface="Liberation Sans"/>
                 <a:ea typeface="Liberation Sans"/>
                 <a:cs typeface="Liberation Sans"/>
               </a:rPr>
-              <a:t>The ESP32 reads the physical input and signs a new answer for this request.</a:t>
-            </a:r>
-          </a:p>
-        </p:txBody>
-      </p:sp>
-      <p:sp>
-        <p:nvSpPr>
-          <p:cNvPr id="8" name="">
+              <a:t>Seeker</a:t>
+            </a:r>
+          </a:p>
+        </p:txBody>
+      </p:sp>
+      <p:sp>
+        <p:nvSpPr>
+          <p:cNvPr id="9" name="">
             <a:extLst xmlns:a="http://schemas.openxmlformats.org/drawingml/2006/main">
               <a:ext uri="{FF2B5EF4-FFF2-40B4-BE49-F238E27FC236}">
-                <a16:creationId xmlns:a16="http://schemas.microsoft.com/office/drawing/2014/main" id="{B65840EE-00C9-4E8B-8C13-4901DC69D951}"/>
+                <a16:creationId xmlns:a16="http://schemas.microsoft.com/office/drawing/2014/main" id="{932110BF-403E-453A-A8C8-D49FF69165C5}"/>
               </a:ext>
             </a:extLst>
           </p:cNvPr>
@@ -2717,8 +2561,8 @@
         </p:nvSpPr>
         <p:spPr>
           <a:xfrm xmlns:a="http://schemas.openxmlformats.org/drawingml/2006/main">
-            <a:off x="6496050" y="3810000"/>
-            <a:ext cx="5010150" cy="514350"/>
+            <a:off x="5219700" y="4095750"/>
+            <a:ext cx="6191250" cy="466725"/>
           </a:xfrm>
           <a:prstGeom xmlns:a="http://schemas.openxmlformats.org/drawingml/2006/main" prst="rect">
             <a:avLst/>
@@ -2736,12 +2580,12 @@
           <a:p xmlns:a="http://schemas.openxmlformats.org/drawingml/2006/main">
             <a:pPr>
               <a:lnSpc>
-                <a:spcPct val="118000"/>
+                <a:spcPct val="115000"/>
               </a:lnSpc>
               <a:buNone/>
-              <a:defRPr sz="2250" b="1">
-                <a:solidFill>
-                  <a:srgbClr val="126C97"/>
+              <a:defRPr sz="2175" b="0">
+                <a:solidFill>
+                  <a:srgbClr val="111111"/>
                 </a:solidFill>
                 <a:latin typeface="Liberation Sans"/>
                 <a:ea typeface="Liberation Sans"/>
@@ -2749,25 +2593,25 @@
               </a:defRPr>
             </a:pPr>
             <a:r>
-              <a:rPr sz="2250" b="1">
-                <a:solidFill>
-                  <a:srgbClr val="126C97"/>
+              <a:rPr sz="2175" b="0">
+                <a:solidFill>
+                  <a:srgbClr val="111111"/>
                 </a:solidFill>
                 <a:latin typeface="Liberation Sans"/>
                 <a:ea typeface="Liberation Sans"/>
                 <a:cs typeface="Liberation Sans"/>
               </a:rPr>
-              <a:t>4. Verify and decide</a:t>
-            </a:r>
-          </a:p>
-        </p:txBody>
-      </p:sp>
-      <p:sp>
-        <p:nvSpPr>
-          <p:cNvPr id="9" name="">
+              <a:t>Independently verifies the receipt</a:t>
+            </a:r>
+          </a:p>
+        </p:txBody>
+      </p:sp>
+      <p:sp>
+        <p:nvSpPr>
+          <p:cNvPr id="10" name="">
             <a:extLst xmlns:a="http://schemas.openxmlformats.org/drawingml/2006/main">
               <a:ext uri="{FF2B5EF4-FFF2-40B4-BE49-F238E27FC236}">
-                <a16:creationId xmlns:a16="http://schemas.microsoft.com/office/drawing/2014/main" id="{7794797A-FA9D-41A0-A69F-170A74855D43}"/>
+                <a16:creationId xmlns:a16="http://schemas.microsoft.com/office/drawing/2014/main" id="{C435BA18-3AD8-49F8-A2BE-40BB9F26A5AD}"/>
               </a:ext>
             </a:extLst>
           </p:cNvPr>
@@ -2778,8 +2622,8 @@
         </p:nvSpPr>
         <p:spPr>
           <a:xfrm xmlns:a="http://schemas.openxmlformats.org/drawingml/2006/main">
-            <a:off x="6496050" y="4429125"/>
-            <a:ext cx="4953000" cy="1257300"/>
+            <a:off x="685800" y="5381625"/>
+            <a:ext cx="5010150" cy="400050"/>
           </a:xfrm>
           <a:prstGeom xmlns:a="http://schemas.openxmlformats.org/drawingml/2006/main" prst="rect">
             <a:avLst/>
@@ -2797,12 +2641,12 @@
           <a:p xmlns:a="http://schemas.openxmlformats.org/drawingml/2006/main">
             <a:pPr>
               <a:lnSpc>
-                <a:spcPct val="118000"/>
+                <a:spcPct val="115000"/>
               </a:lnSpc>
               <a:buNone/>
-              <a:defRPr sz="2025" b="0">
-                <a:solidFill>
-                  <a:srgbClr val="17364D"/>
+              <a:defRPr sz="2100" b="1">
+                <a:solidFill>
+                  <a:srgbClr val="111111"/>
                 </a:solidFill>
                 <a:latin typeface="Liberation Sans"/>
                 <a:ea typeface="Liberation Sans"/>
@@ -2810,25 +2654,25 @@
               </a:defRPr>
             </a:pPr>
             <a:r>
-              <a:rPr sz="2025" b="0">
-                <a:solidFill>
-                  <a:srgbClr val="17364D"/>
+              <a:rPr sz="2100" b="1">
+                <a:solidFill>
+                  <a:srgbClr val="111111"/>
                 </a:solidFill>
                 <a:latin typeface="Liberation Sans"/>
                 <a:ea typeface="Liberation Sans"/>
                 <a:cs typeface="Liberation Sans"/>
               </a:rPr>
-              <a:t>The buyer verifies the source, request, signature, and age before its next action.</a:t>
-            </a:r>
-          </a:p>
-        </p:txBody>
-      </p:sp>
-      <p:sp>
-        <p:nvSpPr>
-          <p:cNvPr id="10" name="">
+              <a:t>Solana Devnet</a:t>
+            </a:r>
+          </a:p>
+        </p:txBody>
+      </p:sp>
+      <p:sp>
+        <p:nvSpPr>
+          <p:cNvPr id="11" name="">
             <a:extLst xmlns:a="http://schemas.openxmlformats.org/drawingml/2006/main">
               <a:ext uri="{FF2B5EF4-FFF2-40B4-BE49-F238E27FC236}">
-                <a16:creationId xmlns:a16="http://schemas.microsoft.com/office/drawing/2014/main" id="{25EE1B7B-F1CE-4E97-8B7C-CD6A86DCED08}"/>
+                <a16:creationId xmlns:a16="http://schemas.microsoft.com/office/drawing/2014/main" id="{2E6706D0-EFA4-42D3-9B2A-BE3012318E08}"/>
               </a:ext>
             </a:extLst>
           </p:cNvPr>
@@ -2839,8 +2683,8 @@
         </p:nvSpPr>
         <p:spPr>
           <a:xfrm xmlns:a="http://schemas.openxmlformats.org/drawingml/2006/main">
-            <a:off x="685800" y="6276975"/>
-            <a:ext cx="10820400" cy="419100"/>
+            <a:off x="685800" y="5810250"/>
+            <a:ext cx="5010150" cy="781050"/>
           </a:xfrm>
           <a:prstGeom xmlns:a="http://schemas.openxmlformats.org/drawingml/2006/main" prst="rect">
             <a:avLst/>
@@ -2858,12 +2702,12 @@
           <a:p xmlns:a="http://schemas.openxmlformats.org/drawingml/2006/main">
             <a:pPr>
               <a:lnSpc>
-                <a:spcPct val="118000"/>
+                <a:spcPct val="115000"/>
               </a:lnSpc>
               <a:buNone/>
-              <a:defRPr sz="1350" b="0">
-                <a:solidFill>
-                  <a:srgbClr val="536D80"/>
+              <a:defRPr sz="1800" b="0">
+                <a:solidFill>
+                  <a:srgbClr val="111111"/>
                 </a:solidFill>
                 <a:latin typeface="Liberation Sans"/>
                 <a:ea typeface="Liberation Sans"/>
@@ -2871,15 +2715,137 @@
               </a:defRPr>
             </a:pPr>
             <a:r>
-              <a:rPr sz="1350" b="0">
-                <a:solidFill>
-                  <a:srgbClr val="536D80"/>
+              <a:rPr sz="1800" b="0">
+                <a:solidFill>
+                  <a:srgbClr val="111111"/>
                 </a:solidFill>
                 <a:latin typeface="Liberation Sans"/>
                 <a:ea typeface="Liberation Sans"/>
                 <a:cs typeface="Liberation Sans"/>
               </a:rPr>
-              <a:t>03 / Both contact states fulfill the paid check. The operator receives test tokens.</a:t>
+              <a:t>0.001 test USDC to the operator</a:t>
+            </a:r>
+          </a:p>
+        </p:txBody>
+      </p:sp>
+      <p:sp>
+        <p:nvSpPr>
+          <p:cNvPr id="12" name="">
+            <a:extLst xmlns:a="http://schemas.openxmlformats.org/drawingml/2006/main">
+              <a:ext uri="{FF2B5EF4-FFF2-40B4-BE49-F238E27FC236}">
+                <a16:creationId xmlns:a16="http://schemas.microsoft.com/office/drawing/2014/main" id="{6697C91D-DE4B-4266-A966-8E8EC22255B4}"/>
+              </a:ext>
+            </a:extLst>
+          </p:cNvPr>
+          <p:cNvSpPr>
+            <a:spLocks xmlns:a="http://schemas.openxmlformats.org/drawingml/2006/main" noGrp="1"/>
+          </p:cNvSpPr>
+          <p:nvPr/>
+        </p:nvSpPr>
+        <p:spPr>
+          <a:xfrm xmlns:a="http://schemas.openxmlformats.org/drawingml/2006/main">
+            <a:off x="6496050" y="5381625"/>
+            <a:ext cx="5010150" cy="400050"/>
+          </a:xfrm>
+          <a:prstGeom xmlns:a="http://schemas.openxmlformats.org/drawingml/2006/main" prst="rect">
+            <a:avLst/>
+          </a:prstGeom>
+          <a:noFill xmlns:a="http://schemas.openxmlformats.org/drawingml/2006/main"/>
+          <a:ln xmlns:a="http://schemas.openxmlformats.org/drawingml/2006/main" w="0">
+            <a:noFill/>
+          </a:ln>
+        </p:spPr>
+        <p:txBody>
+          <a:bodyPr xmlns:a="http://schemas.openxmlformats.org/drawingml/2006/main" lIns="0" tIns="0" rIns="0" bIns="0" anchor="t">
+            <a:noAutofit/>
+          </a:bodyPr>
+          <a:lstStyle xmlns:a="http://schemas.openxmlformats.org/drawingml/2006/main"/>
+          <a:p xmlns:a="http://schemas.openxmlformats.org/drawingml/2006/main">
+            <a:pPr>
+              <a:lnSpc>
+                <a:spcPct val="115000"/>
+              </a:lnSpc>
+              <a:buNone/>
+              <a:defRPr sz="2100" b="1">
+                <a:solidFill>
+                  <a:srgbClr val="111111"/>
+                </a:solidFill>
+                <a:latin typeface="Liberation Sans"/>
+                <a:ea typeface="Liberation Sans"/>
+                <a:cs typeface="Liberation Sans"/>
+              </a:defRPr>
+            </a:pPr>
+            <a:r>
+              <a:rPr sz="2100" b="1">
+                <a:solidFill>
+                  <a:srgbClr val="111111"/>
+                </a:solidFill>
+                <a:latin typeface="Liberation Sans"/>
+                <a:ea typeface="Liberation Sans"/>
+                <a:cs typeface="Liberation Sans"/>
+              </a:rPr>
+              <a:t>peaq Agung</a:t>
+            </a:r>
+          </a:p>
+        </p:txBody>
+      </p:sp>
+      <p:sp>
+        <p:nvSpPr>
+          <p:cNvPr id="13" name="">
+            <a:extLst xmlns:a="http://schemas.openxmlformats.org/drawingml/2006/main">
+              <a:ext uri="{FF2B5EF4-FFF2-40B4-BE49-F238E27FC236}">
+                <a16:creationId xmlns:a16="http://schemas.microsoft.com/office/drawing/2014/main" id="{7009E01F-8162-4D20-92B9-FB0ACAE4F808}"/>
+              </a:ext>
+            </a:extLst>
+          </p:cNvPr>
+          <p:cNvSpPr>
+            <a:spLocks xmlns:a="http://schemas.openxmlformats.org/drawingml/2006/main" noGrp="1"/>
+          </p:cNvSpPr>
+          <p:nvPr/>
+        </p:nvSpPr>
+        <p:spPr>
+          <a:xfrm xmlns:a="http://schemas.openxmlformats.org/drawingml/2006/main">
+            <a:off x="6496050" y="5810250"/>
+            <a:ext cx="5010150" cy="781050"/>
+          </a:xfrm>
+          <a:prstGeom xmlns:a="http://schemas.openxmlformats.org/drawingml/2006/main" prst="rect">
+            <a:avLst/>
+          </a:prstGeom>
+          <a:noFill xmlns:a="http://schemas.openxmlformats.org/drawingml/2006/main"/>
+          <a:ln xmlns:a="http://schemas.openxmlformats.org/drawingml/2006/main" w="0">
+            <a:noFill/>
+          </a:ln>
+        </p:spPr>
+        <p:txBody>
+          <a:bodyPr xmlns:a="http://schemas.openxmlformats.org/drawingml/2006/main" lIns="0" tIns="0" rIns="0" bIns="0" anchor="t">
+            <a:noAutofit/>
+          </a:bodyPr>
+          <a:lstStyle xmlns:a="http://schemas.openxmlformats.org/drawingml/2006/main"/>
+          <a:p xmlns:a="http://schemas.openxmlformats.org/drawingml/2006/main">
+            <a:pPr>
+              <a:lnSpc>
+                <a:spcPct val="115000"/>
+              </a:lnSpc>
+              <a:buNone/>
+              <a:defRPr sz="1800" b="0">
+                <a:solidFill>
+                  <a:srgbClr val="111111"/>
+                </a:solidFill>
+                <a:latin typeface="Liberation Sans"/>
+                <a:ea typeface="Liberation Sans"/>
+                <a:cs typeface="Liberation Sans"/>
+              </a:defRPr>
+            </a:pPr>
+            <a:r>
+              <a:rPr sz="1800" b="0">
+                <a:solidFill>
+                  <a:srgbClr val="111111"/>
+                </a:solidFill>
+                <a:latin typeface="Liberation Sans"/>
+                <a:ea typeface="Liberation Sans"/>
+                <a:cs typeface="Liberation Sans"/>
+              </a:rPr>
+              <a:t>Registered device key and linked work record</a:t>
             </a:r>
           </a:p>
         </p:txBody>
@@ -2887,7 +2853,7 @@
     </p:spTree>
     <p:extLst>
       <p:ext uri="{BB962C8B-B14F-4D97-AF65-F5344CB8AC3E}">
-        <p14:creationId xmlns:p14="http://schemas.microsoft.com/office/powerpoint/2010/main" val="311761918"/>
+        <p14:creationId xmlns:p14="http://schemas.microsoft.com/office/powerpoint/2010/main" val="357328579"/>
       </p:ext>
     </p:extLst>
   </p:cSld>
@@ -2900,7 +2866,7 @@
     <p:bg>
       <p:bgPr>
         <a:solidFill xmlns:a="http://schemas.openxmlformats.org/drawingml/2006/main">
-          <a:srgbClr val="F4FAFF"/>
+          <a:srgbClr val="FFFFFF"/>
         </a:solidFill>
       </p:bgPr>
     </p:bg>
@@ -2915,10 +2881,10 @@
       </p:grpSpPr>
       <p:sp>
         <p:nvSpPr>
-          <p:cNvPr id="9" name="">
+          <p:cNvPr id="8" name="">
             <a:extLst xmlns:a="http://schemas.openxmlformats.org/drawingml/2006/main">
               <a:ext uri="{FF2B5EF4-FFF2-40B4-BE49-F238E27FC236}">
-                <a16:creationId xmlns:a16="http://schemas.microsoft.com/office/drawing/2014/main" id="{5730CC44-E194-4465-9290-4ABB54D2A04B}"/>
+                <a16:creationId xmlns:a16="http://schemas.microsoft.com/office/drawing/2014/main" id="{731457B2-1DC3-4836-8A1D-979681C611D8}"/>
               </a:ext>
             </a:extLst>
           </p:cNvPr>
@@ -2929,8 +2895,8 @@
         </p:nvSpPr>
         <p:spPr>
           <a:xfrm xmlns:a="http://schemas.openxmlformats.org/drawingml/2006/main">
-            <a:off x="685800" y="457200"/>
-            <a:ext cx="10820400" cy="857250"/>
+            <a:off x="685800" y="590550"/>
+            <a:ext cx="10820400" cy="1123950"/>
           </a:xfrm>
           <a:prstGeom xmlns:a="http://schemas.openxmlformats.org/drawingml/2006/main" prst="rect">
             <a:avLst/>
@@ -2948,12 +2914,12 @@
           <a:p xmlns:a="http://schemas.openxmlformats.org/drawingml/2006/main">
             <a:pPr>
               <a:lnSpc>
-                <a:spcPct val="118000"/>
+                <a:spcPct val="115000"/>
               </a:lnSpc>
               <a:buNone/>
-              <a:defRPr sz="3450" b="1">
-                <a:solidFill>
-                  <a:srgbClr val="17364D"/>
+              <a:defRPr sz="3675" b="1">
+                <a:solidFill>
+                  <a:srgbClr val="111111"/>
                 </a:solidFill>
                 <a:latin typeface="Liberation Sans"/>
                 <a:ea typeface="Liberation Sans"/>
@@ -2961,15 +2927,15 @@
               </a:defRPr>
             </a:pPr>
             <a:r>
-              <a:rPr sz="3450" b="1">
-                <a:solidFill>
-                  <a:srgbClr val="17364D"/>
+              <a:rPr sz="3675" b="1">
+                <a:solidFill>
+                  <a:srgbClr val="111111"/>
                 </a:solidFill>
                 <a:latin typeface="Liberation Sans"/>
                 <a:ea typeface="Liberation Sans"/>
                 <a:cs typeface="Liberation Sans"/>
               </a:rPr>
-              <a:t>The evidence has limits</a:t>
+              <a:t>Payment stays final. Answers expire.</a:t>
             </a:r>
           </a:p>
         </p:txBody>
@@ -2979,7 +2945,7 @@
           <p:cNvPr id="2" name="">
             <a:extLst xmlns:a="http://schemas.openxmlformats.org/drawingml/2006/main">
               <a:ext uri="{FF2B5EF4-FFF2-40B4-BE49-F238E27FC236}">
-                <a16:creationId xmlns:a16="http://schemas.microsoft.com/office/drawing/2014/main" id="{018CC3A7-E786-4CC1-9C69-74721A8FB110}"/>
+                <a16:creationId xmlns:a16="http://schemas.microsoft.com/office/drawing/2014/main" id="{15B3A513-AD3D-40E4-B2F8-5E794AB80444}"/>
               </a:ext>
             </a:extLst>
           </p:cNvPr>
@@ -2990,8 +2956,8 @@
         </p:nvSpPr>
         <p:spPr>
           <a:xfrm xmlns:a="http://schemas.openxmlformats.org/drawingml/2006/main">
-            <a:off x="685800" y="1809750"/>
-            <a:ext cx="5010150" cy="666750"/>
+            <a:off x="685800" y="2667000"/>
+            <a:ext cx="5010150" cy="571500"/>
           </a:xfrm>
           <a:prstGeom xmlns:a="http://schemas.openxmlformats.org/drawingml/2006/main" prst="rect">
             <a:avLst/>
@@ -3009,12 +2975,12 @@
           <a:p xmlns:a="http://schemas.openxmlformats.org/drawingml/2006/main">
             <a:pPr>
               <a:lnSpc>
-                <a:spcPct val="118000"/>
+                <a:spcPct val="115000"/>
               </a:lnSpc>
               <a:buNone/>
-              <a:defRPr sz="2175" b="1">
-                <a:solidFill>
-                  <a:srgbClr val="126C97"/>
+              <a:defRPr sz="3150" b="1">
+                <a:solidFill>
+                  <a:srgbClr val="111111"/>
                 </a:solidFill>
                 <a:latin typeface="Liberation Sans"/>
                 <a:ea typeface="Liberation Sans"/>
@@ -3022,15 +2988,15 @@
               </a:defRPr>
             </a:pPr>
             <a:r>
-              <a:rPr sz="2175" b="1">
-                <a:solidFill>
-                  <a:srgbClr val="126C97"/>
+              <a:rPr sz="3150" b="1">
+                <a:solidFill>
+                  <a:srgbClr val="111111"/>
                 </a:solidFill>
                 <a:latin typeface="Liberation Sans"/>
                 <a:ea typeface="Liberation Sans"/>
                 <a:cs typeface="Liberation Sans"/>
               </a:rPr>
-              <a:t>The buyer can verify</a:t>
+              <a:t>Payment</a:t>
             </a:r>
           </a:p>
         </p:txBody>
@@ -3040,7 +3006,7 @@
           <p:cNvPr id="3" name="">
             <a:extLst xmlns:a="http://schemas.openxmlformats.org/drawingml/2006/main">
               <a:ext uri="{FF2B5EF4-FFF2-40B4-BE49-F238E27FC236}">
-                <a16:creationId xmlns:a16="http://schemas.microsoft.com/office/drawing/2014/main" id="{92020722-7F56-4156-80C4-3AC36EA3A367}"/>
+                <a16:creationId xmlns:a16="http://schemas.microsoft.com/office/drawing/2014/main" id="{17631251-6971-49BF-B434-68942F09FEA4}"/>
               </a:ext>
             </a:extLst>
           </p:cNvPr>
@@ -3051,8 +3017,8 @@
         </p:nvSpPr>
         <p:spPr>
           <a:xfrm xmlns:a="http://schemas.openxmlformats.org/drawingml/2006/main">
-            <a:off x="685800" y="2647950"/>
-            <a:ext cx="4895850" cy="1162050"/>
+            <a:off x="685800" y="3343275"/>
+            <a:ext cx="4857750" cy="1000125"/>
           </a:xfrm>
           <a:prstGeom xmlns:a="http://schemas.openxmlformats.org/drawingml/2006/main" prst="rect">
             <a:avLst/>
@@ -3070,12 +3036,12 @@
           <a:p xmlns:a="http://schemas.openxmlformats.org/drawingml/2006/main">
             <a:pPr>
               <a:lnSpc>
-                <a:spcPct val="118000"/>
+                <a:spcPct val="115000"/>
               </a:lnSpc>
               <a:buNone/>
-              <a:defRPr sz="2100" b="0">
-                <a:solidFill>
-                  <a:srgbClr val="17364D"/>
+              <a:defRPr sz="2175" b="0">
+                <a:solidFill>
+                  <a:srgbClr val="111111"/>
                 </a:solidFill>
                 <a:latin typeface="Liberation Sans"/>
                 <a:ea typeface="Liberation Sans"/>
@@ -3083,15 +3049,15 @@
               </a:defRPr>
             </a:pPr>
             <a:r>
-              <a:rPr sz="2100" b="0">
-                <a:solidFill>
-                  <a:srgbClr val="17364D"/>
+              <a:rPr sz="2175" b="0">
+                <a:solidFill>
+                  <a:srgbClr val="111111"/>
                 </a:solidFill>
                 <a:latin typeface="Liberation Sans"/>
                 <a:ea typeface="Liberation Sans"/>
                 <a:cs typeface="Liberation Sans"/>
               </a:rPr>
-              <a:t>This approved device signed the answer to this request.</a:t>
+              <a:t>The operator keeps the test payment.</a:t>
             </a:r>
           </a:p>
         </p:txBody>
@@ -3101,7 +3067,7 @@
           <p:cNvPr id="4" name="">
             <a:extLst xmlns:a="http://schemas.openxmlformats.org/drawingml/2006/main">
               <a:ext uri="{FF2B5EF4-FFF2-40B4-BE49-F238E27FC236}">
-                <a16:creationId xmlns:a16="http://schemas.microsoft.com/office/drawing/2014/main" id="{7FD7EF97-601E-4BC5-BFBA-C95FD0DD4F74}"/>
+                <a16:creationId xmlns:a16="http://schemas.microsoft.com/office/drawing/2014/main" id="{8B64E3F7-68A9-4125-9C2F-6F574AB785CA}"/>
               </a:ext>
             </a:extLst>
           </p:cNvPr>
@@ -3112,8 +3078,8 @@
         </p:nvSpPr>
         <p:spPr>
           <a:xfrm xmlns:a="http://schemas.openxmlformats.org/drawingml/2006/main">
-            <a:off x="685800" y="4000500"/>
-            <a:ext cx="4895850" cy="1295400"/>
+            <a:off x="6496050" y="2667000"/>
+            <a:ext cx="5010150" cy="571500"/>
           </a:xfrm>
           <a:prstGeom xmlns:a="http://schemas.openxmlformats.org/drawingml/2006/main" prst="rect">
             <a:avLst/>
@@ -3131,12 +3097,12 @@
           <a:p xmlns:a="http://schemas.openxmlformats.org/drawingml/2006/main">
             <a:pPr>
               <a:lnSpc>
-                <a:spcPct val="118000"/>
+                <a:spcPct val="115000"/>
               </a:lnSpc>
               <a:buNone/>
-              <a:defRPr sz="2100" b="0">
-                <a:solidFill>
-                  <a:srgbClr val="17364D"/>
+              <a:defRPr sz="3150" b="1">
+                <a:solidFill>
+                  <a:srgbClr val="111111"/>
                 </a:solidFill>
                 <a:latin typeface="Liberation Sans"/>
                 <a:ea typeface="Liberation Sans"/>
@@ -3144,15 +3110,15 @@
               </a:defRPr>
             </a:pPr>
             <a:r>
-              <a:rPr sz="2100" b="0">
-                <a:solidFill>
-                  <a:srgbClr val="17364D"/>
+              <a:rPr sz="3150" b="1">
+                <a:solidFill>
+                  <a:srgbClr val="111111"/>
                 </a:solidFill>
                 <a:latin typeface="Liberation Sans"/>
                 <a:ea typeface="Liberation Sans"/>
                 <a:cs typeface="Liberation Sans"/>
               </a:rPr>
-              <a:t>An old answer fails the age policy. An edited answer fails signature verification.</a:t>
+              <a:t>Physical answer</a:t>
             </a:r>
           </a:p>
         </p:txBody>
@@ -3162,7 +3128,7 @@
           <p:cNvPr id="5" name="">
             <a:extLst xmlns:a="http://schemas.openxmlformats.org/drawingml/2006/main">
               <a:ext uri="{FF2B5EF4-FFF2-40B4-BE49-F238E27FC236}">
-                <a16:creationId xmlns:a16="http://schemas.microsoft.com/office/drawing/2014/main" id="{5ED12925-5371-4E4A-BD26-D76D70D24C86}"/>
+                <a16:creationId xmlns:a16="http://schemas.microsoft.com/office/drawing/2014/main" id="{082FB663-A12C-46E6-B7C5-336951FB6991}"/>
               </a:ext>
             </a:extLst>
           </p:cNvPr>
@@ -3173,8 +3139,8 @@
         </p:nvSpPr>
         <p:spPr>
           <a:xfrm xmlns:a="http://schemas.openxmlformats.org/drawingml/2006/main">
-            <a:off x="6496050" y="1809750"/>
-            <a:ext cx="5010150" cy="666750"/>
+            <a:off x="6496050" y="3343275"/>
+            <a:ext cx="4857750" cy="1000125"/>
           </a:xfrm>
           <a:prstGeom xmlns:a="http://schemas.openxmlformats.org/drawingml/2006/main" prst="rect">
             <a:avLst/>
@@ -3192,12 +3158,12 @@
           <a:p xmlns:a="http://schemas.openxmlformats.org/drawingml/2006/main">
             <a:pPr>
               <a:lnSpc>
-                <a:spcPct val="118000"/>
+                <a:spcPct val="115000"/>
               </a:lnSpc>
               <a:buNone/>
-              <a:defRPr sz="2175" b="1">
-                <a:solidFill>
-                  <a:srgbClr val="126C97"/>
+              <a:defRPr sz="2175" b="0">
+                <a:solidFill>
+                  <a:srgbClr val="111111"/>
                 </a:solidFill>
                 <a:latin typeface="Liberation Sans"/>
                 <a:ea typeface="Liberation Sans"/>
@@ -3205,15 +3171,15 @@
               </a:defRPr>
             </a:pPr>
             <a:r>
-              <a:rPr sz="2175" b="1">
-                <a:solidFill>
-                  <a:srgbClr val="126C97"/>
+              <a:rPr sz="2175" b="0">
+                <a:solidFill>
+                  <a:srgbClr val="111111"/>
                 </a:solidFill>
                 <a:latin typeface="Liberation Sans"/>
                 <a:ea typeface="Liberation Sans"/>
                 <a:cs typeface="Liberation Sans"/>
               </a:rPr>
-              <a:t>The physical demonstration</a:t>
+              <a:t>The buyer needs a new check after ten seconds.</a:t>
             </a:r>
           </a:p>
         </p:txBody>
@@ -3223,7 +3189,7 @@
           <p:cNvPr id="6" name="">
             <a:extLst xmlns:a="http://schemas.openxmlformats.org/drawingml/2006/main">
               <a:ext uri="{FF2B5EF4-FFF2-40B4-BE49-F238E27FC236}">
-                <a16:creationId xmlns:a16="http://schemas.microsoft.com/office/drawing/2014/main" id="{E1B3F251-2749-4411-92C3-6B7BB2A5A262}"/>
+                <a16:creationId xmlns:a16="http://schemas.microsoft.com/office/drawing/2014/main" id="{D0CDAC81-40C3-4C33-8737-281E3A7248AE}"/>
               </a:ext>
             </a:extLst>
           </p:cNvPr>
@@ -3234,8 +3200,8 @@
         </p:nvSpPr>
         <p:spPr>
           <a:xfrm xmlns:a="http://schemas.openxmlformats.org/drawingml/2006/main">
-            <a:off x="6496050" y="2647950"/>
-            <a:ext cx="4895850" cy="1162050"/>
+            <a:off x="685800" y="4648200"/>
+            <a:ext cx="10820400" cy="762000"/>
           </a:xfrm>
           <a:prstGeom xmlns:a="http://schemas.openxmlformats.org/drawingml/2006/main" prst="rect">
             <a:avLst/>
@@ -3253,12 +3219,12 @@
           <a:p xmlns:a="http://schemas.openxmlformats.org/drawingml/2006/main">
             <a:pPr>
               <a:lnSpc>
-                <a:spcPct val="118000"/>
+                <a:spcPct val="115000"/>
               </a:lnSpc>
               <a:buNone/>
-              <a:defRPr sz="2100" b="0">
-                <a:solidFill>
-                  <a:srgbClr val="17364D"/>
+              <a:defRPr sz="2400" b="0">
+                <a:solidFill>
+                  <a:srgbClr val="111111"/>
                 </a:solidFill>
                 <a:latin typeface="Liberation Sans"/>
                 <a:ea typeface="Liberation Sans"/>
@@ -3266,15 +3232,15 @@
               </a:defRPr>
             </a:pPr>
             <a:r>
-              <a:rPr sz="2100" b="0">
-                <a:solidFill>
-                  <a:srgbClr val="17364D"/>
+              <a:rPr sz="2400" b="0">
+                <a:solidFill>
+                  <a:srgbClr val="111111"/>
                 </a:solidFill>
                 <a:latin typeface="Liberation Sans"/>
                 <a:ea typeface="Liberation Sans"/>
                 <a:cs typeface="Liberation Sans"/>
               </a:rPr>
-              <a:t>Release or hold BOOT. The contact changes between OPEN and CLOSED.</a:t>
+              <a:t>An edited answer fails signature verification.</a:t>
             </a:r>
           </a:p>
         </p:txBody>
@@ -3284,7 +3250,7 @@
           <p:cNvPr id="7" name="">
             <a:extLst xmlns:a="http://schemas.openxmlformats.org/drawingml/2006/main">
               <a:ext uri="{FF2B5EF4-FFF2-40B4-BE49-F238E27FC236}">
-                <a16:creationId xmlns:a16="http://schemas.microsoft.com/office/drawing/2014/main" id="{83E7AB47-D984-400A-B4D2-B7CAB8DCEC84}"/>
+                <a16:creationId xmlns:a16="http://schemas.microsoft.com/office/drawing/2014/main" id="{D28E698F-3BB4-4A02-B51B-1BF48CCE2CA3}"/>
               </a:ext>
             </a:extLst>
           </p:cNvPr>
@@ -3295,8 +3261,8 @@
         </p:nvSpPr>
         <p:spPr>
           <a:xfrm xmlns:a="http://schemas.openxmlformats.org/drawingml/2006/main">
-            <a:off x="6496050" y="4000500"/>
-            <a:ext cx="4895850" cy="1295400"/>
+            <a:off x="685800" y="5791200"/>
+            <a:ext cx="10820400" cy="590550"/>
           </a:xfrm>
           <a:prstGeom xmlns:a="http://schemas.openxmlformats.org/drawingml/2006/main" prst="rect">
             <a:avLst/>
@@ -3314,12 +3280,12 @@
           <a:p xmlns:a="http://schemas.openxmlformats.org/drawingml/2006/main">
             <a:pPr>
               <a:lnSpc>
-                <a:spcPct val="118000"/>
+                <a:spcPct val="115000"/>
               </a:lnSpc>
               <a:buNone/>
-              <a:defRPr sz="2100" b="0">
-                <a:solidFill>
-                  <a:srgbClr val="17364D"/>
+              <a:defRPr sz="1575" b="0">
+                <a:solidFill>
+                  <a:srgbClr val="555555"/>
                 </a:solidFill>
                 <a:latin typeface="Liberation Sans"/>
                 <a:ea typeface="Liberation Sans"/>
@@ -3327,76 +3293,15 @@
               </a:defRPr>
             </a:pPr>
             <a:r>
-              <a:rPr sz="2100" b="0">
-                <a:solidFill>
-                  <a:srgbClr val="17364D"/>
+              <a:rPr sz="1575" b="0">
+                <a:solidFill>
+                  <a:srgbClr val="555555"/>
                 </a:solidFill>
                 <a:latin typeface="Liberation Sans"/>
                 <a:ea typeface="Liberation Sans"/>
                 <a:cs typeface="Liberation Sans"/>
               </a:rPr>
-              <a:t>The contact does not prove contents, safety, or completed work.</a:t>
-            </a:r>
-          </a:p>
-        </p:txBody>
-      </p:sp>
-      <p:sp>
-        <p:nvSpPr>
-          <p:cNvPr id="8" name="">
-            <a:extLst xmlns:a="http://schemas.openxmlformats.org/drawingml/2006/main">
-              <a:ext uri="{FF2B5EF4-FFF2-40B4-BE49-F238E27FC236}">
-                <a16:creationId xmlns:a16="http://schemas.microsoft.com/office/drawing/2014/main" id="{E21B37B1-E47D-447A-9F42-B4DE9184A511}"/>
-              </a:ext>
-            </a:extLst>
-          </p:cNvPr>
-          <p:cNvSpPr>
-            <a:spLocks xmlns:a="http://schemas.openxmlformats.org/drawingml/2006/main" noGrp="1"/>
-          </p:cNvSpPr>
-          <p:nvPr/>
-        </p:nvSpPr>
-        <p:spPr>
-          <a:xfrm xmlns:a="http://schemas.openxmlformats.org/drawingml/2006/main">
-            <a:off x="685800" y="6276975"/>
-            <a:ext cx="10820400" cy="419100"/>
-          </a:xfrm>
-          <a:prstGeom xmlns:a="http://schemas.openxmlformats.org/drawingml/2006/main" prst="rect">
-            <a:avLst/>
-          </a:prstGeom>
-          <a:noFill xmlns:a="http://schemas.openxmlformats.org/drawingml/2006/main"/>
-          <a:ln xmlns:a="http://schemas.openxmlformats.org/drawingml/2006/main" w="0">
-            <a:noFill/>
-          </a:ln>
-        </p:spPr>
-        <p:txBody>
-          <a:bodyPr xmlns:a="http://schemas.openxmlformats.org/drawingml/2006/main" lIns="0" tIns="0" rIns="0" bIns="0" anchor="t">
-            <a:noAutofit/>
-          </a:bodyPr>
-          <a:lstStyle xmlns:a="http://schemas.openxmlformats.org/drawingml/2006/main"/>
-          <a:p xmlns:a="http://schemas.openxmlformats.org/drawingml/2006/main">
-            <a:pPr>
-              <a:lnSpc>
-                <a:spcPct val="118000"/>
-              </a:lnSpc>
-              <a:buNone/>
-              <a:defRPr sz="1350" b="0">
-                <a:solidFill>
-                  <a:srgbClr val="536D80"/>
-                </a:solidFill>
-                <a:latin typeface="Liberation Sans"/>
-                <a:ea typeface="Liberation Sans"/>
-                <a:cs typeface="Liberation Sans"/>
-              </a:defRPr>
-            </a:pPr>
-            <a:r>
-              <a:rPr sz="1350" b="0">
-                <a:solidFill>
-                  <a:srgbClr val="536D80"/>
-                </a:solidFill>
-                <a:latin typeface="Liberation Sans"/>
-                <a:ea typeface="Liberation Sans"/>
-                <a:cs typeface="Liberation Sans"/>
-              </a:rPr>
-              <a:t>04 / BOOT represents a contact. This software controls no door or robot.</a:t>
+              <a:t>A signature identifies a claim's source. Physical truth needs separate controls.</a:t>
             </a:r>
           </a:p>
         </p:txBody>
@@ -3404,7 +3309,7 @@
     </p:spTree>
     <p:extLst>
       <p:ext uri="{BB962C8B-B14F-4D97-AF65-F5344CB8AC3E}">
-        <p14:creationId xmlns:p14="http://schemas.microsoft.com/office/powerpoint/2010/main" val="1579757540"/>
+        <p14:creationId xmlns:p14="http://schemas.microsoft.com/office/powerpoint/2010/main" val="727731073"/>
       </p:ext>
     </p:extLst>
   </p:cSld>
@@ -3417,7 +3322,7 @@
     <p:bg>
       <p:bgPr>
         <a:solidFill xmlns:a="http://schemas.openxmlformats.org/drawingml/2006/main">
-          <a:srgbClr val="F4FAFF"/>
+          <a:srgbClr val="FFFFFF"/>
         </a:solidFill>
       </p:bgPr>
     </p:bg>
@@ -3432,10 +3337,10 @@
       </p:grpSpPr>
       <p:sp>
         <p:nvSpPr>
-          <p:cNvPr id="10" name="">
+          <p:cNvPr id="8" name="">
             <a:extLst xmlns:a="http://schemas.openxmlformats.org/drawingml/2006/main">
               <a:ext uri="{FF2B5EF4-FFF2-40B4-BE49-F238E27FC236}">
-                <a16:creationId xmlns:a16="http://schemas.microsoft.com/office/drawing/2014/main" id="{9724F5E4-17EC-41DD-BA2B-F5158BEA951A}"/>
+                <a16:creationId xmlns:a16="http://schemas.microsoft.com/office/drawing/2014/main" id="{A0A62E7C-731B-4431-A937-EA8D87FE8199}"/>
               </a:ext>
             </a:extLst>
           </p:cNvPr>
@@ -3446,8 +3351,8 @@
         </p:nvSpPr>
         <p:spPr>
           <a:xfrm xmlns:a="http://schemas.openxmlformats.org/drawingml/2006/main">
-            <a:off x="685800" y="457200"/>
-            <a:ext cx="10820400" cy="857250"/>
+            <a:off x="685800" y="590550"/>
+            <a:ext cx="9715500" cy="1123950"/>
           </a:xfrm>
           <a:prstGeom xmlns:a="http://schemas.openxmlformats.org/drawingml/2006/main" prst="rect">
             <a:avLst/>
@@ -3465,12 +3370,12 @@
           <a:p xmlns:a="http://schemas.openxmlformats.org/drawingml/2006/main">
             <a:pPr>
               <a:lnSpc>
-                <a:spcPct val="118000"/>
+                <a:spcPct val="115000"/>
               </a:lnSpc>
               <a:buNone/>
-              <a:defRPr sz="3450" b="1">
-                <a:solidFill>
-                  <a:srgbClr val="17364D"/>
+              <a:defRPr sz="3675" b="1">
+                <a:solidFill>
+                  <a:srgbClr val="111111"/>
                 </a:solidFill>
                 <a:latin typeface="Liberation Sans"/>
                 <a:ea typeface="Liberation Sans"/>
@@ -3478,25 +3383,47 @@
               </a:defRPr>
             </a:pPr>
             <a:r>
-              <a:rPr sz="3450" b="1">
-                <a:solidFill>
-                  <a:srgbClr val="17364D"/>
+              <a:rPr sz="3675" b="1">
+                <a:solidFill>
+                  <a:srgbClr val="111111"/>
                 </a:solidFill>
                 <a:latin typeface="Liberation Sans"/>
                 <a:ea typeface="Liberation Sans"/>
                 <a:cs typeface="Liberation Sans"/>
               </a:rPr>
-              <a:t>peaq's role and the next test</a:t>
-            </a:r>
-          </a:p>
-        </p:txBody>
-      </p:sp>
-      <p:sp>
-        <p:nvSpPr>
-          <p:cNvPr id="2" name="">
+              <a:t>One useful check. Then a network.</a:t>
+            </a:r>
+          </a:p>
+        </p:txBody>
+      </p:sp>
+      <p:pic>
+        <p:nvPicPr>
+          <p:cNvPr id="9" name=""/>
+          <p:cNvPicPr>
+            <a:picLocks xmlns:a="http://schemas.openxmlformats.org/drawingml/2006/main" noChangeAspect="1"/>
+          </p:cNvPicPr>
+          <p:nvPr/>
+        </p:nvPicPr>
+        <p:blipFill>
+          <a:blip xmlns:r="http://schemas.openxmlformats.org/officeDocument/2006/relationships" xmlns:a="http://schemas.openxmlformats.org/drawingml/2006/main" r:embed="Rbeac64cf91f04a6b"/>
+          <a:stretch xmlns:a="http://schemas.openxmlformats.org/drawingml/2006/main"/>
+        </p:blipFill>
+        <p:spPr>
+          <a:xfrm xmlns:a="http://schemas.openxmlformats.org/drawingml/2006/main">
+            <a:off x="10620375" y="428625"/>
+            <a:ext cx="952500" cy="952500"/>
+          </a:xfrm>
+          <a:prstGeom xmlns:a="http://schemas.openxmlformats.org/drawingml/2006/main" prst="rect">
+            <a:avLst/>
+          </a:prstGeom>
+        </p:spPr>
+      </p:pic>
+      <p:sp>
+        <p:nvSpPr>
+          <p:cNvPr id="3" name="">
             <a:extLst xmlns:a="http://schemas.openxmlformats.org/drawingml/2006/main">
               <a:ext uri="{FF2B5EF4-FFF2-40B4-BE49-F238E27FC236}">
-                <a16:creationId xmlns:a16="http://schemas.microsoft.com/office/drawing/2014/main" id="{EDB86DF7-06DD-4D5C-9EFE-A598175D4613}"/>
+                <a16:creationId xmlns:a16="http://schemas.microsoft.com/office/drawing/2014/main" id="{00B0CF48-A0F2-4292-9DD5-2F562C57270F}"/>
               </a:ext>
             </a:extLst>
           </p:cNvPr>
@@ -3507,8 +3434,8 @@
         </p:nvSpPr>
         <p:spPr>
           <a:xfrm xmlns:a="http://schemas.openxmlformats.org/drawingml/2006/main">
-            <a:off x="685800" y="1809750"/>
-            <a:ext cx="5010150" cy="666750"/>
+            <a:off x="685800" y="2095500"/>
+            <a:ext cx="10820400" cy="762000"/>
           </a:xfrm>
           <a:prstGeom xmlns:a="http://schemas.openxmlformats.org/drawingml/2006/main" prst="rect">
             <a:avLst/>
@@ -3526,12 +3453,12 @@
           <a:p xmlns:a="http://schemas.openxmlformats.org/drawingml/2006/main">
             <a:pPr>
               <a:lnSpc>
-                <a:spcPct val="118000"/>
+                <a:spcPct val="115000"/>
               </a:lnSpc>
               <a:buNone/>
-              <a:defRPr sz="2175" b="1">
-                <a:solidFill>
-                  <a:srgbClr val="126C97"/>
+              <a:defRPr sz="3225" b="1">
+                <a:solidFill>
+                  <a:srgbClr val="111111"/>
                 </a:solidFill>
                 <a:latin typeface="Liberation Sans"/>
                 <a:ea typeface="Liberation Sans"/>
@@ -3539,25 +3466,25 @@
               </a:defRPr>
             </a:pPr>
             <a:r>
-              <a:rPr sz="2175" b="1">
-                <a:solidFill>
-                  <a:srgbClr val="126C97"/>
+              <a:rPr sz="3225" b="1">
+                <a:solidFill>
+                  <a:srgbClr val="111111"/>
                 </a:solidFill>
                 <a:latin typeface="Liberation Sans"/>
                 <a:ea typeface="Liberation Sans"/>
                 <a:cs typeface="Liberation Sans"/>
               </a:rPr>
-              <a:t>Solana: demonstrated</a:t>
-            </a:r>
-          </a:p>
-        </p:txBody>
-      </p:sp>
-      <p:sp>
-        <p:nvSpPr>
-          <p:cNvPr id="3" name="">
+              <a:t>Will a buyer pay repeatedly?</a:t>
+            </a:r>
+          </a:p>
+        </p:txBody>
+      </p:sp>
+      <p:sp>
+        <p:nvSpPr>
+          <p:cNvPr id="4" name="">
             <a:extLst xmlns:a="http://schemas.openxmlformats.org/drawingml/2006/main">
               <a:ext uri="{FF2B5EF4-FFF2-40B4-BE49-F238E27FC236}">
-                <a16:creationId xmlns:a16="http://schemas.microsoft.com/office/drawing/2014/main" id="{A2653A6F-76EB-4548-AD77-89CC759E8570}"/>
+                <a16:creationId xmlns:a16="http://schemas.microsoft.com/office/drawing/2014/main" id="{2507821C-7DFB-42E6-9668-7EBEE2FDB4CC}"/>
               </a:ext>
             </a:extLst>
           </p:cNvPr>
@@ -3568,8 +3495,8 @@
         </p:nvSpPr>
         <p:spPr>
           <a:xfrm xmlns:a="http://schemas.openxmlformats.org/drawingml/2006/main">
-            <a:off x="685800" y="2647950"/>
-            <a:ext cx="4895850" cy="1162050"/>
+            <a:off x="685800" y="3152775"/>
+            <a:ext cx="10668000" cy="876300"/>
           </a:xfrm>
           <a:prstGeom xmlns:a="http://schemas.openxmlformats.org/drawingml/2006/main" prst="rect">
             <a:avLst/>
@@ -3587,12 +3514,12 @@
           <a:p xmlns:a="http://schemas.openxmlformats.org/drawingml/2006/main">
             <a:pPr>
               <a:lnSpc>
-                <a:spcPct val="118000"/>
+                <a:spcPct val="115000"/>
               </a:lnSpc>
               <a:buNone/>
-              <a:defRPr sz="2100" b="0">
-                <a:solidFill>
-                  <a:srgbClr val="17364D"/>
+              <a:defRPr sz="2175" b="0">
+                <a:solidFill>
+                  <a:srgbClr val="111111"/>
                 </a:solidFill>
                 <a:latin typeface="Liberation Sans"/>
                 <a:ea typeface="Liberation Sans"/>
@@ -3600,25 +3527,25 @@
               </a:defRPr>
             </a:pPr>
             <a:r>
-              <a:rPr sz="2100" b="0">
-                <a:solidFill>
-                  <a:srgbClr val="17364D"/>
+              <a:rPr sz="2175" b="0">
+                <a:solidFill>
+                  <a:srgbClr val="111111"/>
                 </a:solidFill>
                 <a:latin typeface="Liberation Sans"/>
                 <a:ea typeface="Liberation Sans"/>
                 <a:cs typeface="Liberation Sans"/>
               </a:rPr>
-              <a:t>Bounded Devnet payment and an original device-signed answer.</a:t>
-            </a:r>
-          </a:p>
-        </p:txBody>
-      </p:sp>
-      <p:sp>
-        <p:nvSpPr>
-          <p:cNvPr id="4" name="">
+              <a:t>Buyer hypothesis: software teams that already pay for remote checks.</a:t>
+            </a:r>
+          </a:p>
+        </p:txBody>
+      </p:sp>
+      <p:sp>
+        <p:nvSpPr>
+          <p:cNvPr id="5" name="">
             <a:extLst xmlns:a="http://schemas.openxmlformats.org/drawingml/2006/main">
               <a:ext uri="{FF2B5EF4-FFF2-40B4-BE49-F238E27FC236}">
-                <a16:creationId xmlns:a16="http://schemas.microsoft.com/office/drawing/2014/main" id="{F4AA4F36-7F39-45F1-ABA8-E1A79CB962D8}"/>
+                <a16:creationId xmlns:a16="http://schemas.microsoft.com/office/drawing/2014/main" id="{DDA3EAA3-70C0-4ED5-8C65-4A8263B5FE4B}"/>
               </a:ext>
             </a:extLst>
           </p:cNvPr>
@@ -3629,8 +3556,8 @@
         </p:nvSpPr>
         <p:spPr>
           <a:xfrm xmlns:a="http://schemas.openxmlformats.org/drawingml/2006/main">
-            <a:off x="685800" y="4000500"/>
-            <a:ext cx="4895850" cy="1295400"/>
+            <a:off x="685800" y="4181475"/>
+            <a:ext cx="10820400" cy="619125"/>
           </a:xfrm>
           <a:prstGeom xmlns:a="http://schemas.openxmlformats.org/drawingml/2006/main" prst="rect">
             <a:avLst/>
@@ -3648,12 +3575,12 @@
           <a:p xmlns:a="http://schemas.openxmlformats.org/drawingml/2006/main">
             <a:pPr>
               <a:lnSpc>
-                <a:spcPct val="118000"/>
+                <a:spcPct val="115000"/>
               </a:lnSpc>
               <a:buNone/>
-              <a:defRPr sz="1725" b="0">
-                <a:solidFill>
-                  <a:srgbClr val="536D80"/>
+              <a:defRPr sz="2175" b="0">
+                <a:solidFill>
+                  <a:srgbClr val="111111"/>
                 </a:solidFill>
                 <a:latin typeface="Liberation Sans"/>
                 <a:ea typeface="Liberation Sans"/>
@@ -3661,25 +3588,25 @@
               </a:defRPr>
             </a:pPr>
             <a:r>
-              <a:rPr sz="1725" b="0">
-                <a:solidFill>
-                  <a:srgbClr val="536D80"/>
+              <a:rPr sz="2175" b="0">
+                <a:solidFill>
+                  <a:srgbClr val="111111"/>
                 </a:solidFill>
                 <a:latin typeface="Liberation Sans"/>
                 <a:ea typeface="Liberation Sans"/>
                 <a:cs typeface="Liberation Sans"/>
               </a:rPr>
-              <a:t>The public replay preserves the October 12 job and its original capture time.</a:t>
-            </a:r>
-          </a:p>
-        </p:txBody>
-      </p:sp>
-      <p:sp>
-        <p:nvSpPr>
-          <p:cNvPr id="5" name="">
+              <a:t>Next test: one operator and one recurring question.</a:t>
+            </a:r>
+          </a:p>
+        </p:txBody>
+      </p:sp>
+      <p:sp>
+        <p:nvSpPr>
+          <p:cNvPr id="6" name="">
             <a:extLst xmlns:a="http://schemas.openxmlformats.org/drawingml/2006/main">
               <a:ext uri="{FF2B5EF4-FFF2-40B4-BE49-F238E27FC236}">
-                <a16:creationId xmlns:a16="http://schemas.microsoft.com/office/drawing/2014/main" id="{22C798D7-7D19-415B-AC38-B83C1CE911B0}"/>
+                <a16:creationId xmlns:a16="http://schemas.microsoft.com/office/drawing/2014/main" id="{DFE4E6FE-BE33-4BF3-9D70-DF62CD7C65B1}"/>
               </a:ext>
             </a:extLst>
           </p:cNvPr>
@@ -3690,8 +3617,8 @@
         </p:nvSpPr>
         <p:spPr>
           <a:xfrm xmlns:a="http://schemas.openxmlformats.org/drawingml/2006/main">
-            <a:off x="6496050" y="1809750"/>
-            <a:ext cx="5010150" cy="666750"/>
+            <a:off x="685800" y="4933950"/>
+            <a:ext cx="10820400" cy="619125"/>
           </a:xfrm>
           <a:prstGeom xmlns:a="http://schemas.openxmlformats.org/drawingml/2006/main" prst="rect">
             <a:avLst/>
@@ -3709,12 +3636,12 @@
           <a:p xmlns:a="http://schemas.openxmlformats.org/drawingml/2006/main">
             <a:pPr>
               <a:lnSpc>
-                <a:spcPct val="118000"/>
+                <a:spcPct val="115000"/>
               </a:lnSpc>
               <a:buNone/>
-              <a:defRPr sz="2175" b="1">
-                <a:solidFill>
-                  <a:srgbClr val="126C97"/>
+              <a:defRPr sz="2175" b="0">
+                <a:solidFill>
+                  <a:srgbClr val="111111"/>
                 </a:solidFill>
                 <a:latin typeface="Liberation Sans"/>
                 <a:ea typeface="Liberation Sans"/>
@@ -3722,25 +3649,25 @@
               </a:defRPr>
             </a:pPr>
             <a:r>
-              <a:rPr sz="2175" b="1">
-                <a:solidFill>
-                  <a:srgbClr val="126C97"/>
+              <a:rPr sz="2175" b="0">
+                <a:solidFill>
+                  <a:srgbClr val="111111"/>
                 </a:solidFill>
                 <a:latin typeface="Liberation Sans"/>
                 <a:ea typeface="Liberation Sans"/>
                 <a:cs typeface="Liberation Sans"/>
               </a:rPr>
-              <a:t>peaq Agung: verified</a:t>
-            </a:r>
-          </a:p>
-        </p:txBody>
-      </p:sp>
-      <p:sp>
-        <p:nvSpPr>
-          <p:cNvPr id="6" name="">
+              <a:t>Revenue hypothesis: integration and per-check fees.</a:t>
+            </a:r>
+          </a:p>
+        </p:txBody>
+      </p:sp>
+      <p:sp>
+        <p:nvSpPr>
+          <p:cNvPr id="7" name="">
             <a:extLst xmlns:a="http://schemas.openxmlformats.org/drawingml/2006/main">
               <a:ext uri="{FF2B5EF4-FFF2-40B4-BE49-F238E27FC236}">
-                <a16:creationId xmlns:a16="http://schemas.microsoft.com/office/drawing/2014/main" id="{BA1C4157-4CC7-4145-9603-248218084465}"/>
+                <a16:creationId xmlns:a16="http://schemas.microsoft.com/office/drawing/2014/main" id="{85AA6EB4-76EF-43A6-AD4F-62663A18A756}"/>
               </a:ext>
             </a:extLst>
           </p:cNvPr>
@@ -3751,8 +3678,8 @@
         </p:nvSpPr>
         <p:spPr>
           <a:xfrm xmlns:a="http://schemas.openxmlformats.org/drawingml/2006/main">
-            <a:off x="6496050" y="2647950"/>
-            <a:ext cx="4895850" cy="1162050"/>
+            <a:off x="685800" y="5886450"/>
+            <a:ext cx="10820400" cy="523875"/>
           </a:xfrm>
           <a:prstGeom xmlns:a="http://schemas.openxmlformats.org/drawingml/2006/main" prst="rect">
             <a:avLst/>
@@ -3770,12 +3697,12 @@
           <a:p xmlns:a="http://schemas.openxmlformats.org/drawingml/2006/main">
             <a:pPr>
               <a:lnSpc>
-                <a:spcPct val="118000"/>
+                <a:spcPct val="115000"/>
               </a:lnSpc>
               <a:buNone/>
-              <a:defRPr sz="2100" b="0">
-                <a:solidFill>
-                  <a:srgbClr val="17364D"/>
+              <a:defRPr sz="1575" b="0">
+                <a:solidFill>
+                  <a:srgbClr val="555555"/>
                 </a:solidFill>
                 <a:latin typeface="Liberation Sans"/>
                 <a:ea typeface="Liberation Sans"/>
@@ -3783,198 +3710,15 @@
               </a:defRPr>
             </a:pPr>
             <a:r>
-              <a:rPr sz="2100" b="0">
-                <a:solidFill>
-                  <a:srgbClr val="17364D"/>
+              <a:rPr sz="1575" b="0">
+                <a:solidFill>
+                  <a:srgbClr val="555555"/>
                 </a:solidFill>
                 <a:latin typeface="Liberation Sans"/>
                 <a:ea typeface="Liberation Sans"/>
                 <a:cs typeface="Liberation Sans"/>
               </a:rPr>
-              <a:t>A machine identity binds the offered service to its device key.</a:t>
-            </a:r>
-          </a:p>
-        </p:txBody>
-      </p:sp>
-      <p:sp>
-        <p:nvSpPr>
-          <p:cNvPr id="7" name="">
-            <a:extLst xmlns:a="http://schemas.openxmlformats.org/drawingml/2006/main">
-              <a:ext uri="{FF2B5EF4-FFF2-40B4-BE49-F238E27FC236}">
-                <a16:creationId xmlns:a16="http://schemas.microsoft.com/office/drawing/2014/main" id="{9156A9B7-7967-436E-A82D-BF33D4F6AADE}"/>
-              </a:ext>
-            </a:extLst>
-          </p:cNvPr>
-          <p:cNvSpPr>
-            <a:spLocks xmlns:a="http://schemas.openxmlformats.org/drawingml/2006/main" noGrp="1"/>
-          </p:cNvSpPr>
-          <p:nvPr/>
-        </p:nvSpPr>
-        <p:spPr>
-          <a:xfrm xmlns:a="http://schemas.openxmlformats.org/drawingml/2006/main">
-            <a:off x="6496050" y="4000500"/>
-            <a:ext cx="4895850" cy="1295400"/>
-          </a:xfrm>
-          <a:prstGeom xmlns:a="http://schemas.openxmlformats.org/drawingml/2006/main" prst="rect">
-            <a:avLst/>
-          </a:prstGeom>
-          <a:noFill xmlns:a="http://schemas.openxmlformats.org/drawingml/2006/main"/>
-          <a:ln xmlns:a="http://schemas.openxmlformats.org/drawingml/2006/main" w="0">
-            <a:noFill/>
-          </a:ln>
-        </p:spPr>
-        <p:txBody>
-          <a:bodyPr xmlns:a="http://schemas.openxmlformats.org/drawingml/2006/main" lIns="0" tIns="0" rIns="0" bIns="0" anchor="t">
-            <a:noAutofit/>
-          </a:bodyPr>
-          <a:lstStyle xmlns:a="http://schemas.openxmlformats.org/drawingml/2006/main"/>
-          <a:p xmlns:a="http://schemas.openxmlformats.org/drawingml/2006/main">
-            <a:pPr>
-              <a:lnSpc>
-                <a:spcPct val="118000"/>
-              </a:lnSpc>
-              <a:buNone/>
-              <a:defRPr sz="2100" b="0">
-                <a:solidFill>
-                  <a:srgbClr val="17364D"/>
-                </a:solidFill>
-                <a:latin typeface="Liberation Sans"/>
-                <a:ea typeface="Liberation Sans"/>
-                <a:cs typeface="Liberation Sans"/>
-              </a:defRPr>
-            </a:pPr>
-            <a:r>
-              <a:rPr sz="2100" b="0">
-                <a:solidFill>
-                  <a:srgbClr val="17364D"/>
-                </a:solidFill>
-                <a:latin typeface="Liberation Sans"/>
-                <a:ea typeface="Liberation Sans"/>
-                <a:cs typeface="Liberation Sans"/>
-              </a:rPr>
-              <a:t>A finalized native Storage record links the unchanged job hash.</a:t>
-            </a:r>
-          </a:p>
-        </p:txBody>
-      </p:sp>
-      <p:sp>
-        <p:nvSpPr>
-          <p:cNvPr id="8" name="">
-            <a:extLst xmlns:a="http://schemas.openxmlformats.org/drawingml/2006/main">
-              <a:ext uri="{FF2B5EF4-FFF2-40B4-BE49-F238E27FC236}">
-                <a16:creationId xmlns:a16="http://schemas.microsoft.com/office/drawing/2014/main" id="{FF4D7D35-24C9-40BC-84B6-D5DE0EA65F79}"/>
-              </a:ext>
-            </a:extLst>
-          </p:cNvPr>
-          <p:cNvSpPr>
-            <a:spLocks xmlns:a="http://schemas.openxmlformats.org/drawingml/2006/main" noGrp="1"/>
-          </p:cNvSpPr>
-          <p:nvPr/>
-        </p:nvSpPr>
-        <p:spPr>
-          <a:xfrm xmlns:a="http://schemas.openxmlformats.org/drawingml/2006/main">
-            <a:off x="685800" y="5505450"/>
-            <a:ext cx="10820400" cy="590550"/>
-          </a:xfrm>
-          <a:prstGeom xmlns:a="http://schemas.openxmlformats.org/drawingml/2006/main" prst="rect">
-            <a:avLst/>
-          </a:prstGeom>
-          <a:noFill xmlns:a="http://schemas.openxmlformats.org/drawingml/2006/main"/>
-          <a:ln xmlns:a="http://schemas.openxmlformats.org/drawingml/2006/main" w="0">
-            <a:noFill/>
-          </a:ln>
-        </p:spPr>
-        <p:txBody>
-          <a:bodyPr xmlns:a="http://schemas.openxmlformats.org/drawingml/2006/main" lIns="0" tIns="0" rIns="0" bIns="0" anchor="t">
-            <a:noAutofit/>
-          </a:bodyPr>
-          <a:lstStyle xmlns:a="http://schemas.openxmlformats.org/drawingml/2006/main"/>
-          <a:p xmlns:a="http://schemas.openxmlformats.org/drawingml/2006/main">
-            <a:pPr>
-              <a:lnSpc>
-                <a:spcPct val="118000"/>
-              </a:lnSpc>
-              <a:buNone/>
-              <a:defRPr sz="1875" b="0">
-                <a:solidFill>
-                  <a:srgbClr val="126C97"/>
-                </a:solidFill>
-                <a:latin typeface="Liberation Sans"/>
-                <a:ea typeface="Liberation Sans"/>
-                <a:cs typeface="Liberation Sans"/>
-              </a:defRPr>
-            </a:pPr>
-            <a:r>
-              <a:rPr sz="1875" b="0">
-                <a:solidFill>
-                  <a:srgbClr val="126C97"/>
-                </a:solidFill>
-                <a:latin typeface="Liberation Sans"/>
-                <a:ea typeface="Liberation Sans"/>
-                <a:cs typeface="Liberation Sans"/>
-              </a:rPr>
-              <a:t>Next: one authorized operator, one repeated question, and a comparison with its current process.</a:t>
-            </a:r>
-          </a:p>
-        </p:txBody>
-      </p:sp>
-      <p:sp>
-        <p:nvSpPr>
-          <p:cNvPr id="9" name="">
-            <a:extLst xmlns:a="http://schemas.openxmlformats.org/drawingml/2006/main">
-              <a:ext uri="{FF2B5EF4-FFF2-40B4-BE49-F238E27FC236}">
-                <a16:creationId xmlns:a16="http://schemas.microsoft.com/office/drawing/2014/main" id="{DCECA491-FDD6-4553-AB75-D5580F727B6B}"/>
-              </a:ext>
-            </a:extLst>
-          </p:cNvPr>
-          <p:cNvSpPr>
-            <a:spLocks xmlns:a="http://schemas.openxmlformats.org/drawingml/2006/main" noGrp="1"/>
-          </p:cNvSpPr>
-          <p:nvPr/>
-        </p:nvSpPr>
-        <p:spPr>
-          <a:xfrm xmlns:a="http://schemas.openxmlformats.org/drawingml/2006/main">
-            <a:off x="685800" y="6276975"/>
-            <a:ext cx="10820400" cy="419100"/>
-          </a:xfrm>
-          <a:prstGeom xmlns:a="http://schemas.openxmlformats.org/drawingml/2006/main" prst="rect">
-            <a:avLst/>
-          </a:prstGeom>
-          <a:noFill xmlns:a="http://schemas.openxmlformats.org/drawingml/2006/main"/>
-          <a:ln xmlns:a="http://schemas.openxmlformats.org/drawingml/2006/main" w="0">
-            <a:noFill/>
-          </a:ln>
-        </p:spPr>
-        <p:txBody>
-          <a:bodyPr xmlns:a="http://schemas.openxmlformats.org/drawingml/2006/main" lIns="0" tIns="0" rIns="0" bIns="0" anchor="t">
-            <a:noAutofit/>
-          </a:bodyPr>
-          <a:lstStyle xmlns:a="http://schemas.openxmlformats.org/drawingml/2006/main"/>
-          <a:p xmlns:a="http://schemas.openxmlformats.org/drawingml/2006/main">
-            <a:pPr>
-              <a:lnSpc>
-                <a:spcPct val="118000"/>
-              </a:lnSpc>
-              <a:buNone/>
-              <a:defRPr sz="1350" b="0">
-                <a:solidFill>
-                  <a:srgbClr val="536D80"/>
-                </a:solidFill>
-                <a:latin typeface="Liberation Sans"/>
-                <a:ea typeface="Liberation Sans"/>
-                <a:cs typeface="Liberation Sans"/>
-              </a:defRPr>
-            </a:pPr>
-            <a:r>
-              <a:rPr sz="1350" b="0">
-                <a:solidFill>
-                  <a:srgbClr val="536D80"/>
-                </a:solidFill>
-                <a:latin typeface="Liberation Sans"/>
-                <a:ea typeface="Liberation Sans"/>
-                <a:cs typeface="Liberation Sans"/>
-              </a:rPr>
-              <a:t>05 / Real Agung identity and Storage readbacks. Customer demand remains unvalidated.</a:t>
+              <a:t>The network, customer demand, and reputation remain unvalidated.</a:t>
             </a:r>
           </a:p>
         </p:txBody>
@@ -3982,7 +3726,7 @@
     </p:spTree>
     <p:extLst>
       <p:ext uri="{BB962C8B-B14F-4D97-AF65-F5344CB8AC3E}">
-        <p14:creationId xmlns:p14="http://schemas.microsoft.com/office/powerpoint/2010/main" val="398696374"/>
+        <p14:creationId xmlns:p14="http://schemas.microsoft.com/office/powerpoint/2010/main" val="139742060"/>
       </p:ext>
     </p:extLst>
   </p:cSld>

</xml_diff>

<commit_message>
docs: publish the final words and current recording limits
</commit_message>
<xml_diff>
--- a/competition/fieldproof-pitch.pptx
+++ b/competition/fieldproof-pitch.pptx
@@ -2,17 +2,17 @@
 <file path=ppt/presentation.xml><?xml version="1.0" encoding="utf-8"?>
 <p:presentation xmlns:p="http://schemas.openxmlformats.org/presentationml/2006/main">
   <p:sldMasterIdLst>
-    <p:sldMasterId xmlns:r="http://schemas.openxmlformats.org/officeDocument/2006/relationships" id="2147483648" r:id="Rad932027e67345d1"/>
+    <p:sldMasterId xmlns:r="http://schemas.openxmlformats.org/officeDocument/2006/relationships" id="2147483648" r:id="R0e8842d58eec4758"/>
   </p:sldMasterIdLst>
   <p:notesMasterIdLst>
-    <p:notesMasterId xmlns:r="http://schemas.openxmlformats.org/officeDocument/2006/relationships" r:id="R9717f12da3ed4360"/>
+    <p:notesMasterId xmlns:r="http://schemas.openxmlformats.org/officeDocument/2006/relationships" r:id="R4a991b03d9124940"/>
   </p:notesMasterIdLst>
   <p:sldIdLst>
-    <p:sldId xmlns:r="http://schemas.openxmlformats.org/officeDocument/2006/relationships" id="256" r:id="Ree86c22933ad40f2"/>
-    <p:sldId xmlns:r="http://schemas.openxmlformats.org/officeDocument/2006/relationships" id="257" r:id="R3c0cdab536b44258"/>
-    <p:sldId xmlns:r="http://schemas.openxmlformats.org/officeDocument/2006/relationships" id="258" r:id="Rf269fe350e0442bb"/>
-    <p:sldId xmlns:r="http://schemas.openxmlformats.org/officeDocument/2006/relationships" id="259" r:id="Read9203d2f5443ac"/>
-    <p:sldId xmlns:r="http://schemas.openxmlformats.org/officeDocument/2006/relationships" id="260" r:id="Rff1a3ccf8c0f472f"/>
+    <p:sldId xmlns:r="http://schemas.openxmlformats.org/officeDocument/2006/relationships" id="256" r:id="R6c8d6ff344bf4c0f"/>
+    <p:sldId xmlns:r="http://schemas.openxmlformats.org/officeDocument/2006/relationships" id="257" r:id="R6cbdf384c86241c3"/>
+    <p:sldId xmlns:r="http://schemas.openxmlformats.org/officeDocument/2006/relationships" id="258" r:id="R851a0ad753d943ac"/>
+    <p:sldId xmlns:r="http://schemas.openxmlformats.org/officeDocument/2006/relationships" id="259" r:id="R1759c4a77057461e"/>
+    <p:sldId xmlns:r="http://schemas.openxmlformats.org/officeDocument/2006/relationships" id="260" r:id="R8dcb748fa1ab4d5e"/>
   </p:sldIdLst>
   <p:sldSz cx="12192000" cy="6858000"/>
   <p:notesSz cx="6858000" cy="9144000"/>
@@ -794,7 +794,7 @@
   </p:cSld>
   <p:clrMap bg1="lt1" tx1="dk1" bg2="lt2" tx2="dk2" accent1="accent1" accent2="accent2" accent3="accent3" accent4="accent4" accent5="accent5" accent6="accent6" hlink="hlink" folHlink="folHlink"/>
   <p:sldLayoutIdLst>
-    <p:sldLayoutId xmlns:r="http://schemas.openxmlformats.org/officeDocument/2006/relationships" id="2147483649" r:id="Rdf191859f87f4955"/>
+    <p:sldLayoutId xmlns:r="http://schemas.openxmlformats.org/officeDocument/2006/relationships" id="2147483649" r:id="R3ea2c05650e04666"/>
   </p:sldLayoutIdLst>
   <p:txStyles>
     <p:titleStyle>
@@ -1345,7 +1345,7 @@
           <p:cNvPr id="3" name="">
             <a:extLst xmlns:a="http://schemas.openxmlformats.org/drawingml/2006/main">
               <a:ext uri="{FF2B5EF4-FFF2-40B4-BE49-F238E27FC236}">
-                <a16:creationId xmlns:a16="http://schemas.microsoft.com/office/drawing/2014/main" id="{CADA974E-C978-43D5-936E-8D128C594A3D}"/>
+                <a16:creationId xmlns:a16="http://schemas.microsoft.com/office/drawing/2014/main" id="{6A1119C0-88C4-4A5B-A6BA-B63116203E57}"/>
               </a:ext>
             </a:extLst>
           </p:cNvPr>
@@ -1406,7 +1406,7 @@
           <p:cNvPr id="2" name="">
             <a:extLst xmlns:a="http://schemas.openxmlformats.org/drawingml/2006/main">
               <a:ext uri="{FF2B5EF4-FFF2-40B4-BE49-F238E27FC236}">
-                <a16:creationId xmlns:a16="http://schemas.microsoft.com/office/drawing/2014/main" id="{8179D66A-471E-4F32-9AE0-03E057D0DE4E}"/>
+                <a16:creationId xmlns:a16="http://schemas.microsoft.com/office/drawing/2014/main" id="{79A8803F-D5C7-4C9E-81B2-2A983C1CE8EA}"/>
               </a:ext>
             </a:extLst>
           </p:cNvPr>
@@ -1492,7 +1492,7 @@
     </p:spTree>
     <p:extLst>
       <p:ext uri="{BB962C8B-B14F-4D97-AF65-F5344CB8AC3E}">
-        <p14:creationId xmlns:p14="http://schemas.microsoft.com/office/powerpoint/2010/main" val="171500543"/>
+        <p14:creationId xmlns:p14="http://schemas.microsoft.com/office/powerpoint/2010/main" val="65740343"/>
       </p:ext>
     </p:extLst>
   </p:cSld>
@@ -1523,7 +1523,7 @@
           <p:cNvPr id="10" name="">
             <a:extLst xmlns:a="http://schemas.openxmlformats.org/drawingml/2006/main">
               <a:ext uri="{FF2B5EF4-FFF2-40B4-BE49-F238E27FC236}">
-                <a16:creationId xmlns:a16="http://schemas.microsoft.com/office/drawing/2014/main" id="{1EFE8D5C-0C7A-4EDB-9B68-CADBC315AEED}"/>
+                <a16:creationId xmlns:a16="http://schemas.microsoft.com/office/drawing/2014/main" id="{2FA673ED-792E-4A67-851B-46686A73794B}"/>
               </a:ext>
             </a:extLst>
           </p:cNvPr>
@@ -1584,7 +1584,7 @@
           <p:cNvPr id="2" name="">
             <a:extLst xmlns:a="http://schemas.openxmlformats.org/drawingml/2006/main">
               <a:ext uri="{FF2B5EF4-FFF2-40B4-BE49-F238E27FC236}">
-                <a16:creationId xmlns:a16="http://schemas.microsoft.com/office/drawing/2014/main" id="{8FAC85EC-D51B-47F2-B449-DF69AFD70E3C}"/>
+                <a16:creationId xmlns:a16="http://schemas.microsoft.com/office/drawing/2014/main" id="{921D1066-FB80-4508-9148-3932BCAC5922}"/>
               </a:ext>
             </a:extLst>
           </p:cNvPr>
@@ -1645,7 +1645,7 @@
           <p:cNvPr id="3" name="">
             <a:extLst xmlns:a="http://schemas.openxmlformats.org/drawingml/2006/main">
               <a:ext uri="{FF2B5EF4-FFF2-40B4-BE49-F238E27FC236}">
-                <a16:creationId xmlns:a16="http://schemas.microsoft.com/office/drawing/2014/main" id="{45DBA91D-C6E1-4188-A6C5-9283E1510A9A}"/>
+                <a16:creationId xmlns:a16="http://schemas.microsoft.com/office/drawing/2014/main" id="{65C8DBD0-58DA-4B9B-95AB-CF89364B77CF}"/>
               </a:ext>
             </a:extLst>
           </p:cNvPr>
@@ -1706,7 +1706,7 @@
           <p:cNvPr id="4" name="">
             <a:extLst xmlns:a="http://schemas.openxmlformats.org/drawingml/2006/main">
               <a:ext uri="{FF2B5EF4-FFF2-40B4-BE49-F238E27FC236}">
-                <a16:creationId xmlns:a16="http://schemas.microsoft.com/office/drawing/2014/main" id="{3D3F6296-40C3-4A78-85A0-D543495038C1}"/>
+                <a16:creationId xmlns:a16="http://schemas.microsoft.com/office/drawing/2014/main" id="{9BBD911E-7711-4F63-AB84-D315F603B597}"/>
               </a:ext>
             </a:extLst>
           </p:cNvPr>
@@ -1767,7 +1767,7 @@
           <p:cNvPr id="5" name="">
             <a:extLst xmlns:a="http://schemas.openxmlformats.org/drawingml/2006/main">
               <a:ext uri="{FF2B5EF4-FFF2-40B4-BE49-F238E27FC236}">
-                <a16:creationId xmlns:a16="http://schemas.microsoft.com/office/drawing/2014/main" id="{22339FCC-93E6-4378-8676-FED173C3A20D}"/>
+                <a16:creationId xmlns:a16="http://schemas.microsoft.com/office/drawing/2014/main" id="{1E7C93EA-4908-4C2B-B0AF-3FFDDBECA2BF}"/>
               </a:ext>
             </a:extLst>
           </p:cNvPr>
@@ -1828,7 +1828,7 @@
           <p:cNvPr id="6" name="">
             <a:extLst xmlns:a="http://schemas.openxmlformats.org/drawingml/2006/main">
               <a:ext uri="{FF2B5EF4-FFF2-40B4-BE49-F238E27FC236}">
-                <a16:creationId xmlns:a16="http://schemas.microsoft.com/office/drawing/2014/main" id="{981B916E-0263-46DB-9400-8E8859C10A23}"/>
+                <a16:creationId xmlns:a16="http://schemas.microsoft.com/office/drawing/2014/main" id="{F34C0989-70C6-4225-BBD7-482A32E96058}"/>
               </a:ext>
             </a:extLst>
           </p:cNvPr>
@@ -1889,7 +1889,7 @@
           <p:cNvPr id="7" name="">
             <a:extLst xmlns:a="http://schemas.openxmlformats.org/drawingml/2006/main">
               <a:ext uri="{FF2B5EF4-FFF2-40B4-BE49-F238E27FC236}">
-                <a16:creationId xmlns:a16="http://schemas.microsoft.com/office/drawing/2014/main" id="{B91B2A95-0B54-4E1E-B32F-A4D4AB4575E3}"/>
+                <a16:creationId xmlns:a16="http://schemas.microsoft.com/office/drawing/2014/main" id="{CAFC9349-4599-497C-A995-6F5ED724CA2F}"/>
               </a:ext>
             </a:extLst>
           </p:cNvPr>
@@ -1950,7 +1950,7 @@
           <p:cNvPr id="8" name="">
             <a:extLst xmlns:a="http://schemas.openxmlformats.org/drawingml/2006/main">
               <a:ext uri="{FF2B5EF4-FFF2-40B4-BE49-F238E27FC236}">
-                <a16:creationId xmlns:a16="http://schemas.microsoft.com/office/drawing/2014/main" id="{1ACCFC56-B1FF-41D0-8ED8-A17F569AE311}"/>
+                <a16:creationId xmlns:a16="http://schemas.microsoft.com/office/drawing/2014/main" id="{707DBDA2-B70C-4773-B404-0E1A6F290C53}"/>
               </a:ext>
             </a:extLst>
           </p:cNvPr>
@@ -2011,7 +2011,7 @@
           <p:cNvPr id="9" name="">
             <a:extLst xmlns:a="http://schemas.openxmlformats.org/drawingml/2006/main">
               <a:ext uri="{FF2B5EF4-FFF2-40B4-BE49-F238E27FC236}">
-                <a16:creationId xmlns:a16="http://schemas.microsoft.com/office/drawing/2014/main" id="{EA8C6E58-C6AD-4C71-9E82-2566CEEFF812}"/>
+                <a16:creationId xmlns:a16="http://schemas.microsoft.com/office/drawing/2014/main" id="{5F541F41-0226-4554-AAE6-5787E42D9BB0}"/>
               </a:ext>
             </a:extLst>
           </p:cNvPr>
@@ -2062,7 +2062,7 @@
                 <a:ea typeface="Liberation Sans"/>
                 <a:cs typeface="Liberation Sans"/>
               </a:rPr>
-              <a:t>A common workflow across different device owners is the product hypothesis.</a:t>
+              <a:t>One paid check connects a software buyer and a device operator.</a:t>
             </a:r>
           </a:p>
         </p:txBody>
@@ -2070,7 +2070,7 @@
     </p:spTree>
     <p:extLst>
       <p:ext uri="{BB962C8B-B14F-4D97-AF65-F5344CB8AC3E}">
-        <p14:creationId xmlns:p14="http://schemas.microsoft.com/office/powerpoint/2010/main" val="2126693891"/>
+        <p14:creationId xmlns:p14="http://schemas.microsoft.com/office/powerpoint/2010/main" val="87196875"/>
       </p:ext>
     </p:extLst>
   </p:cSld>
@@ -2101,7 +2101,7 @@
           <p:cNvPr id="14" name="">
             <a:extLst xmlns:a="http://schemas.openxmlformats.org/drawingml/2006/main">
               <a:ext uri="{FF2B5EF4-FFF2-40B4-BE49-F238E27FC236}">
-                <a16:creationId xmlns:a16="http://schemas.microsoft.com/office/drawing/2014/main" id="{6B93A88D-F65A-4738-9ED7-09A3B56EF016}"/>
+                <a16:creationId xmlns:a16="http://schemas.microsoft.com/office/drawing/2014/main" id="{E656367C-E13E-4EA8-BC88-C1E17064C633}"/>
               </a:ext>
             </a:extLst>
           </p:cNvPr>
@@ -2166,7 +2166,7 @@
           <p:nvPr/>
         </p:nvPicPr>
         <p:blipFill>
-          <a:blip xmlns:r="http://schemas.openxmlformats.org/officeDocument/2006/relationships" xmlns:a="http://schemas.openxmlformats.org/drawingml/2006/main" r:embed="Rb662421ab2fb429e"/>
+          <a:blip xmlns:r="http://schemas.openxmlformats.org/officeDocument/2006/relationships" xmlns:a="http://schemas.openxmlformats.org/drawingml/2006/main" r:embed="R6a754d9efe3d4ae5"/>
           <a:stretch xmlns:a="http://schemas.openxmlformats.org/drawingml/2006/main"/>
         </p:blipFill>
         <p:spPr>
@@ -2184,7 +2184,7 @@
           <p:cNvPr id="3" name="">
             <a:extLst xmlns:a="http://schemas.openxmlformats.org/drawingml/2006/main">
               <a:ext uri="{FF2B5EF4-FFF2-40B4-BE49-F238E27FC236}">
-                <a16:creationId xmlns:a16="http://schemas.microsoft.com/office/drawing/2014/main" id="{60FE2999-A2AC-4FB0-8947-8FDDD1A4C774}"/>
+                <a16:creationId xmlns:a16="http://schemas.microsoft.com/office/drawing/2014/main" id="{6EC38F7F-0A95-4B98-A2F7-CE8455A847A8}"/>
               </a:ext>
             </a:extLst>
           </p:cNvPr>
@@ -2245,7 +2245,7 @@
           <p:cNvPr id="4" name="">
             <a:extLst xmlns:a="http://schemas.openxmlformats.org/drawingml/2006/main">
               <a:ext uri="{FF2B5EF4-FFF2-40B4-BE49-F238E27FC236}">
-                <a16:creationId xmlns:a16="http://schemas.microsoft.com/office/drawing/2014/main" id="{EBFEC9CF-DE00-4EAA-9A69-2B0B182A0DC9}"/>
+                <a16:creationId xmlns:a16="http://schemas.microsoft.com/office/drawing/2014/main" id="{39008448-9EA9-41D8-89E3-4070E339CB63}"/>
               </a:ext>
             </a:extLst>
           </p:cNvPr>
@@ -2306,7 +2306,7 @@
           <p:cNvPr id="5" name="">
             <a:extLst xmlns:a="http://schemas.openxmlformats.org/drawingml/2006/main">
               <a:ext uri="{FF2B5EF4-FFF2-40B4-BE49-F238E27FC236}">
-                <a16:creationId xmlns:a16="http://schemas.microsoft.com/office/drawing/2014/main" id="{D3C8118A-DFBE-4712-ADC8-CC89117EE287}"/>
+                <a16:creationId xmlns:a16="http://schemas.microsoft.com/office/drawing/2014/main" id="{1AE21889-BFF6-4CB6-AA86-91485D3CD9EE}"/>
               </a:ext>
             </a:extLst>
           </p:cNvPr>
@@ -2367,7 +2367,7 @@
           <p:cNvPr id="6" name="">
             <a:extLst xmlns:a="http://schemas.openxmlformats.org/drawingml/2006/main">
               <a:ext uri="{FF2B5EF4-FFF2-40B4-BE49-F238E27FC236}">
-                <a16:creationId xmlns:a16="http://schemas.microsoft.com/office/drawing/2014/main" id="{E4F936DB-D85D-4A73-9FFD-D3291DB50EEE}"/>
+                <a16:creationId xmlns:a16="http://schemas.microsoft.com/office/drawing/2014/main" id="{947648D7-5A07-475F-AC1E-F803D5245BE6}"/>
               </a:ext>
             </a:extLst>
           </p:cNvPr>
@@ -2428,7 +2428,7 @@
           <p:cNvPr id="7" name="">
             <a:extLst xmlns:a="http://schemas.openxmlformats.org/drawingml/2006/main">
               <a:ext uri="{FF2B5EF4-FFF2-40B4-BE49-F238E27FC236}">
-                <a16:creationId xmlns:a16="http://schemas.microsoft.com/office/drawing/2014/main" id="{2D3EECA0-3BB1-43D5-BCE3-B77975A2F35D}"/>
+                <a16:creationId xmlns:a16="http://schemas.microsoft.com/office/drawing/2014/main" id="{93BF8CD9-84A9-48F8-8887-C43507BDEFE4}"/>
               </a:ext>
             </a:extLst>
           </p:cNvPr>
@@ -2489,7 +2489,7 @@
           <p:cNvPr id="8" name="">
             <a:extLst xmlns:a="http://schemas.openxmlformats.org/drawingml/2006/main">
               <a:ext uri="{FF2B5EF4-FFF2-40B4-BE49-F238E27FC236}">
-                <a16:creationId xmlns:a16="http://schemas.microsoft.com/office/drawing/2014/main" id="{F8AFA449-06A4-433A-BCA0-B7EECD7012EF}"/>
+                <a16:creationId xmlns:a16="http://schemas.microsoft.com/office/drawing/2014/main" id="{66F13258-7C00-4D98-9ECB-2779D3F8992B}"/>
               </a:ext>
             </a:extLst>
           </p:cNvPr>
@@ -2550,7 +2550,7 @@
           <p:cNvPr id="9" name="">
             <a:extLst xmlns:a="http://schemas.openxmlformats.org/drawingml/2006/main">
               <a:ext uri="{FF2B5EF4-FFF2-40B4-BE49-F238E27FC236}">
-                <a16:creationId xmlns:a16="http://schemas.microsoft.com/office/drawing/2014/main" id="{932110BF-403E-453A-A8C8-D49FF69165C5}"/>
+                <a16:creationId xmlns:a16="http://schemas.microsoft.com/office/drawing/2014/main" id="{ECA99593-78C7-47BF-8ADB-90DE54EFC271}"/>
               </a:ext>
             </a:extLst>
           </p:cNvPr>
@@ -2611,7 +2611,7 @@
           <p:cNvPr id="10" name="">
             <a:extLst xmlns:a="http://schemas.openxmlformats.org/drawingml/2006/main">
               <a:ext uri="{FF2B5EF4-FFF2-40B4-BE49-F238E27FC236}">
-                <a16:creationId xmlns:a16="http://schemas.microsoft.com/office/drawing/2014/main" id="{C435BA18-3AD8-49F8-A2BE-40BB9F26A5AD}"/>
+                <a16:creationId xmlns:a16="http://schemas.microsoft.com/office/drawing/2014/main" id="{3581DF4B-D162-4402-8376-F1CCF3694D4C}"/>
               </a:ext>
             </a:extLst>
           </p:cNvPr>
@@ -2672,7 +2672,7 @@
           <p:cNvPr id="11" name="">
             <a:extLst xmlns:a="http://schemas.openxmlformats.org/drawingml/2006/main">
               <a:ext uri="{FF2B5EF4-FFF2-40B4-BE49-F238E27FC236}">
-                <a16:creationId xmlns:a16="http://schemas.microsoft.com/office/drawing/2014/main" id="{2E6706D0-EFA4-42D3-9B2A-BE3012318E08}"/>
+                <a16:creationId xmlns:a16="http://schemas.microsoft.com/office/drawing/2014/main" id="{345BE1FD-A5B8-4A87-BB61-C8EA2DA306C0}"/>
               </a:ext>
             </a:extLst>
           </p:cNvPr>
@@ -2733,7 +2733,7 @@
           <p:cNvPr id="12" name="">
             <a:extLst xmlns:a="http://schemas.openxmlformats.org/drawingml/2006/main">
               <a:ext uri="{FF2B5EF4-FFF2-40B4-BE49-F238E27FC236}">
-                <a16:creationId xmlns:a16="http://schemas.microsoft.com/office/drawing/2014/main" id="{6697C91D-DE4B-4266-A966-8E8EC22255B4}"/>
+                <a16:creationId xmlns:a16="http://schemas.microsoft.com/office/drawing/2014/main" id="{E164917E-2A2A-49CC-A492-9185BCD2ADEE}"/>
               </a:ext>
             </a:extLst>
           </p:cNvPr>
@@ -2794,7 +2794,7 @@
           <p:cNvPr id="13" name="">
             <a:extLst xmlns:a="http://schemas.openxmlformats.org/drawingml/2006/main">
               <a:ext uri="{FF2B5EF4-FFF2-40B4-BE49-F238E27FC236}">
-                <a16:creationId xmlns:a16="http://schemas.microsoft.com/office/drawing/2014/main" id="{7009E01F-8162-4D20-92B9-FB0ACAE4F808}"/>
+                <a16:creationId xmlns:a16="http://schemas.microsoft.com/office/drawing/2014/main" id="{57C679CA-B587-442C-BFE6-C47B54FF6C9B}"/>
               </a:ext>
             </a:extLst>
           </p:cNvPr>
@@ -2853,7 +2853,7 @@
     </p:spTree>
     <p:extLst>
       <p:ext uri="{BB962C8B-B14F-4D97-AF65-F5344CB8AC3E}">
-        <p14:creationId xmlns:p14="http://schemas.microsoft.com/office/powerpoint/2010/main" val="357328579"/>
+        <p14:creationId xmlns:p14="http://schemas.microsoft.com/office/powerpoint/2010/main" val="1484323260"/>
       </p:ext>
     </p:extLst>
   </p:cSld>
@@ -2884,7 +2884,7 @@
           <p:cNvPr id="8" name="">
             <a:extLst xmlns:a="http://schemas.openxmlformats.org/drawingml/2006/main">
               <a:ext uri="{FF2B5EF4-FFF2-40B4-BE49-F238E27FC236}">
-                <a16:creationId xmlns:a16="http://schemas.microsoft.com/office/drawing/2014/main" id="{731457B2-1DC3-4836-8A1D-979681C611D8}"/>
+                <a16:creationId xmlns:a16="http://schemas.microsoft.com/office/drawing/2014/main" id="{250D3E40-378F-462E-9240-F66765D7A212}"/>
               </a:ext>
             </a:extLst>
           </p:cNvPr>
@@ -2945,7 +2945,7 @@
           <p:cNvPr id="2" name="">
             <a:extLst xmlns:a="http://schemas.openxmlformats.org/drawingml/2006/main">
               <a:ext uri="{FF2B5EF4-FFF2-40B4-BE49-F238E27FC236}">
-                <a16:creationId xmlns:a16="http://schemas.microsoft.com/office/drawing/2014/main" id="{15B3A513-AD3D-40E4-B2F8-5E794AB80444}"/>
+                <a16:creationId xmlns:a16="http://schemas.microsoft.com/office/drawing/2014/main" id="{EFFCB0A7-3EEB-4094-942A-8430D52D66EA}"/>
               </a:ext>
             </a:extLst>
           </p:cNvPr>
@@ -3006,7 +3006,7 @@
           <p:cNvPr id="3" name="">
             <a:extLst xmlns:a="http://schemas.openxmlformats.org/drawingml/2006/main">
               <a:ext uri="{FF2B5EF4-FFF2-40B4-BE49-F238E27FC236}">
-                <a16:creationId xmlns:a16="http://schemas.microsoft.com/office/drawing/2014/main" id="{17631251-6971-49BF-B434-68942F09FEA4}"/>
+                <a16:creationId xmlns:a16="http://schemas.microsoft.com/office/drawing/2014/main" id="{61461F05-BF42-45AA-84E0-E7C7ECFECB23}"/>
               </a:ext>
             </a:extLst>
           </p:cNvPr>
@@ -3067,7 +3067,7 @@
           <p:cNvPr id="4" name="">
             <a:extLst xmlns:a="http://schemas.openxmlformats.org/drawingml/2006/main">
               <a:ext uri="{FF2B5EF4-FFF2-40B4-BE49-F238E27FC236}">
-                <a16:creationId xmlns:a16="http://schemas.microsoft.com/office/drawing/2014/main" id="{8B64E3F7-68A9-4125-9C2F-6F574AB785CA}"/>
+                <a16:creationId xmlns:a16="http://schemas.microsoft.com/office/drawing/2014/main" id="{91613478-B6CD-4FFE-81F8-60D3800D4576}"/>
               </a:ext>
             </a:extLst>
           </p:cNvPr>
@@ -3128,7 +3128,7 @@
           <p:cNvPr id="5" name="">
             <a:extLst xmlns:a="http://schemas.openxmlformats.org/drawingml/2006/main">
               <a:ext uri="{FF2B5EF4-FFF2-40B4-BE49-F238E27FC236}">
-                <a16:creationId xmlns:a16="http://schemas.microsoft.com/office/drawing/2014/main" id="{082FB663-A12C-46E6-B7C5-336951FB6991}"/>
+                <a16:creationId xmlns:a16="http://schemas.microsoft.com/office/drawing/2014/main" id="{D027A557-9B74-4B3B-AA68-A32CAC0EF0F1}"/>
               </a:ext>
             </a:extLst>
           </p:cNvPr>
@@ -3189,7 +3189,7 @@
           <p:cNvPr id="6" name="">
             <a:extLst xmlns:a="http://schemas.openxmlformats.org/drawingml/2006/main">
               <a:ext uri="{FF2B5EF4-FFF2-40B4-BE49-F238E27FC236}">
-                <a16:creationId xmlns:a16="http://schemas.microsoft.com/office/drawing/2014/main" id="{D0CDAC81-40C3-4C33-8737-281E3A7248AE}"/>
+                <a16:creationId xmlns:a16="http://schemas.microsoft.com/office/drawing/2014/main" id="{A1053E4A-9321-44E1-8369-34CAEA3FCDFB}"/>
               </a:ext>
             </a:extLst>
           </p:cNvPr>
@@ -3250,7 +3250,7 @@
           <p:cNvPr id="7" name="">
             <a:extLst xmlns:a="http://schemas.openxmlformats.org/drawingml/2006/main">
               <a:ext uri="{FF2B5EF4-FFF2-40B4-BE49-F238E27FC236}">
-                <a16:creationId xmlns:a16="http://schemas.microsoft.com/office/drawing/2014/main" id="{D28E698F-3BB4-4A02-B51B-1BF48CCE2CA3}"/>
+                <a16:creationId xmlns:a16="http://schemas.microsoft.com/office/drawing/2014/main" id="{B23F4C1F-E839-46EF-89FC-0D1DA796C18E}"/>
               </a:ext>
             </a:extLst>
           </p:cNvPr>
@@ -3309,7 +3309,7 @@
     </p:spTree>
     <p:extLst>
       <p:ext uri="{BB962C8B-B14F-4D97-AF65-F5344CB8AC3E}">
-        <p14:creationId xmlns:p14="http://schemas.microsoft.com/office/powerpoint/2010/main" val="727731073"/>
+        <p14:creationId xmlns:p14="http://schemas.microsoft.com/office/powerpoint/2010/main" val="296433561"/>
       </p:ext>
     </p:extLst>
   </p:cSld>
@@ -3340,7 +3340,7 @@
           <p:cNvPr id="8" name="">
             <a:extLst xmlns:a="http://schemas.openxmlformats.org/drawingml/2006/main">
               <a:ext uri="{FF2B5EF4-FFF2-40B4-BE49-F238E27FC236}">
-                <a16:creationId xmlns:a16="http://schemas.microsoft.com/office/drawing/2014/main" id="{A0A62E7C-731B-4431-A937-EA8D87FE8199}"/>
+                <a16:creationId xmlns:a16="http://schemas.microsoft.com/office/drawing/2014/main" id="{3B5261AB-A3DE-481B-88E4-4B41EBB9DCF4}"/>
               </a:ext>
             </a:extLst>
           </p:cNvPr>
@@ -3405,7 +3405,7 @@
           <p:nvPr/>
         </p:nvPicPr>
         <p:blipFill>
-          <a:blip xmlns:r="http://schemas.openxmlformats.org/officeDocument/2006/relationships" xmlns:a="http://schemas.openxmlformats.org/drawingml/2006/main" r:embed="Rbeac64cf91f04a6b"/>
+          <a:blip xmlns:r="http://schemas.openxmlformats.org/officeDocument/2006/relationships" xmlns:a="http://schemas.openxmlformats.org/drawingml/2006/main" r:embed="R9cdfd9572eba406b"/>
           <a:stretch xmlns:a="http://schemas.openxmlformats.org/drawingml/2006/main"/>
         </p:blipFill>
         <p:spPr>
@@ -3423,7 +3423,7 @@
           <p:cNvPr id="3" name="">
             <a:extLst xmlns:a="http://schemas.openxmlformats.org/drawingml/2006/main">
               <a:ext uri="{FF2B5EF4-FFF2-40B4-BE49-F238E27FC236}">
-                <a16:creationId xmlns:a16="http://schemas.microsoft.com/office/drawing/2014/main" id="{00B0CF48-A0F2-4292-9DD5-2F562C57270F}"/>
+                <a16:creationId xmlns:a16="http://schemas.microsoft.com/office/drawing/2014/main" id="{D69655C1-3CDB-488C-AAC4-BBCE5E70BF86}"/>
               </a:ext>
             </a:extLst>
           </p:cNvPr>
@@ -3474,7 +3474,7 @@
                 <a:ea typeface="Liberation Sans"/>
                 <a:cs typeface="Liberation Sans"/>
               </a:rPr>
-              <a:t>Will a buyer pay repeatedly?</a:t>
+              <a:t>Next: one recurring paid check</a:t>
             </a:r>
           </a:p>
         </p:txBody>
@@ -3484,7 +3484,7 @@
           <p:cNvPr id="4" name="">
             <a:extLst xmlns:a="http://schemas.openxmlformats.org/drawingml/2006/main">
               <a:ext uri="{FF2B5EF4-FFF2-40B4-BE49-F238E27FC236}">
-                <a16:creationId xmlns:a16="http://schemas.microsoft.com/office/drawing/2014/main" id="{2507821C-7DFB-42E6-9668-7EBEE2FDB4CC}"/>
+                <a16:creationId xmlns:a16="http://schemas.microsoft.com/office/drawing/2014/main" id="{F1A3AC5D-BF08-4DFE-B709-02D5C6D68102}"/>
               </a:ext>
             </a:extLst>
           </p:cNvPr>
@@ -3535,7 +3535,7 @@
                 <a:ea typeface="Liberation Sans"/>
                 <a:cs typeface="Liberation Sans"/>
               </a:rPr>
-              <a:t>Buyer hypothesis: software teams that already pay for remote checks.</a:t>
+              <a:t>First buyers to recruit: software teams that pay for remote checks.</a:t>
             </a:r>
           </a:p>
         </p:txBody>
@@ -3545,7 +3545,7 @@
           <p:cNvPr id="5" name="">
             <a:extLst xmlns:a="http://schemas.openxmlformats.org/drawingml/2006/main">
               <a:ext uri="{FF2B5EF4-FFF2-40B4-BE49-F238E27FC236}">
-                <a16:creationId xmlns:a16="http://schemas.microsoft.com/office/drawing/2014/main" id="{DDA3EAA3-70C0-4ED5-8C65-4A8263B5FE4B}"/>
+                <a16:creationId xmlns:a16="http://schemas.microsoft.com/office/drawing/2014/main" id="{D4610F9B-1EF7-4B64-A2C7-A9E5D75D6EB3}"/>
               </a:ext>
             </a:extLst>
           </p:cNvPr>
@@ -3596,7 +3596,7 @@
                 <a:ea typeface="Liberation Sans"/>
                 <a:cs typeface="Liberation Sans"/>
               </a:rPr>
-              <a:t>Next test: one operator and one recurring question.</a:t>
+              <a:t>Pilot plan: one operator, one buyer, measured cost and reliability.</a:t>
             </a:r>
           </a:p>
         </p:txBody>
@@ -3606,7 +3606,7 @@
           <p:cNvPr id="6" name="">
             <a:extLst xmlns:a="http://schemas.openxmlformats.org/drawingml/2006/main">
               <a:ext uri="{FF2B5EF4-FFF2-40B4-BE49-F238E27FC236}">
-                <a16:creationId xmlns:a16="http://schemas.microsoft.com/office/drawing/2014/main" id="{DFE4E6FE-BE33-4BF3-9D70-DF62CD7C65B1}"/>
+                <a16:creationId xmlns:a16="http://schemas.microsoft.com/office/drawing/2014/main" id="{73169C9F-CC3B-4860-8E11-2EC926BA9B96}"/>
               </a:ext>
             </a:extLst>
           </p:cNvPr>
@@ -3657,7 +3657,7 @@
                 <a:ea typeface="Liberation Sans"/>
                 <a:cs typeface="Liberation Sans"/>
               </a:rPr>
-              <a:t>Revenue hypothesis: integration and per-check fees.</a:t>
+              <a:t>Revenue plan: integration and service fees.</a:t>
             </a:r>
           </a:p>
         </p:txBody>
@@ -3667,7 +3667,7 @@
           <p:cNvPr id="7" name="">
             <a:extLst xmlns:a="http://schemas.openxmlformats.org/drawingml/2006/main">
               <a:ext uri="{FF2B5EF4-FFF2-40B4-BE49-F238E27FC236}">
-                <a16:creationId xmlns:a16="http://schemas.microsoft.com/office/drawing/2014/main" id="{85AA6EB4-76EF-43A6-AD4F-62663A18A756}"/>
+                <a16:creationId xmlns:a16="http://schemas.microsoft.com/office/drawing/2014/main" id="{C7D237B1-AF16-4260-AAEE-C38318A33996}"/>
               </a:ext>
             </a:extLst>
           </p:cNvPr>
@@ -3718,7 +3718,7 @@
                 <a:ea typeface="Liberation Sans"/>
                 <a:cs typeface="Liberation Sans"/>
               </a:rPr>
-              <a:t>The network, customer demand, and reputation remain unvalidated.</a:t>
+              <a:t>Today: one provider. The paid pilot will test demand and pricing.</a:t>
             </a:r>
           </a:p>
         </p:txBody>
@@ -3726,7 +3726,7 @@
     </p:spTree>
     <p:extLst>
       <p:ext uri="{BB962C8B-B14F-4D97-AF65-F5344CB8AC3E}">
-        <p14:creationId xmlns:p14="http://schemas.microsoft.com/office/powerpoint/2010/main" val="139742060"/>
+        <p14:creationId xmlns:p14="http://schemas.microsoft.com/office/powerpoint/2010/main" val="1332558348"/>
       </p:ext>
     </p:extLst>
   </p:cSld>

</xml_diff>